<commit_message>
Set top15 primary report and full-KEGG FDR005 overlap
</commit_message>
<xml_diff>
--- a/projects/GSE262271_TALL_relapse_scRNAseq/07_Student_Handoff/01_Summary/Leukemia_scRNAseq_STAT5B_reviewed.pptx
+++ b/projects/GSE262271_TALL_relapse_scRNAseq/07_Student_Handoff/01_Summary/Leukemia_scRNAseq_STAT5B_reviewed.pptx
@@ -2,26 +2,26 @@
 <file path=ppt/presentation.xml><?xml version="1.0" encoding="utf-8"?>
 <p:presentation xmlns:p="http://schemas.openxmlformats.org/presentationml/2006/main">
   <p:sldMasterIdLst>
-    <p:sldMasterId xmlns:r="http://schemas.openxmlformats.org/officeDocument/2006/relationships" id="2147483648" r:id="R862b9637226448d7"/>
+    <p:sldMasterId xmlns:r="http://schemas.openxmlformats.org/officeDocument/2006/relationships" id="2147483648" r:id="R17a29904a7e34fe2"/>
   </p:sldMasterIdLst>
   <p:notesMasterIdLst>
-    <p:notesMasterId xmlns:r="http://schemas.openxmlformats.org/officeDocument/2006/relationships" r:id="Rfcc81316096747b3"/>
+    <p:notesMasterId xmlns:r="http://schemas.openxmlformats.org/officeDocument/2006/relationships" r:id="Rc89f8f8522f54fba"/>
   </p:notesMasterIdLst>
   <p:sldIdLst>
-    <p:sldId xmlns:r="http://schemas.openxmlformats.org/officeDocument/2006/relationships" id="256" r:id="R27644708646d48dd"/>
-    <p:sldId xmlns:r="http://schemas.openxmlformats.org/officeDocument/2006/relationships" id="257" r:id="R05a3aa08f6cf42d3"/>
-    <p:sldId xmlns:r="http://schemas.openxmlformats.org/officeDocument/2006/relationships" id="258" r:id="R0cf7bfbe439043ca"/>
-    <p:sldId xmlns:r="http://schemas.openxmlformats.org/officeDocument/2006/relationships" id="259" r:id="Raf25a8bfaaa34210"/>
-    <p:sldId xmlns:r="http://schemas.openxmlformats.org/officeDocument/2006/relationships" id="260" r:id="Re99f3f73e59a4ea7"/>
-    <p:sldId xmlns:r="http://schemas.openxmlformats.org/officeDocument/2006/relationships" id="261" r:id="R8e04d5bc91a844b1"/>
-    <p:sldId xmlns:r="http://schemas.openxmlformats.org/officeDocument/2006/relationships" id="262" r:id="Rf7a00533549d4f3e"/>
-    <p:sldId xmlns:r="http://schemas.openxmlformats.org/officeDocument/2006/relationships" id="263" r:id="R2f4518e083334ba8"/>
-    <p:sldId xmlns:r="http://schemas.openxmlformats.org/officeDocument/2006/relationships" id="264" r:id="R4f610c0a8fb449bf"/>
-    <p:sldId xmlns:r="http://schemas.openxmlformats.org/officeDocument/2006/relationships" id="265" r:id="R2749d3d868554636"/>
-    <p:sldId xmlns:r="http://schemas.openxmlformats.org/officeDocument/2006/relationships" id="266" r:id="Ra7e8a73963734bbb"/>
-    <p:sldId xmlns:r="http://schemas.openxmlformats.org/officeDocument/2006/relationships" id="267" r:id="R2e8a7d9547c149e0"/>
-    <p:sldId xmlns:r="http://schemas.openxmlformats.org/officeDocument/2006/relationships" id="268" r:id="R7f3459db959f42fa"/>
-    <p:sldId xmlns:r="http://schemas.openxmlformats.org/officeDocument/2006/relationships" id="269" r:id="R52defa739df044b4"/>
+    <p:sldId xmlns:r="http://schemas.openxmlformats.org/officeDocument/2006/relationships" id="256" r:id="R5f60c4c641da4cd4"/>
+    <p:sldId xmlns:r="http://schemas.openxmlformats.org/officeDocument/2006/relationships" id="257" r:id="Rb9f0b3cf3e2948d9"/>
+    <p:sldId xmlns:r="http://schemas.openxmlformats.org/officeDocument/2006/relationships" id="258" r:id="Re2de27cb1ef2427c"/>
+    <p:sldId xmlns:r="http://schemas.openxmlformats.org/officeDocument/2006/relationships" id="259" r:id="R7317dfb164c948e2"/>
+    <p:sldId xmlns:r="http://schemas.openxmlformats.org/officeDocument/2006/relationships" id="260" r:id="R47d507ef7ccf4b49"/>
+    <p:sldId xmlns:r="http://schemas.openxmlformats.org/officeDocument/2006/relationships" id="261" r:id="R005ab2211d4b404c"/>
+    <p:sldId xmlns:r="http://schemas.openxmlformats.org/officeDocument/2006/relationships" id="262" r:id="Ra415a6cf4b6c4d4d"/>
+    <p:sldId xmlns:r="http://schemas.openxmlformats.org/officeDocument/2006/relationships" id="263" r:id="Rb424d6403ddd4ace"/>
+    <p:sldId xmlns:r="http://schemas.openxmlformats.org/officeDocument/2006/relationships" id="264" r:id="R08eaef45b97842b9"/>
+    <p:sldId xmlns:r="http://schemas.openxmlformats.org/officeDocument/2006/relationships" id="265" r:id="Rdbb11098723946d1"/>
+    <p:sldId xmlns:r="http://schemas.openxmlformats.org/officeDocument/2006/relationships" id="266" r:id="Rb7a87ab838614feb"/>
+    <p:sldId xmlns:r="http://schemas.openxmlformats.org/officeDocument/2006/relationships" id="267" r:id="Re9f330a615234426"/>
+    <p:sldId xmlns:r="http://schemas.openxmlformats.org/officeDocument/2006/relationships" id="268" r:id="R4b6d1588762b407f"/>
+    <p:sldId xmlns:r="http://schemas.openxmlformats.org/officeDocument/2006/relationships" id="269" r:id="Rcd730057a98f43b3"/>
   </p:sldIdLst>
   <p:sldSz cx="12192000" cy="6858000"/>
   <p:notesSz cx="6858000" cy="9144000"/>
@@ -1295,7 +1295,7 @@
           <a:lstStyle xmlns:a="http://schemas.openxmlformats.org/drawingml/2006/main"/>
           <a:p xmlns:a="http://schemas.openxmlformats.org/drawingml/2006/main">
             <a:r>
-              <a:t>Figure05 restricts the universe to common tested canonical pathway names. It does not silently call pathways missing from one catalog non-significant. Circle area is schematic. Table06 has all membership; Table07 lists every shared pathway.</a:t>
+              <a:t>Figure05 restricts the universe to common tested canonical pathway names. It does not call pathways missing from one catalog non-significant. Circle area is schematic. Table06 has all membership; Table07 lists all40 primary shared pathways. TableS05 retains global25 sensitivity. Primary display uses within15 as requested, while cutoff selection remains exploratory.</a:t>
             </a:r>
           </a:p>
         </p:txBody>
@@ -1433,7 +1433,7 @@
   </p:cSld>
   <p:clrMap bg1="lt1" tx1="dk1" bg2="lt2" tx2="dk2" accent1="accent1" accent2="accent2" accent3="accent3" accent4="accent4" accent5="accent5" accent6="accent6" hlink="hlink" folHlink="folHlink"/>
   <p:sldLayoutIdLst>
-    <p:sldLayoutId xmlns:r="http://schemas.openxmlformats.org/officeDocument/2006/relationships" id="2147483649" r:id="Rcaa202b71504494e"/>
+    <p:sldLayoutId xmlns:r="http://schemas.openxmlformats.org/officeDocument/2006/relationships" id="2147483649" r:id="R484a6def0a1f47ac"/>
   </p:sldLayoutIdLst>
   <p:txStyles>
     <p:titleStyle>
@@ -1984,7 +1984,7 @@
           <p:cNvPr id="9" name="">
             <a:extLst xmlns:a="http://schemas.openxmlformats.org/drawingml/2006/main">
               <a:ext uri="{FF2B5EF4-FFF2-40B4-BE49-F238E27FC236}">
-                <a16:creationId xmlns:a16="http://schemas.microsoft.com/office/drawing/2014/main" id="{534470FE-957C-4270-B9F1-1A0E2C18C814}"/>
+                <a16:creationId xmlns:a16="http://schemas.microsoft.com/office/drawing/2014/main" id="{91E6CCD2-64CB-4CF5-8FFF-3B6F4AE356E8}"/>
               </a:ext>
             </a:extLst>
           </p:cNvPr>
@@ -2041,7 +2041,7 @@
           <p:cNvPr id="2" name="">
             <a:extLst xmlns:a="http://schemas.openxmlformats.org/drawingml/2006/main">
               <a:ext uri="{FF2B5EF4-FFF2-40B4-BE49-F238E27FC236}">
-                <a16:creationId xmlns:a16="http://schemas.microsoft.com/office/drawing/2014/main" id="{A3CE88A7-A640-4747-8EEB-0CF188730E1D}"/>
+                <a16:creationId xmlns:a16="http://schemas.microsoft.com/office/drawing/2014/main" id="{7C4495CA-8855-41A1-883D-F5C67CAC1CB9}"/>
               </a:ext>
             </a:extLst>
           </p:cNvPr>
@@ -2098,7 +2098,7 @@
           <p:cNvPr id="3" name="">
             <a:extLst xmlns:a="http://schemas.openxmlformats.org/drawingml/2006/main">
               <a:ext uri="{FF2B5EF4-FFF2-40B4-BE49-F238E27FC236}">
-                <a16:creationId xmlns:a16="http://schemas.microsoft.com/office/drawing/2014/main" id="{CFABA575-067B-4DA4-8C03-0550626C2236}"/>
+                <a16:creationId xmlns:a16="http://schemas.microsoft.com/office/drawing/2014/main" id="{E23FD51F-4C69-4A5E-91DD-2AD394910338}"/>
               </a:ext>
             </a:extLst>
           </p:cNvPr>
@@ -2155,7 +2155,7 @@
           <p:cNvPr id="4" name="">
             <a:extLst xmlns:a="http://schemas.openxmlformats.org/drawingml/2006/main">
               <a:ext uri="{FF2B5EF4-FFF2-40B4-BE49-F238E27FC236}">
-                <a16:creationId xmlns:a16="http://schemas.microsoft.com/office/drawing/2014/main" id="{5FCE1A43-DF86-42DB-8336-0633A4E45D66}"/>
+                <a16:creationId xmlns:a16="http://schemas.microsoft.com/office/drawing/2014/main" id="{5171ECF3-CA9D-4DF3-9A0B-C8FF76109732}"/>
               </a:ext>
             </a:extLst>
           </p:cNvPr>
@@ -2212,7 +2212,7 @@
           <p:cNvPr id="5" name="">
             <a:extLst xmlns:a="http://schemas.openxmlformats.org/drawingml/2006/main">
               <a:ext uri="{FF2B5EF4-FFF2-40B4-BE49-F238E27FC236}">
-                <a16:creationId xmlns:a16="http://schemas.microsoft.com/office/drawing/2014/main" id="{78A6A0B8-F957-436A-AE3D-C2C198940922}"/>
+                <a16:creationId xmlns:a16="http://schemas.microsoft.com/office/drawing/2014/main" id="{80B564FF-33D8-48D4-9435-B6A225DA249F}"/>
               </a:ext>
             </a:extLst>
           </p:cNvPr>
@@ -2269,7 +2269,7 @@
           <p:cNvPr id="6" name="">
             <a:extLst xmlns:a="http://schemas.openxmlformats.org/drawingml/2006/main">
               <a:ext uri="{FF2B5EF4-FFF2-40B4-BE49-F238E27FC236}">
-                <a16:creationId xmlns:a16="http://schemas.microsoft.com/office/drawing/2014/main" id="{E30BD7D0-8541-4B65-AAB2-DBEEA8E05E1D}"/>
+                <a16:creationId xmlns:a16="http://schemas.microsoft.com/office/drawing/2014/main" id="{D5C9457E-489D-4013-810B-050DD8BCE50E}"/>
               </a:ext>
             </a:extLst>
           </p:cNvPr>
@@ -2326,7 +2326,7 @@
           <p:cNvPr id="7" name="">
             <a:extLst xmlns:a="http://schemas.openxmlformats.org/drawingml/2006/main">
               <a:ext uri="{FF2B5EF4-FFF2-40B4-BE49-F238E27FC236}">
-                <a16:creationId xmlns:a16="http://schemas.microsoft.com/office/drawing/2014/main" id="{DB50B662-FF67-426D-AF3B-CADA352ADF49}"/>
+                <a16:creationId xmlns:a16="http://schemas.microsoft.com/office/drawing/2014/main" id="{13FFD5BF-1F61-4284-B90C-F642024AC01E}"/>
               </a:ext>
             </a:extLst>
           </p:cNvPr>
@@ -2406,7 +2406,7 @@
           <p:cNvPr id="8" name="">
             <a:extLst xmlns:a="http://schemas.openxmlformats.org/drawingml/2006/main">
               <a:ext uri="{FF2B5EF4-FFF2-40B4-BE49-F238E27FC236}">
-                <a16:creationId xmlns:a16="http://schemas.microsoft.com/office/drawing/2014/main" id="{83411D25-E94C-463B-AF04-DBF5417E5172}"/>
+                <a16:creationId xmlns:a16="http://schemas.microsoft.com/office/drawing/2014/main" id="{88D95EB9-C8F0-4256-BB11-BA59D12168D5}"/>
               </a:ext>
             </a:extLst>
           </p:cNvPr>
@@ -2453,7 +2453,7 @@
                 <a:ea typeface="Microsoft JhengHei"/>
                 <a:cs typeface="Microsoft JhengHei"/>
               </a:rPr>
-              <a:t>本報告保留原始 top 25% 結果，另列 exploratory within-sample top 15%。</a:t>
+              <a:t>主分析固定 within-sample CNV top 15%，pathway 與交集皆採完整 KEGG FDR &lt; 0.05。</a:t>
             </a:r>
           </a:p>
         </p:txBody>
@@ -2461,7 +2461,7 @@
     </p:spTree>
     <p:extLst>
       <p:ext uri="{BB962C8B-B14F-4D97-AF65-F5344CB8AC3E}">
-        <p14:creationId xmlns:p14="http://schemas.microsoft.com/office/powerpoint/2010/main" val="116414465"/>
+        <p14:creationId xmlns:p14="http://schemas.microsoft.com/office/powerpoint/2010/main" val="1423246754"/>
       </p:ext>
     </p:extLst>
   </p:cSld>
@@ -2492,7 +2492,7 @@
           <p:cNvPr id="7" name="">
             <a:extLst xmlns:a="http://schemas.openxmlformats.org/drawingml/2006/main">
               <a:ext uri="{FF2B5EF4-FFF2-40B4-BE49-F238E27FC236}">
-                <a16:creationId xmlns:a16="http://schemas.microsoft.com/office/drawing/2014/main" id="{902F3ADE-6AF7-4F46-861D-1AA3CB653C8E}"/>
+                <a16:creationId xmlns:a16="http://schemas.microsoft.com/office/drawing/2014/main" id="{1506798B-E2B7-4D0A-B89A-B8DB57C3AFB3}"/>
               </a:ext>
             </a:extLst>
           </p:cNvPr>
@@ -2549,7 +2549,7 @@
           <p:cNvPr id="2" name="">
             <a:extLst xmlns:a="http://schemas.openxmlformats.org/drawingml/2006/main">
               <a:ext uri="{FF2B5EF4-FFF2-40B4-BE49-F238E27FC236}">
-                <a16:creationId xmlns:a16="http://schemas.microsoft.com/office/drawing/2014/main" id="{C93CA159-CC1B-498A-A245-2BA0938F1732}"/>
+                <a16:creationId xmlns:a16="http://schemas.microsoft.com/office/drawing/2014/main" id="{322AD55F-4621-40A3-94F4-A56C980EF2D3}"/>
               </a:ext>
             </a:extLst>
           </p:cNvPr>
@@ -2606,7 +2606,7 @@
           <p:cNvPr id="3" name="">
             <a:extLst xmlns:a="http://schemas.openxmlformats.org/drawingml/2006/main">
               <a:ext uri="{FF2B5EF4-FFF2-40B4-BE49-F238E27FC236}">
-                <a16:creationId xmlns:a16="http://schemas.microsoft.com/office/drawing/2014/main" id="{8423E76E-C803-4CDC-9ACA-76C85A020216}"/>
+                <a16:creationId xmlns:a16="http://schemas.microsoft.com/office/drawing/2014/main" id="{95820BA2-F3C6-4C8A-AABB-F0D889B99201}"/>
               </a:ext>
             </a:extLst>
           </p:cNvPr>
@@ -2663,7 +2663,7 @@
           <p:cNvPr id="4" name="">
             <a:extLst xmlns:a="http://schemas.openxmlformats.org/drawingml/2006/main">
               <a:ext uri="{FF2B5EF4-FFF2-40B4-BE49-F238E27FC236}">
-                <a16:creationId xmlns:a16="http://schemas.microsoft.com/office/drawing/2014/main" id="{29F93DF2-C0BB-402B-A446-360BC4116B61}"/>
+                <a16:creationId xmlns:a16="http://schemas.microsoft.com/office/drawing/2014/main" id="{28C3B606-FF48-4635-8410-518A9A3BF68E}"/>
               </a:ext>
             </a:extLst>
           </p:cNvPr>
@@ -2724,13 +2724,13 @@
           <p:nvPr/>
         </p:nvPicPr>
         <p:blipFill>
-          <a:blip xmlns:r="http://schemas.openxmlformats.org/officeDocument/2006/relationships" xmlns:a="http://schemas.openxmlformats.org/drawingml/2006/main" r:embed="Reb3db202c20d4eb6"/>
+          <a:blip xmlns:r="http://schemas.openxmlformats.org/officeDocument/2006/relationships" xmlns:a="http://schemas.openxmlformats.org/drawingml/2006/main" r:embed="R2ebcdfadf305483f"/>
           <a:stretch xmlns:a="http://schemas.openxmlformats.org/drawingml/2006/main"/>
         </p:blipFill>
         <p:spPr>
           <a:xfrm xmlns:a="http://schemas.openxmlformats.org/drawingml/2006/main">
-            <a:off x="1239242" y="1362075"/>
-            <a:ext cx="9713516" cy="4238625"/>
+            <a:off x="2122289" y="1362075"/>
+            <a:ext cx="7947422" cy="4238625"/>
           </a:xfrm>
           <a:prstGeom xmlns:a="http://schemas.openxmlformats.org/drawingml/2006/main" prst="rect">
             <a:avLst/>
@@ -2742,7 +2742,7 @@
           <p:cNvPr id="6" name="">
             <a:extLst xmlns:a="http://schemas.openxmlformats.org/drawingml/2006/main">
               <a:ext uri="{FF2B5EF4-FFF2-40B4-BE49-F238E27FC236}">
-                <a16:creationId xmlns:a16="http://schemas.microsoft.com/office/drawing/2014/main" id="{6A72D360-64AD-40C7-901C-5AF3B72457C4}"/>
+                <a16:creationId xmlns:a16="http://schemas.microsoft.com/office/drawing/2014/main" id="{8E33C5E0-D39D-4A3D-9D9F-A366AEE9BDC3}"/>
               </a:ext>
             </a:extLst>
           </p:cNvPr>
@@ -2789,7 +2789,7 @@
                 <a:ea typeface="Microsoft JhengHei"/>
                 <a:cs typeface="Microsoft JhengHei"/>
               </a:rPr>
-              <a:t>這兩條的 NES 是正值：relapse 與 N642H 都較高。Top 15% 的顯著性不能套用到原始 top 25%。</a:t>
+              <a:t>Proteasome、mitophagy 均上調，兩組資料的完整 KEGG FDR 都小於 0.05。</a:t>
             </a:r>
           </a:p>
         </p:txBody>
@@ -2797,7 +2797,7 @@
     </p:spTree>
     <p:extLst>
       <p:ext uri="{BB962C8B-B14F-4D97-AF65-F5344CB8AC3E}">
-        <p14:creationId xmlns:p14="http://schemas.microsoft.com/office/powerpoint/2010/main" val="71367776"/>
+        <p14:creationId xmlns:p14="http://schemas.microsoft.com/office/powerpoint/2010/main" val="1479276253"/>
       </p:ext>
     </p:extLst>
   </p:cSld>
@@ -2828,7 +2828,7 @@
           <p:cNvPr id="8" name="">
             <a:extLst xmlns:a="http://schemas.openxmlformats.org/drawingml/2006/main">
               <a:ext uri="{FF2B5EF4-FFF2-40B4-BE49-F238E27FC236}">
-                <a16:creationId xmlns:a16="http://schemas.microsoft.com/office/drawing/2014/main" id="{CF75FB2D-A5C8-421C-9932-BBD72553F593}"/>
+                <a16:creationId xmlns:a16="http://schemas.microsoft.com/office/drawing/2014/main" id="{12B8CB02-5257-434D-909A-2D70F1C5FD71}"/>
               </a:ext>
             </a:extLst>
           </p:cNvPr>
@@ -2885,7 +2885,7 @@
           <p:cNvPr id="2" name="">
             <a:extLst xmlns:a="http://schemas.openxmlformats.org/drawingml/2006/main">
               <a:ext uri="{FF2B5EF4-FFF2-40B4-BE49-F238E27FC236}">
-                <a16:creationId xmlns:a16="http://schemas.microsoft.com/office/drawing/2014/main" id="{8CD33002-7136-4C7A-B7A0-09084D0D8370}"/>
+                <a16:creationId xmlns:a16="http://schemas.microsoft.com/office/drawing/2014/main" id="{DA9F256B-A29C-4BB5-A07F-D03909475925}"/>
               </a:ext>
             </a:extLst>
           </p:cNvPr>
@@ -2942,7 +2942,7 @@
           <p:cNvPr id="3" name="">
             <a:extLst xmlns:a="http://schemas.openxmlformats.org/drawingml/2006/main">
               <a:ext uri="{FF2B5EF4-FFF2-40B4-BE49-F238E27FC236}">
-                <a16:creationId xmlns:a16="http://schemas.microsoft.com/office/drawing/2014/main" id="{3C06545B-E70F-42C3-82B9-C363548C294F}"/>
+                <a16:creationId xmlns:a16="http://schemas.microsoft.com/office/drawing/2014/main" id="{A5E5A68D-BBEE-4D32-B7AD-AAFDD731B600}"/>
               </a:ext>
             </a:extLst>
           </p:cNvPr>
@@ -2999,7 +2999,7 @@
           <p:cNvPr id="4" name="">
             <a:extLst xmlns:a="http://schemas.openxmlformats.org/drawingml/2006/main">
               <a:ext uri="{FF2B5EF4-FFF2-40B4-BE49-F238E27FC236}">
-                <a16:creationId xmlns:a16="http://schemas.microsoft.com/office/drawing/2014/main" id="{F86FB53C-7803-4ABE-B6BF-6F4DAFC23FD6}"/>
+                <a16:creationId xmlns:a16="http://schemas.microsoft.com/office/drawing/2014/main" id="{4BBDAC00-A282-48CD-AADC-89B5CCA0B19A}"/>
               </a:ext>
             </a:extLst>
           </p:cNvPr>
@@ -3060,7 +3060,7 @@
           <p:nvPr/>
         </p:nvPicPr>
         <p:blipFill>
-          <a:blip xmlns:r="http://schemas.openxmlformats.org/officeDocument/2006/relationships" xmlns:a="http://schemas.openxmlformats.org/drawingml/2006/main" r:embed="Rf21f4457506f4d4d"/>
+          <a:blip xmlns:r="http://schemas.openxmlformats.org/officeDocument/2006/relationships" xmlns:a="http://schemas.openxmlformats.org/drawingml/2006/main" r:embed="R25388103743748b3"/>
           <a:stretch xmlns:a="http://schemas.openxmlformats.org/drawingml/2006/main"/>
         </p:blipFill>
         <p:spPr>
@@ -3078,7 +3078,7 @@
           <p:cNvPr id="6" name="">
             <a:extLst xmlns:a="http://schemas.openxmlformats.org/drawingml/2006/main">
               <a:ext uri="{FF2B5EF4-FFF2-40B4-BE49-F238E27FC236}">
-                <a16:creationId xmlns:a16="http://schemas.microsoft.com/office/drawing/2014/main" id="{19EBCE93-7A9C-4F47-9738-96DCD44F8388}"/>
+                <a16:creationId xmlns:a16="http://schemas.microsoft.com/office/drawing/2014/main" id="{33D19D66-5BD8-4E65-AAFC-A2349521F3DE}"/>
               </a:ext>
             </a:extLst>
           </p:cNvPr>
@@ -3135,7 +3135,7 @@
           <p:cNvPr id="7" name="">
             <a:extLst xmlns:a="http://schemas.openxmlformats.org/drawingml/2006/main">
               <a:ext uri="{FF2B5EF4-FFF2-40B4-BE49-F238E27FC236}">
-                <a16:creationId xmlns:a16="http://schemas.microsoft.com/office/drawing/2014/main" id="{E9381DF5-A212-4436-99C1-D8041F8B19A0}"/>
+                <a16:creationId xmlns:a16="http://schemas.microsoft.com/office/drawing/2014/main" id="{88378425-E98D-456B-B9C4-4A99F125D1F1}"/>
               </a:ext>
             </a:extLst>
           </p:cNvPr>
@@ -3210,7 +3210,7 @@
                 <a:ea typeface="Microsoft JhengHei"/>
                 <a:cs typeface="Microsoft JhengHei"/>
               </a:rPr>
-              <a:t>方向檢查是描述性證據，不能再當成獨立驗證。</a:t>
+              <a:t>這裡只描述三位病人的方向，不作額外的獨立驗證。</a:t>
             </a:r>
           </a:p>
         </p:txBody>
@@ -3218,7 +3218,7 @@
     </p:spTree>
     <p:extLst>
       <p:ext uri="{BB962C8B-B14F-4D97-AF65-F5344CB8AC3E}">
-        <p14:creationId xmlns:p14="http://schemas.microsoft.com/office/powerpoint/2010/main" val="1483495777"/>
+        <p14:creationId xmlns:p14="http://schemas.microsoft.com/office/powerpoint/2010/main" val="1241329555"/>
       </p:ext>
     </p:extLst>
   </p:cSld>
@@ -3249,7 +3249,7 @@
           <p:cNvPr id="9" name="">
             <a:extLst xmlns:a="http://schemas.openxmlformats.org/drawingml/2006/main">
               <a:ext uri="{FF2B5EF4-FFF2-40B4-BE49-F238E27FC236}">
-                <a16:creationId xmlns:a16="http://schemas.microsoft.com/office/drawing/2014/main" id="{46652140-EFF0-4494-9179-726A45039239}"/>
+                <a16:creationId xmlns:a16="http://schemas.microsoft.com/office/drawing/2014/main" id="{16E4BF93-4904-4CFE-A168-264AD43FFBEC}"/>
               </a:ext>
             </a:extLst>
           </p:cNvPr>
@@ -3306,7 +3306,7 @@
           <p:cNvPr id="2" name="">
             <a:extLst xmlns:a="http://schemas.openxmlformats.org/drawingml/2006/main">
               <a:ext uri="{FF2B5EF4-FFF2-40B4-BE49-F238E27FC236}">
-                <a16:creationId xmlns:a16="http://schemas.microsoft.com/office/drawing/2014/main" id="{17FC26FE-3004-4658-96F8-13D49CDFB60C}"/>
+                <a16:creationId xmlns:a16="http://schemas.microsoft.com/office/drawing/2014/main" id="{DC4E71E9-075A-441D-BFA4-B928E5E43046}"/>
               </a:ext>
             </a:extLst>
           </p:cNvPr>
@@ -3353,7 +3353,7 @@
                 <a:ea typeface="Microsoft JhengHei"/>
                 <a:cs typeface="Microsoft JhengHei"/>
               </a:rPr>
-              <a:t>15% 的依據與限制</a:t>
+              <a:t>CNV top 15% 設定與 reference 對照</a:t>
             </a:r>
           </a:p>
         </p:txBody>
@@ -3363,7 +3363,7 @@
           <p:cNvPr id="3" name="">
             <a:extLst xmlns:a="http://schemas.openxmlformats.org/drawingml/2006/main">
               <a:ext uri="{FF2B5EF4-FFF2-40B4-BE49-F238E27FC236}">
-                <a16:creationId xmlns:a16="http://schemas.microsoft.com/office/drawing/2014/main" id="{46E87C88-9273-488C-9A64-690BFEE6F749}"/>
+                <a16:creationId xmlns:a16="http://schemas.microsoft.com/office/drawing/2014/main" id="{ADBFA3F9-2002-4E63-8CCB-7687217D1DB6}"/>
               </a:ext>
             </a:extLst>
           </p:cNvPr>
@@ -3420,7 +3420,7 @@
           <p:cNvPr id="4" name="">
             <a:extLst xmlns:a="http://schemas.openxmlformats.org/drawingml/2006/main">
               <a:ext uri="{FF2B5EF4-FFF2-40B4-BE49-F238E27FC236}">
-                <a16:creationId xmlns:a16="http://schemas.microsoft.com/office/drawing/2014/main" id="{273D9AA2-4383-4E7C-ABE8-A4F8EFE84788}"/>
+                <a16:creationId xmlns:a16="http://schemas.microsoft.com/office/drawing/2014/main" id="{E77A0E46-2EC3-4566-BF4E-0D97F1B54169}"/>
               </a:ext>
             </a:extLst>
           </p:cNvPr>
@@ -3477,7 +3477,7 @@
           <p:cNvPr id="5" name="">
             <a:extLst xmlns:a="http://schemas.openxmlformats.org/drawingml/2006/main">
               <a:ext uri="{FF2B5EF4-FFF2-40B4-BE49-F238E27FC236}">
-                <a16:creationId xmlns:a16="http://schemas.microsoft.com/office/drawing/2014/main" id="{BD3F7252-C7B0-4770-8911-2F2F38212DB8}"/>
+                <a16:creationId xmlns:a16="http://schemas.microsoft.com/office/drawing/2014/main" id="{E7BC03BA-BAA7-4829-B6A5-AC8145BF22E0}"/>
               </a:ext>
             </a:extLst>
           </p:cNvPr>
@@ -3524,7 +3524,7 @@
                 <a:ea typeface="Microsoft JhengHei"/>
                 <a:cs typeface="Microsoft JhengHei"/>
               </a:rPr>
-              <a:t>正常 reference 的 q95 與 within-sample top 15% 是兩個不同規則</a:t>
+              <a:t>每個 sample 保留 CNV score 最高的 15%，作為相對高 CNV 的 T-lineage core</a:t>
             </a:r>
           </a:p>
         </p:txBody>
@@ -3637,7 +3637,82 @@
                           <a:ea typeface="Microsoft JhengHei"/>
                           <a:cs typeface="Microsoft JhengHei"/>
                         </a:rPr>
-                        <a:t>Absolute reference q95</a:t>
+                        <a:t>主分析：sample top 15%</a:t>
+                      </a:r>
+                    </a:p>
+                  </a:txBody>
+                  <a:tcPr marL="91440" marR="91440" marT="45720" marB="45720"/>
+                </a:tc>
+                <a:tc>
+                  <a:txBody>
+                    <a:bodyPr/>
+                    <a:lstStyle/>
+                    <a:p>
+                      <a:r>
+                        <a:rPr sz="1575">
+                          <a:solidFill>
+                            <a:srgbClr val="142F43"/>
+                          </a:solidFill>
+                          <a:latin typeface="Microsoft JhengHei"/>
+                          <a:ea typeface="Microsoft JhengHei"/>
+                          <a:cs typeface="Microsoft JhengHei"/>
+                        </a:rPr>
+                        <a:t>每個 sample 各自選 CNV score 最高 15%</a:t>
+                      </a:r>
+                    </a:p>
+                  </a:txBody>
+                  <a:tcPr marL="91440" marR="91440" marT="45720" marB="45720"/>
+                </a:tc>
+                <a:tc>
+                  <a:txBody>
+                    <a:bodyPr/>
+                    <a:lstStyle/>
+                    <a:p>
+                      <a:r>
+                        <a:rPr sz="1575">
+                          <a:solidFill>
+                            <a:srgbClr val="142F43"/>
+                          </a:solidFill>
+                          <a:latin typeface="Microsoft JhengHei"/>
+                          <a:ea typeface="Microsoft JhengHei"/>
+                          <a:cs typeface="Microsoft JhengHei"/>
+                        </a:rPr>
+                        <a:t>1,926 cells</a:t>
+                      </a:r>
+                    </a:p>
+                    <a:p>
+                      <a:r>
+                        <a:rPr sz="1575">
+                          <a:solidFill>
+                            <a:srgbClr val="142F43"/>
+                          </a:solidFill>
+                          <a:latin typeface="Microsoft JhengHei"/>
+                          <a:ea typeface="Microsoft JhengHei"/>
+                          <a:cs typeface="Microsoft JhengHei"/>
+                        </a:rPr>
+                        <a:t>最小 sample 107</a:t>
+                      </a:r>
+                    </a:p>
+                  </a:txBody>
+                  <a:tcPr marL="91440" marR="91440" marT="45720" marB="45720"/>
+                </a:tc>
+              </a:tr>
+              <a:tr h="790575">
+                <a:tc>
+                  <a:txBody>
+                    <a:bodyPr/>
+                    <a:lstStyle/>
+                    <a:p>
+                      <a:r>
+                        <a:rPr sz="1575">
+                          <a:solidFill>
+                            <a:srgbClr val="142F43"/>
+                          </a:solidFill>
+                          <a:latin typeface="Microsoft JhengHei"/>
+                          <a:ea typeface="Microsoft JhengHei"/>
+                          <a:cs typeface="Microsoft JhengHei"/>
+                        </a:rPr>
+                        <a:t>Non-T reference q95</a:t>
                       </a:r>
                     </a:p>
                   </a:txBody>
@@ -3697,81 +3772,6 @@
                   <a:tcPr marL="91440" marR="91440" marT="45720" marB="45720"/>
                 </a:tc>
               </a:tr>
-              <a:tr h="790575">
-                <a:tc>
-                  <a:txBody>
-                    <a:bodyPr/>
-                    <a:lstStyle/>
-                    <a:p>
-                      <a:r>
-                        <a:rPr sz="1575">
-                          <a:solidFill>
-                            <a:srgbClr val="142F43"/>
-                          </a:solidFill>
-                          <a:latin typeface="Microsoft JhengHei"/>
-                          <a:ea typeface="Microsoft JhengHei"/>
-                          <a:cs typeface="Microsoft JhengHei"/>
-                        </a:rPr>
-                        <a:t>Within-sample top 15%</a:t>
-                      </a:r>
-                    </a:p>
-                  </a:txBody>
-                  <a:tcPr marL="91440" marR="91440" marT="45720" marB="45720"/>
-                </a:tc>
-                <a:tc>
-                  <a:txBody>
-                    <a:bodyPr/>
-                    <a:lstStyle/>
-                    <a:p>
-                      <a:r>
-                        <a:rPr sz="1575">
-                          <a:solidFill>
-                            <a:srgbClr val="142F43"/>
-                          </a:solidFill>
-                          <a:latin typeface="Microsoft JhengHei"/>
-                          <a:ea typeface="Microsoft JhengHei"/>
-                          <a:cs typeface="Microsoft JhengHei"/>
-                        </a:rPr>
-                        <a:t>每個 sample 各自選 CNV score 最高 15%</a:t>
-                      </a:r>
-                    </a:p>
-                  </a:txBody>
-                  <a:tcPr marL="91440" marR="91440" marT="45720" marB="45720"/>
-                </a:tc>
-                <a:tc>
-                  <a:txBody>
-                    <a:bodyPr/>
-                    <a:lstStyle/>
-                    <a:p>
-                      <a:r>
-                        <a:rPr sz="1575">
-                          <a:solidFill>
-                            <a:srgbClr val="142F43"/>
-                          </a:solidFill>
-                          <a:latin typeface="Microsoft JhengHei"/>
-                          <a:ea typeface="Microsoft JhengHei"/>
-                          <a:cs typeface="Microsoft JhengHei"/>
-                        </a:rPr>
-                        <a:t>1,926 cells</a:t>
-                      </a:r>
-                    </a:p>
-                    <a:p>
-                      <a:r>
-                        <a:rPr sz="1575">
-                          <a:solidFill>
-                            <a:srgbClr val="142F43"/>
-                          </a:solidFill>
-                          <a:latin typeface="Microsoft JhengHei"/>
-                          <a:ea typeface="Microsoft JhengHei"/>
-                          <a:cs typeface="Microsoft JhengHei"/>
-                        </a:rPr>
-                        <a:t>最小 sample 107</a:t>
-                      </a:r>
-                    </a:p>
-                  </a:txBody>
-                  <a:tcPr marL="91440" marR="91440" marT="45720" marB="45720"/>
-                </a:tc>
-              </a:tr>
             </a:tbl>
           </a:graphicData>
         </a:graphic>
@@ -3781,7 +3781,7 @@
           <p:cNvPr id="7" name="">
             <a:extLst xmlns:a="http://schemas.openxmlformats.org/drawingml/2006/main">
               <a:ext uri="{FF2B5EF4-FFF2-40B4-BE49-F238E27FC236}">
-                <a16:creationId xmlns:a16="http://schemas.microsoft.com/office/drawing/2014/main" id="{1C57D718-55CC-49C2-862B-C72E856272B8}"/>
+                <a16:creationId xmlns:a16="http://schemas.microsoft.com/office/drawing/2014/main" id="{67465EEF-2553-4B36-A006-89BDD098131D}"/>
               </a:ext>
             </a:extLst>
           </p:cNvPr>
@@ -3793,7 +3793,7 @@
         <p:spPr>
           <a:xfrm xmlns:a="http://schemas.openxmlformats.org/drawingml/2006/main">
             <a:off x="619125" y="4667250"/>
-            <a:ext cx="10668000" cy="733425"/>
+            <a:ext cx="10668000" cy="828675"/>
           </a:xfrm>
           <a:prstGeom xmlns:a="http://schemas.openxmlformats.org/drawingml/2006/main" prst="rect">
             <a:avLst/>
@@ -3810,25 +3810,25 @@
           <a:lstStyle xmlns:a="http://schemas.openxmlformats.org/drawingml/2006/main"/>
           <a:p xmlns:a="http://schemas.openxmlformats.org/drawingml/2006/main">
             <a:pPr>
-              <a:defRPr sz="1800" b="0">
-                <a:solidFill>
-                  <a:srgbClr val="D55E00"/>
-                </a:solidFill>
-                <a:latin typeface="Microsoft JhengHei"/>
-                <a:ea typeface="Microsoft JhengHei"/>
-                <a:cs typeface="Microsoft JhengHei"/>
-              </a:defRPr>
-            </a:pPr>
-            <a:r>
-              <a:rPr sz="1800" b="0">
-                <a:solidFill>
-                  <a:srgbClr val="D55E00"/>
-                </a:solidFill>
-                <a:latin typeface="Microsoft JhengHei"/>
-                <a:ea typeface="Microsoft JhengHei"/>
-                <a:cs typeface="Microsoft JhengHei"/>
-              </a:rPr>
-              <a:t>15.4% 高於 pooled reference q95，只是近似的描述性對照，不能把選 15% 說成 unbiased。</a:t>
+              <a:defRPr sz="1725" b="0">
+                <a:solidFill>
+                  <a:srgbClr val="142F43"/>
+                </a:solidFill>
+                <a:latin typeface="Microsoft JhengHei"/>
+                <a:ea typeface="Microsoft JhengHei"/>
+                <a:cs typeface="Microsoft JhengHei"/>
+              </a:defRPr>
+            </a:pPr>
+            <a:r>
+              <a:rPr sz="1725" b="0">
+                <a:solidFill>
+                  <a:srgbClr val="142F43"/>
+                </a:solidFill>
+                <a:latin typeface="Microsoft JhengHei"/>
+                <a:ea typeface="Microsoft JhengHei"/>
+                <a:cs typeface="Microsoft JhengHei"/>
+              </a:rPr>
+              <a:t>Reference q95 提供比例尺度對照。Top 15% 中有 1,407 / 1,926 cells（73.1%）高於 q95，兩種規則選到的細胞並不相同。</a:t>
             </a:r>
           </a:p>
         </p:txBody>
@@ -3838,7 +3838,7 @@
           <p:cNvPr id="8" name="">
             <a:extLst xmlns:a="http://schemas.openxmlformats.org/drawingml/2006/main">
               <a:ext uri="{FF2B5EF4-FFF2-40B4-BE49-F238E27FC236}">
-                <a16:creationId xmlns:a16="http://schemas.microsoft.com/office/drawing/2014/main" id="{3CF934D7-E343-4A9B-92C9-B419B75943E5}"/>
+                <a16:creationId xmlns:a16="http://schemas.microsoft.com/office/drawing/2014/main" id="{158ED145-073F-44BC-A535-02A3E63E1818}"/>
               </a:ext>
             </a:extLst>
           </p:cNvPr>
@@ -3867,25 +3867,25 @@
           <a:lstStyle xmlns:a="http://schemas.openxmlformats.org/drawingml/2006/main"/>
           <a:p xmlns:a="http://schemas.openxmlformats.org/drawingml/2006/main">
             <a:pPr>
-              <a:defRPr sz="1650" b="0">
-                <a:solidFill>
-                  <a:srgbClr val="142F43"/>
-                </a:solidFill>
-                <a:latin typeface="Microsoft JhengHei"/>
-                <a:ea typeface="Microsoft JhengHei"/>
-                <a:cs typeface="Microsoft JhengHei"/>
-              </a:defRPr>
-            </a:pPr>
-            <a:r>
-              <a:rPr sz="1650" b="0">
-                <a:solidFill>
-                  <a:srgbClr val="142F43"/>
-                </a:solidFill>
-                <a:latin typeface="Microsoft JhengHei"/>
-                <a:ea typeface="Microsoft JhengHei"/>
-                <a:cs typeface="Microsoft JhengHei"/>
-              </a:rPr>
-              <a:t>完整 KEGG FDR 只校正該次 pathway 測試，沒有校正嘗試多套篩選條件後再挑選的影響。</a:t>
+              <a:defRPr sz="1575" b="0">
+                <a:solidFill>
+                  <a:srgbClr val="D55E00"/>
+                </a:solidFill>
+                <a:latin typeface="Microsoft JhengHei"/>
+                <a:ea typeface="Microsoft JhengHei"/>
+                <a:cs typeface="Microsoft JhengHei"/>
+              </a:defRPr>
+            </a:pPr>
+            <a:r>
+              <a:rPr sz="1575" b="0">
+                <a:solidFill>
+                  <a:srgbClr val="D55E00"/>
+                </a:solidFill>
+                <a:latin typeface="Microsoft JhengHei"/>
+                <a:ea typeface="Microsoft JhengHei"/>
+                <a:cs typeface="Microsoft JhengHei"/>
+              </a:rPr>
+              <a:t>Top 15% 在 sensitivity 檢查後固定為主分析。FDR &lt; 0.05 是 pathway 門檻，沒有額外校正選擇分析條件的影響。</a:t>
             </a:r>
           </a:p>
         </p:txBody>
@@ -3893,7 +3893,7 @@
     </p:spTree>
     <p:extLst>
       <p:ext uri="{BB962C8B-B14F-4D97-AF65-F5344CB8AC3E}">
-        <p14:creationId xmlns:p14="http://schemas.microsoft.com/office/powerpoint/2010/main" val="1532590862"/>
+        <p14:creationId xmlns:p14="http://schemas.microsoft.com/office/powerpoint/2010/main" val="1078628514"/>
       </p:ext>
     </p:extLst>
   </p:cSld>
@@ -3924,7 +3924,7 @@
           <p:cNvPr id="8" name="">
             <a:extLst xmlns:a="http://schemas.openxmlformats.org/drawingml/2006/main">
               <a:ext uri="{FF2B5EF4-FFF2-40B4-BE49-F238E27FC236}">
-                <a16:creationId xmlns:a16="http://schemas.microsoft.com/office/drawing/2014/main" id="{2BB479EF-9A00-497F-A41C-D100C274179D}"/>
+                <a16:creationId xmlns:a16="http://schemas.microsoft.com/office/drawing/2014/main" id="{41678ED5-EAC8-47C3-83D1-9FF178B6FAC5}"/>
               </a:ext>
             </a:extLst>
           </p:cNvPr>
@@ -3981,7 +3981,7 @@
           <p:cNvPr id="2" name="">
             <a:extLst xmlns:a="http://schemas.openxmlformats.org/drawingml/2006/main">
               <a:ext uri="{FF2B5EF4-FFF2-40B4-BE49-F238E27FC236}">
-                <a16:creationId xmlns:a16="http://schemas.microsoft.com/office/drawing/2014/main" id="{C63E8DCC-0903-4087-9DB4-A7A6834D55CC}"/>
+                <a16:creationId xmlns:a16="http://schemas.microsoft.com/office/drawing/2014/main" id="{5DCCD8A8-51A4-4D94-B940-D6CCE072FD56}"/>
               </a:ext>
             </a:extLst>
           </p:cNvPr>
@@ -4038,7 +4038,7 @@
           <p:cNvPr id="3" name="">
             <a:extLst xmlns:a="http://schemas.openxmlformats.org/drawingml/2006/main">
               <a:ext uri="{FF2B5EF4-FFF2-40B4-BE49-F238E27FC236}">
-                <a16:creationId xmlns:a16="http://schemas.microsoft.com/office/drawing/2014/main" id="{E8C73163-5C27-4CA8-961E-068DAC10F12C}"/>
+                <a16:creationId xmlns:a16="http://schemas.microsoft.com/office/drawing/2014/main" id="{5C8AA5BD-8D05-480C-B80D-F1DB047F262D}"/>
               </a:ext>
             </a:extLst>
           </p:cNvPr>
@@ -4095,7 +4095,7 @@
           <p:cNvPr id="4" name="">
             <a:extLst xmlns:a="http://schemas.openxmlformats.org/drawingml/2006/main">
               <a:ext uri="{FF2B5EF4-FFF2-40B4-BE49-F238E27FC236}">
-                <a16:creationId xmlns:a16="http://schemas.microsoft.com/office/drawing/2014/main" id="{8E739B79-1495-4D18-8A45-9E28B626D3A5}"/>
+                <a16:creationId xmlns:a16="http://schemas.microsoft.com/office/drawing/2014/main" id="{71503BDF-C64F-4677-BCCF-B58C4A7203EE}"/>
               </a:ext>
             </a:extLst>
           </p:cNvPr>
@@ -4152,7 +4152,7 @@
           <p:cNvPr id="5" name="">
             <a:extLst xmlns:a="http://schemas.openxmlformats.org/drawingml/2006/main">
               <a:ext uri="{FF2B5EF4-FFF2-40B4-BE49-F238E27FC236}">
-                <a16:creationId xmlns:a16="http://schemas.microsoft.com/office/drawing/2014/main" id="{181E41DB-99DE-448D-916E-5F60DE541C94}"/>
+                <a16:creationId xmlns:a16="http://schemas.microsoft.com/office/drawing/2014/main" id="{B9EF9F9D-40E9-4AF5-89B7-B9B364D0E26E}"/>
               </a:ext>
             </a:extLst>
           </p:cNvPr>
@@ -4209,7 +4209,7 @@
           <p:cNvPr id="6" name="">
             <a:extLst xmlns:a="http://schemas.openxmlformats.org/drawingml/2006/main">
               <a:ext uri="{FF2B5EF4-FFF2-40B4-BE49-F238E27FC236}">
-                <a16:creationId xmlns:a16="http://schemas.microsoft.com/office/drawing/2014/main" id="{3169BA53-B9DF-4DEA-9DA8-EA23C7E6FC8A}"/>
+                <a16:creationId xmlns:a16="http://schemas.microsoft.com/office/drawing/2014/main" id="{33E8C953-0726-4F5C-AF81-ACEEDCD3E75F}"/>
               </a:ext>
             </a:extLst>
           </p:cNvPr>
@@ -4266,7 +4266,7 @@
           <p:cNvPr id="7" name="">
             <a:extLst xmlns:a="http://schemas.openxmlformats.org/drawingml/2006/main">
               <a:ext uri="{FF2B5EF4-FFF2-40B4-BE49-F238E27FC236}">
-                <a16:creationId xmlns:a16="http://schemas.microsoft.com/office/drawing/2014/main" id="{21E264F4-0596-4214-ABCB-45C4306D929C}"/>
+                <a16:creationId xmlns:a16="http://schemas.microsoft.com/office/drawing/2014/main" id="{84A85ABF-F71C-43AB-99E2-BC8911647396}"/>
               </a:ext>
             </a:extLst>
           </p:cNvPr>
@@ -4321,7 +4321,7 @@
     </p:spTree>
     <p:extLst>
       <p:ext uri="{BB962C8B-B14F-4D97-AF65-F5344CB8AC3E}">
-        <p14:creationId xmlns:p14="http://schemas.microsoft.com/office/powerpoint/2010/main" val="836903781"/>
+        <p14:creationId xmlns:p14="http://schemas.microsoft.com/office/powerpoint/2010/main" val="1428910776"/>
       </p:ext>
     </p:extLst>
   </p:cSld>
@@ -4352,7 +4352,7 @@
           <p:cNvPr id="8" name="">
             <a:extLst xmlns:a="http://schemas.openxmlformats.org/drawingml/2006/main">
               <a:ext uri="{FF2B5EF4-FFF2-40B4-BE49-F238E27FC236}">
-                <a16:creationId xmlns:a16="http://schemas.microsoft.com/office/drawing/2014/main" id="{5A1567BD-D6CA-4D4C-A426-CE61C6C205E6}"/>
+                <a16:creationId xmlns:a16="http://schemas.microsoft.com/office/drawing/2014/main" id="{B636F826-3F4A-4AF4-93AB-DB9310AD131F}"/>
               </a:ext>
             </a:extLst>
           </p:cNvPr>
@@ -4409,7 +4409,7 @@
           <p:cNvPr id="2" name="">
             <a:extLst xmlns:a="http://schemas.openxmlformats.org/drawingml/2006/main">
               <a:ext uri="{FF2B5EF4-FFF2-40B4-BE49-F238E27FC236}">
-                <a16:creationId xmlns:a16="http://schemas.microsoft.com/office/drawing/2014/main" id="{954BB178-3B76-4F1A-9E29-52FAF28AEFF7}"/>
+                <a16:creationId xmlns:a16="http://schemas.microsoft.com/office/drawing/2014/main" id="{63D410B5-0D76-4248-8019-D8988B7C500D}"/>
               </a:ext>
             </a:extLst>
           </p:cNvPr>
@@ -4466,7 +4466,7 @@
           <p:cNvPr id="3" name="">
             <a:extLst xmlns:a="http://schemas.openxmlformats.org/drawingml/2006/main">
               <a:ext uri="{FF2B5EF4-FFF2-40B4-BE49-F238E27FC236}">
-                <a16:creationId xmlns:a16="http://schemas.microsoft.com/office/drawing/2014/main" id="{A1CF8BA5-DAF7-4FA9-BD44-EF1105CA6A61}"/>
+                <a16:creationId xmlns:a16="http://schemas.microsoft.com/office/drawing/2014/main" id="{B474F5DE-0917-41A3-8098-26B595BD082A}"/>
               </a:ext>
             </a:extLst>
           </p:cNvPr>
@@ -4523,7 +4523,7 @@
           <p:cNvPr id="4" name="">
             <a:extLst xmlns:a="http://schemas.openxmlformats.org/drawingml/2006/main">
               <a:ext uri="{FF2B5EF4-FFF2-40B4-BE49-F238E27FC236}">
-                <a16:creationId xmlns:a16="http://schemas.microsoft.com/office/drawing/2014/main" id="{75524C2F-4055-403A-8485-640F5E41361E}"/>
+                <a16:creationId xmlns:a16="http://schemas.microsoft.com/office/drawing/2014/main" id="{806FB2D0-3099-4D8A-9968-CE88BB0ADA64}"/>
               </a:ext>
             </a:extLst>
           </p:cNvPr>
@@ -4862,7 +4862,7 @@
           <p:cNvPr id="6" name="">
             <a:extLst xmlns:a="http://schemas.openxmlformats.org/drawingml/2006/main">
               <a:ext uri="{FF2B5EF4-FFF2-40B4-BE49-F238E27FC236}">
-                <a16:creationId xmlns:a16="http://schemas.microsoft.com/office/drawing/2014/main" id="{F4B1BB58-4591-4B32-8232-715F452405A6}"/>
+                <a16:creationId xmlns:a16="http://schemas.microsoft.com/office/drawing/2014/main" id="{D32E4F07-AFA0-46F0-857E-7048B70629C1}"/>
               </a:ext>
             </a:extLst>
           </p:cNvPr>
@@ -4919,7 +4919,7 @@
           <p:cNvPr id="7" name="">
             <a:extLst xmlns:a="http://schemas.openxmlformats.org/drawingml/2006/main">
               <a:ext uri="{FF2B5EF4-FFF2-40B4-BE49-F238E27FC236}">
-                <a16:creationId xmlns:a16="http://schemas.microsoft.com/office/drawing/2014/main" id="{A4DC28A9-7DC8-41A9-8976-DC4477161803}"/>
+                <a16:creationId xmlns:a16="http://schemas.microsoft.com/office/drawing/2014/main" id="{2CB4E885-DD31-41B2-AEB3-3AD275012F1B}"/>
               </a:ext>
             </a:extLst>
           </p:cNvPr>
@@ -4974,7 +4974,7 @@
     </p:spTree>
     <p:extLst>
       <p:ext uri="{BB962C8B-B14F-4D97-AF65-F5344CB8AC3E}">
-        <p14:creationId xmlns:p14="http://schemas.microsoft.com/office/powerpoint/2010/main" val="1410996092"/>
+        <p14:creationId xmlns:p14="http://schemas.microsoft.com/office/powerpoint/2010/main" val="1037664592"/>
       </p:ext>
     </p:extLst>
   </p:cSld>
@@ -5005,7 +5005,7 @@
           <p:cNvPr id="7" name="">
             <a:extLst xmlns:a="http://schemas.openxmlformats.org/drawingml/2006/main">
               <a:ext uri="{FF2B5EF4-FFF2-40B4-BE49-F238E27FC236}">
-                <a16:creationId xmlns:a16="http://schemas.microsoft.com/office/drawing/2014/main" id="{80184479-6286-4CF3-8AFD-4F4EB6388B23}"/>
+                <a16:creationId xmlns:a16="http://schemas.microsoft.com/office/drawing/2014/main" id="{6EF0FA12-371D-4576-AEFD-685B8497BA68}"/>
               </a:ext>
             </a:extLst>
           </p:cNvPr>
@@ -5062,7 +5062,7 @@
           <p:cNvPr id="2" name="">
             <a:extLst xmlns:a="http://schemas.openxmlformats.org/drawingml/2006/main">
               <a:ext uri="{FF2B5EF4-FFF2-40B4-BE49-F238E27FC236}">
-                <a16:creationId xmlns:a16="http://schemas.microsoft.com/office/drawing/2014/main" id="{A1B194F2-4BDC-4070-9E4B-D43557AB8E40}"/>
+                <a16:creationId xmlns:a16="http://schemas.microsoft.com/office/drawing/2014/main" id="{6DF789B7-C11F-4601-912E-AE304B0A7790}"/>
               </a:ext>
             </a:extLst>
           </p:cNvPr>
@@ -5119,7 +5119,7 @@
           <p:cNvPr id="3" name="">
             <a:extLst xmlns:a="http://schemas.openxmlformats.org/drawingml/2006/main">
               <a:ext uri="{FF2B5EF4-FFF2-40B4-BE49-F238E27FC236}">
-                <a16:creationId xmlns:a16="http://schemas.microsoft.com/office/drawing/2014/main" id="{EA587805-9FF3-4BE7-A69D-33624AB916E6}"/>
+                <a16:creationId xmlns:a16="http://schemas.microsoft.com/office/drawing/2014/main" id="{CA60FDA1-DF61-4F9D-B939-81BDFFD9FA5D}"/>
               </a:ext>
             </a:extLst>
           </p:cNvPr>
@@ -5176,7 +5176,7 @@
           <p:cNvPr id="4" name="">
             <a:extLst xmlns:a="http://schemas.openxmlformats.org/drawingml/2006/main">
               <a:ext uri="{FF2B5EF4-FFF2-40B4-BE49-F238E27FC236}">
-                <a16:creationId xmlns:a16="http://schemas.microsoft.com/office/drawing/2014/main" id="{03E1E5FD-F856-4C18-B206-BD116ECD3EC7}"/>
+                <a16:creationId xmlns:a16="http://schemas.microsoft.com/office/drawing/2014/main" id="{498F86D3-575B-45ED-A0DA-02B7AFC3A0A3}"/>
               </a:ext>
             </a:extLst>
           </p:cNvPr>
@@ -5610,7 +5610,7 @@
           <p:cNvPr id="6" name="">
             <a:extLst xmlns:a="http://schemas.openxmlformats.org/drawingml/2006/main">
               <a:ext uri="{FF2B5EF4-FFF2-40B4-BE49-F238E27FC236}">
-                <a16:creationId xmlns:a16="http://schemas.microsoft.com/office/drawing/2014/main" id="{B16CBBE1-BAEF-4150-94EE-BD2A0AD71C3D}"/>
+                <a16:creationId xmlns:a16="http://schemas.microsoft.com/office/drawing/2014/main" id="{C4F1B731-AEC3-4A3B-A671-CD49BA9248D1}"/>
               </a:ext>
             </a:extLst>
           </p:cNvPr>
@@ -5665,7 +5665,7 @@
     </p:spTree>
     <p:extLst>
       <p:ext uri="{BB962C8B-B14F-4D97-AF65-F5344CB8AC3E}">
-        <p14:creationId xmlns:p14="http://schemas.microsoft.com/office/powerpoint/2010/main" val="955592408"/>
+        <p14:creationId xmlns:p14="http://schemas.microsoft.com/office/powerpoint/2010/main" val="2050427488"/>
       </p:ext>
     </p:extLst>
   </p:cSld>
@@ -5696,7 +5696,7 @@
           <p:cNvPr id="9" name="">
             <a:extLst xmlns:a="http://schemas.openxmlformats.org/drawingml/2006/main">
               <a:ext uri="{FF2B5EF4-FFF2-40B4-BE49-F238E27FC236}">
-                <a16:creationId xmlns:a16="http://schemas.microsoft.com/office/drawing/2014/main" id="{85BE3630-6317-4372-8E04-7480A23B72FD}"/>
+                <a16:creationId xmlns:a16="http://schemas.microsoft.com/office/drawing/2014/main" id="{A3044CC2-C80B-4B43-AE4D-E8BA5ED6BF30}"/>
               </a:ext>
             </a:extLst>
           </p:cNvPr>
@@ -5753,7 +5753,7 @@
           <p:cNvPr id="2" name="">
             <a:extLst xmlns:a="http://schemas.openxmlformats.org/drawingml/2006/main">
               <a:ext uri="{FF2B5EF4-FFF2-40B4-BE49-F238E27FC236}">
-                <a16:creationId xmlns:a16="http://schemas.microsoft.com/office/drawing/2014/main" id="{73BA0504-3266-4FBF-BFC2-ABEAB72814BD}"/>
+                <a16:creationId xmlns:a16="http://schemas.microsoft.com/office/drawing/2014/main" id="{3E9C4ADE-4E98-4DC7-82B7-FE2F33A6761F}"/>
               </a:ext>
             </a:extLst>
           </p:cNvPr>
@@ -5810,7 +5810,7 @@
           <p:cNvPr id="3" name="">
             <a:extLst xmlns:a="http://schemas.openxmlformats.org/drawingml/2006/main">
               <a:ext uri="{FF2B5EF4-FFF2-40B4-BE49-F238E27FC236}">
-                <a16:creationId xmlns:a16="http://schemas.microsoft.com/office/drawing/2014/main" id="{515287D8-1FF8-45DB-82BA-D0B16A83C69E}"/>
+                <a16:creationId xmlns:a16="http://schemas.microsoft.com/office/drawing/2014/main" id="{3900DDB9-4454-4822-954D-216C2AB5EC1A}"/>
               </a:ext>
             </a:extLst>
           </p:cNvPr>
@@ -5867,7 +5867,7 @@
           <p:cNvPr id="4" name="">
             <a:extLst xmlns:a="http://schemas.openxmlformats.org/drawingml/2006/main">
               <a:ext uri="{FF2B5EF4-FFF2-40B4-BE49-F238E27FC236}">
-                <a16:creationId xmlns:a16="http://schemas.microsoft.com/office/drawing/2014/main" id="{360BF55F-2236-459F-A279-13526A4AC589}"/>
+                <a16:creationId xmlns:a16="http://schemas.microsoft.com/office/drawing/2014/main" id="{475E32B0-2484-41DB-B3E7-123E064FA3B2}"/>
               </a:ext>
             </a:extLst>
           </p:cNvPr>
@@ -5928,7 +5928,7 @@
           <p:nvPr/>
         </p:nvPicPr>
         <p:blipFill>
-          <a:blip xmlns:r="http://schemas.openxmlformats.org/officeDocument/2006/relationships" xmlns:a="http://schemas.openxmlformats.org/drawingml/2006/main" r:embed="R77227873a4144c01"/>
+          <a:blip xmlns:r="http://schemas.openxmlformats.org/officeDocument/2006/relationships" xmlns:a="http://schemas.openxmlformats.org/drawingml/2006/main" r:embed="R2e2d4a77c50848c4"/>
           <a:stretch xmlns:a="http://schemas.openxmlformats.org/drawingml/2006/main"/>
         </p:blipFill>
         <p:spPr>
@@ -5946,7 +5946,7 @@
           <p:cNvPr id="6" name="">
             <a:extLst xmlns:a="http://schemas.openxmlformats.org/drawingml/2006/main">
               <a:ext uri="{FF2B5EF4-FFF2-40B4-BE49-F238E27FC236}">
-                <a16:creationId xmlns:a16="http://schemas.microsoft.com/office/drawing/2014/main" id="{00B3FD40-3F20-4963-A5EE-3D239EC83CA7}"/>
+                <a16:creationId xmlns:a16="http://schemas.microsoft.com/office/drawing/2014/main" id="{C6959A2F-8919-4DD7-84D2-BCF6731BFF7D}"/>
               </a:ext>
             </a:extLst>
           </p:cNvPr>
@@ -6003,7 +6003,7 @@
           <p:cNvPr id="7" name="">
             <a:extLst xmlns:a="http://schemas.openxmlformats.org/drawingml/2006/main">
               <a:ext uri="{FF2B5EF4-FFF2-40B4-BE49-F238E27FC236}">
-                <a16:creationId xmlns:a16="http://schemas.microsoft.com/office/drawing/2014/main" id="{26DEF7CE-DF6E-4F07-85A4-C05437632528}"/>
+                <a16:creationId xmlns:a16="http://schemas.microsoft.com/office/drawing/2014/main" id="{0907C1F4-889E-42F3-834A-44652244D8A7}"/>
               </a:ext>
             </a:extLst>
           </p:cNvPr>
@@ -6129,7 +6129,7 @@
           <p:cNvPr id="8" name="">
             <a:extLst xmlns:a="http://schemas.openxmlformats.org/drawingml/2006/main">
               <a:ext uri="{FF2B5EF4-FFF2-40B4-BE49-F238E27FC236}">
-                <a16:creationId xmlns:a16="http://schemas.microsoft.com/office/drawing/2014/main" id="{6DCF0182-E068-4576-BA22-7F0536A6A751}"/>
+                <a16:creationId xmlns:a16="http://schemas.microsoft.com/office/drawing/2014/main" id="{640398A2-DC75-4DF5-94A8-FBB3C75D5279}"/>
               </a:ext>
             </a:extLst>
           </p:cNvPr>
@@ -6184,7 +6184,7 @@
     </p:spTree>
     <p:extLst>
       <p:ext uri="{BB962C8B-B14F-4D97-AF65-F5344CB8AC3E}">
-        <p14:creationId xmlns:p14="http://schemas.microsoft.com/office/powerpoint/2010/main" val="1140263419"/>
+        <p14:creationId xmlns:p14="http://schemas.microsoft.com/office/powerpoint/2010/main" val="1736468625"/>
       </p:ext>
     </p:extLst>
   </p:cSld>
@@ -6215,7 +6215,7 @@
           <p:cNvPr id="7" name="">
             <a:extLst xmlns:a="http://schemas.openxmlformats.org/drawingml/2006/main">
               <a:ext uri="{FF2B5EF4-FFF2-40B4-BE49-F238E27FC236}">
-                <a16:creationId xmlns:a16="http://schemas.microsoft.com/office/drawing/2014/main" id="{665C7346-8213-43DF-B2AC-B3017B73BBBD}"/>
+                <a16:creationId xmlns:a16="http://schemas.microsoft.com/office/drawing/2014/main" id="{F5DE7D9F-5127-4DAE-A974-E8B4BF8ADFE9}"/>
               </a:ext>
             </a:extLst>
           </p:cNvPr>
@@ -6272,7 +6272,7 @@
           <p:cNvPr id="2" name="">
             <a:extLst xmlns:a="http://schemas.openxmlformats.org/drawingml/2006/main">
               <a:ext uri="{FF2B5EF4-FFF2-40B4-BE49-F238E27FC236}">
-                <a16:creationId xmlns:a16="http://schemas.microsoft.com/office/drawing/2014/main" id="{BA0E54AB-ABA9-4A30-B064-2FF6EF4F5AC2}"/>
+                <a16:creationId xmlns:a16="http://schemas.microsoft.com/office/drawing/2014/main" id="{005CDB88-888D-4305-904B-4273DF561050}"/>
               </a:ext>
             </a:extLst>
           </p:cNvPr>
@@ -6329,7 +6329,7 @@
           <p:cNvPr id="3" name="">
             <a:extLst xmlns:a="http://schemas.openxmlformats.org/drawingml/2006/main">
               <a:ext uri="{FF2B5EF4-FFF2-40B4-BE49-F238E27FC236}">
-                <a16:creationId xmlns:a16="http://schemas.microsoft.com/office/drawing/2014/main" id="{17F6192F-FFAB-4625-A51C-25FF90AE0574}"/>
+                <a16:creationId xmlns:a16="http://schemas.microsoft.com/office/drawing/2014/main" id="{3A97FCAF-D020-443C-A79B-769ED23AC9EC}"/>
               </a:ext>
             </a:extLst>
           </p:cNvPr>
@@ -6386,7 +6386,7 @@
           <p:cNvPr id="4" name="">
             <a:extLst xmlns:a="http://schemas.openxmlformats.org/drawingml/2006/main">
               <a:ext uri="{FF2B5EF4-FFF2-40B4-BE49-F238E27FC236}">
-                <a16:creationId xmlns:a16="http://schemas.microsoft.com/office/drawing/2014/main" id="{93E19EB1-2222-4E5D-8F96-7C4960F13446}"/>
+                <a16:creationId xmlns:a16="http://schemas.microsoft.com/office/drawing/2014/main" id="{66477DE0-CDE2-47A0-9D9A-1C1CE9D20B24}"/>
               </a:ext>
             </a:extLst>
           </p:cNvPr>
@@ -6447,7 +6447,7 @@
           <p:nvPr/>
         </p:nvPicPr>
         <p:blipFill>
-          <a:blip xmlns:r="http://schemas.openxmlformats.org/officeDocument/2006/relationships" xmlns:a="http://schemas.openxmlformats.org/drawingml/2006/main" r:embed="R2ae4e1b5eaf14d93"/>
+          <a:blip xmlns:r="http://schemas.openxmlformats.org/officeDocument/2006/relationships" xmlns:a="http://schemas.openxmlformats.org/drawingml/2006/main" r:embed="R4b0c1ab8beeb4088"/>
           <a:stretch xmlns:a="http://schemas.openxmlformats.org/drawingml/2006/main"/>
         </p:blipFill>
         <p:spPr>
@@ -6465,7 +6465,7 @@
           <p:cNvPr id="6" name="">
             <a:extLst xmlns:a="http://schemas.openxmlformats.org/drawingml/2006/main">
               <a:ext uri="{FF2B5EF4-FFF2-40B4-BE49-F238E27FC236}">
-                <a16:creationId xmlns:a16="http://schemas.microsoft.com/office/drawing/2014/main" id="{DDD43BD3-6802-4259-AB8B-A7DDD6C8A21E}"/>
+                <a16:creationId xmlns:a16="http://schemas.microsoft.com/office/drawing/2014/main" id="{46FBBF90-A6F6-4721-A91C-5D148221DE05}"/>
               </a:ext>
             </a:extLst>
           </p:cNvPr>
@@ -6520,7 +6520,7 @@
     </p:spTree>
     <p:extLst>
       <p:ext uri="{BB962C8B-B14F-4D97-AF65-F5344CB8AC3E}">
-        <p14:creationId xmlns:p14="http://schemas.microsoft.com/office/powerpoint/2010/main" val="1680776509"/>
+        <p14:creationId xmlns:p14="http://schemas.microsoft.com/office/powerpoint/2010/main" val="911398487"/>
       </p:ext>
     </p:extLst>
   </p:cSld>
@@ -6551,7 +6551,7 @@
           <p:cNvPr id="10" name="">
             <a:extLst xmlns:a="http://schemas.openxmlformats.org/drawingml/2006/main">
               <a:ext uri="{FF2B5EF4-FFF2-40B4-BE49-F238E27FC236}">
-                <a16:creationId xmlns:a16="http://schemas.microsoft.com/office/drawing/2014/main" id="{5F1CB16F-6231-4F0B-9223-F7BF449B6CE0}"/>
+                <a16:creationId xmlns:a16="http://schemas.microsoft.com/office/drawing/2014/main" id="{A54718FC-1433-4090-AF29-DC2E87BFA205}"/>
               </a:ext>
             </a:extLst>
           </p:cNvPr>
@@ -6608,7 +6608,7 @@
           <p:cNvPr id="2" name="">
             <a:extLst xmlns:a="http://schemas.openxmlformats.org/drawingml/2006/main">
               <a:ext uri="{FF2B5EF4-FFF2-40B4-BE49-F238E27FC236}">
-                <a16:creationId xmlns:a16="http://schemas.microsoft.com/office/drawing/2014/main" id="{ACB53B2D-1DA9-4561-A82C-E54D962728D0}"/>
+                <a16:creationId xmlns:a16="http://schemas.microsoft.com/office/drawing/2014/main" id="{BE479827-CC9C-4A8E-BDAB-9DAA948A9360}"/>
               </a:ext>
             </a:extLst>
           </p:cNvPr>
@@ -6665,7 +6665,7 @@
           <p:cNvPr id="3" name="">
             <a:extLst xmlns:a="http://schemas.openxmlformats.org/drawingml/2006/main">
               <a:ext uri="{FF2B5EF4-FFF2-40B4-BE49-F238E27FC236}">
-                <a16:creationId xmlns:a16="http://schemas.microsoft.com/office/drawing/2014/main" id="{EAA7C5BD-BC7A-4501-8A40-7E0C8F907992}"/>
+                <a16:creationId xmlns:a16="http://schemas.microsoft.com/office/drawing/2014/main" id="{938F7DBE-09F0-4623-A30B-B89052EE4851}"/>
               </a:ext>
             </a:extLst>
           </p:cNvPr>
@@ -6722,7 +6722,7 @@
           <p:cNvPr id="4" name="">
             <a:extLst xmlns:a="http://schemas.openxmlformats.org/drawingml/2006/main">
               <a:ext uri="{FF2B5EF4-FFF2-40B4-BE49-F238E27FC236}">
-                <a16:creationId xmlns:a16="http://schemas.microsoft.com/office/drawing/2014/main" id="{0E8FBF13-7CCC-4056-A21F-7754FB71A663}"/>
+                <a16:creationId xmlns:a16="http://schemas.microsoft.com/office/drawing/2014/main" id="{545BC78F-BB33-4975-872D-2ED07904796D}"/>
               </a:ext>
             </a:extLst>
           </p:cNvPr>
@@ -6783,13 +6783,13 @@
           <p:nvPr/>
         </p:nvPicPr>
         <p:blipFill>
-          <a:blip xmlns:r="http://schemas.openxmlformats.org/officeDocument/2006/relationships" xmlns:a="http://schemas.openxmlformats.org/drawingml/2006/main" r:embed="R139a6bdbabce44c4"/>
+          <a:blip xmlns:r="http://schemas.openxmlformats.org/officeDocument/2006/relationships" xmlns:a="http://schemas.openxmlformats.org/drawingml/2006/main" r:embed="R2a135bdfb7144324"/>
           <a:stretch xmlns:a="http://schemas.openxmlformats.org/drawingml/2006/main"/>
         </p:blipFill>
         <p:spPr>
           <a:xfrm xmlns:a="http://schemas.openxmlformats.org/drawingml/2006/main">
-            <a:off x="381000" y="1304925"/>
-            <a:ext cx="7620000" cy="3905250"/>
+            <a:off x="557561" y="1066800"/>
+            <a:ext cx="7266878" cy="4381500"/>
           </a:xfrm>
           <a:prstGeom xmlns:a="http://schemas.openxmlformats.org/drawingml/2006/main" prst="rect">
             <a:avLst/>
@@ -6801,7 +6801,7 @@
           <p:cNvPr id="6" name="">
             <a:extLst xmlns:a="http://schemas.openxmlformats.org/drawingml/2006/main">
               <a:ext uri="{FF2B5EF4-FFF2-40B4-BE49-F238E27FC236}">
-                <a16:creationId xmlns:a16="http://schemas.microsoft.com/office/drawing/2014/main" id="{48FCDFAB-4A6E-4966-AA89-47ABD520A984}"/>
+                <a16:creationId xmlns:a16="http://schemas.microsoft.com/office/drawing/2014/main" id="{18933FD7-3E6D-47B4-9CD9-2C4D72AC6B42}"/>
               </a:ext>
             </a:extLst>
           </p:cNvPr>
@@ -6813,7 +6813,7 @@
         <p:spPr>
           <a:xfrm xmlns:a="http://schemas.openxmlformats.org/drawingml/2006/main">
             <a:off x="8143875" y="1428750"/>
-            <a:ext cx="3524250" cy="904875"/>
+            <a:ext cx="3524250" cy="1000125"/>
           </a:xfrm>
           <a:prstGeom xmlns:a="http://schemas.openxmlformats.org/drawingml/2006/main" prst="rect">
             <a:avLst/>
@@ -6848,7 +6848,7 @@
                 <a:ea typeface="Microsoft JhengHei"/>
                 <a:cs typeface="Microsoft JhengHei"/>
               </a:rPr>
-              <a:t>原始：global top 25%</a:t>
+              <a:t>主分析：within-sample top 15%</a:t>
             </a:r>
           </a:p>
           <a:p xmlns:a="http://schemas.openxmlformats.org/drawingml/2006/main">
@@ -6871,7 +6871,7 @@
                 <a:ea typeface="Microsoft JhengHei"/>
                 <a:cs typeface="Microsoft JhengHei"/>
               </a:rPr>
-              <a:t>3,207 cells，最小 sample 140</a:t>
+              <a:t>1,926 cells，最小 sample 107</a:t>
             </a:r>
           </a:p>
         </p:txBody>
@@ -6881,7 +6881,7 @@
           <p:cNvPr id="7" name="">
             <a:extLst xmlns:a="http://schemas.openxmlformats.org/drawingml/2006/main">
               <a:ext uri="{FF2B5EF4-FFF2-40B4-BE49-F238E27FC236}">
-                <a16:creationId xmlns:a16="http://schemas.microsoft.com/office/drawing/2014/main" id="{B2475294-CCE4-4C30-86A8-8E683920B25B}"/>
+                <a16:creationId xmlns:a16="http://schemas.microsoft.com/office/drawing/2014/main" id="{6718DFE0-760D-4349-966A-EF63D10C55D5}"/>
               </a:ext>
             </a:extLst>
           </p:cNvPr>
@@ -6892,7 +6892,7 @@
         </p:nvSpPr>
         <p:spPr>
           <a:xfrm xmlns:a="http://schemas.openxmlformats.org/drawingml/2006/main">
-            <a:off x="8143875" y="2762250"/>
+            <a:off x="8143875" y="2905125"/>
             <a:ext cx="3524250" cy="1047750"/>
           </a:xfrm>
           <a:prstGeom xmlns:a="http://schemas.openxmlformats.org/drawingml/2006/main" prst="rect">
@@ -6910,48 +6910,48 @@
           <a:lstStyle xmlns:a="http://schemas.openxmlformats.org/drawingml/2006/main"/>
           <a:p xmlns:a="http://schemas.openxmlformats.org/drawingml/2006/main">
             <a:pPr>
-              <a:defRPr sz="1650" b="1">
-                <a:solidFill>
-                  <a:srgbClr val="142F43"/>
-                </a:solidFill>
-                <a:latin typeface="Microsoft JhengHei"/>
-                <a:ea typeface="Microsoft JhengHei"/>
-                <a:cs typeface="Microsoft JhengHei"/>
-              </a:defRPr>
-            </a:pPr>
-            <a:r>
-              <a:rPr sz="1650" b="1">
-                <a:solidFill>
-                  <a:srgbClr val="142F43"/>
-                </a:solidFill>
-                <a:latin typeface="Microsoft JhengHei"/>
-                <a:ea typeface="Microsoft JhengHei"/>
-                <a:cs typeface="Microsoft JhengHei"/>
-              </a:rPr>
-              <a:t>探索型：within-sample top 15%</a:t>
-            </a:r>
-          </a:p>
-          <a:p xmlns:a="http://schemas.openxmlformats.org/drawingml/2006/main">
-            <a:pPr>
-              <a:defRPr sz="1650" b="1">
-                <a:solidFill>
-                  <a:srgbClr val="142F43"/>
-                </a:solidFill>
-                <a:latin typeface="Microsoft JhengHei"/>
-                <a:ea typeface="Microsoft JhengHei"/>
-                <a:cs typeface="Microsoft JhengHei"/>
-              </a:defRPr>
-            </a:pPr>
-            <a:r>
-              <a:rPr sz="1650" b="1">
-                <a:solidFill>
-                  <a:srgbClr val="142F43"/>
-                </a:solidFill>
-                <a:latin typeface="Microsoft JhengHei"/>
-                <a:ea typeface="Microsoft JhengHei"/>
-                <a:cs typeface="Microsoft JhengHei"/>
-              </a:rPr>
-              <a:t>1,926 cells，最小 sample 107</a:t>
+              <a:defRPr sz="1650" b="0">
+                <a:solidFill>
+                  <a:srgbClr val="142F43"/>
+                </a:solidFill>
+                <a:latin typeface="Microsoft JhengHei"/>
+                <a:ea typeface="Microsoft JhengHei"/>
+                <a:cs typeface="Microsoft JhengHei"/>
+              </a:defRPr>
+            </a:pPr>
+            <a:r>
+              <a:rPr sz="1650" b="0">
+                <a:solidFill>
+                  <a:srgbClr val="142F43"/>
+                </a:solidFill>
+                <a:latin typeface="Microsoft JhengHei"/>
+                <a:ea typeface="Microsoft JhengHei"/>
+                <a:cs typeface="Microsoft JhengHei"/>
+              </a:rPr>
+              <a:t>Non-T reference q95 = 0.0269</a:t>
+            </a:r>
+          </a:p>
+          <a:p xmlns:a="http://schemas.openxmlformats.org/drawingml/2006/main">
+            <a:pPr>
+              <a:defRPr sz="1650" b="0">
+                <a:solidFill>
+                  <a:srgbClr val="142F43"/>
+                </a:solidFill>
+                <a:latin typeface="Microsoft JhengHei"/>
+                <a:ea typeface="Microsoft JhengHei"/>
+                <a:cs typeface="Microsoft JhengHei"/>
+              </a:defRPr>
+            </a:pPr>
+            <a:r>
+              <a:rPr sz="1650" b="0">
+                <a:solidFill>
+                  <a:srgbClr val="142F43"/>
+                </a:solidFill>
+                <a:latin typeface="Microsoft JhengHei"/>
+                <a:ea typeface="Microsoft JhengHei"/>
+                <a:cs typeface="Microsoft JhengHei"/>
+              </a:rPr>
+              <a:t>全體候選 T 細胞有 15.4% 高於此值</a:t>
             </a:r>
           </a:p>
         </p:txBody>
@@ -6961,7 +6961,7 @@
           <p:cNvPr id="8" name="">
             <a:extLst xmlns:a="http://schemas.openxmlformats.org/drawingml/2006/main">
               <a:ext uri="{FF2B5EF4-FFF2-40B4-BE49-F238E27FC236}">
-                <a16:creationId xmlns:a16="http://schemas.microsoft.com/office/drawing/2014/main" id="{B41E4724-0244-4F98-82E8-ED1612850E74}"/>
+                <a16:creationId xmlns:a16="http://schemas.microsoft.com/office/drawing/2014/main" id="{E32BF426-9997-4D82-83A2-6067645965FF}"/>
               </a:ext>
             </a:extLst>
           </p:cNvPr>
@@ -7064,7 +7064,7 @@
           <p:cNvPr id="9" name="">
             <a:extLst xmlns:a="http://schemas.openxmlformats.org/drawingml/2006/main">
               <a:ext uri="{FF2B5EF4-FFF2-40B4-BE49-F238E27FC236}">
-                <a16:creationId xmlns:a16="http://schemas.microsoft.com/office/drawing/2014/main" id="{4586BD25-77FA-4533-A640-E9153A04E35F}"/>
+                <a16:creationId xmlns:a16="http://schemas.microsoft.com/office/drawing/2014/main" id="{B04DC160-02C5-4068-A4F8-3781A23A1E4C}"/>
               </a:ext>
             </a:extLst>
           </p:cNvPr>
@@ -7119,7 +7119,7 @@
     </p:spTree>
     <p:extLst>
       <p:ext uri="{BB962C8B-B14F-4D97-AF65-F5344CB8AC3E}">
-        <p14:creationId xmlns:p14="http://schemas.microsoft.com/office/powerpoint/2010/main" val="841834283"/>
+        <p14:creationId xmlns:p14="http://schemas.microsoft.com/office/powerpoint/2010/main" val="842116807"/>
       </p:ext>
     </p:extLst>
   </p:cSld>
@@ -7150,7 +7150,7 @@
           <p:cNvPr id="8" name="">
             <a:extLst xmlns:a="http://schemas.openxmlformats.org/drawingml/2006/main">
               <a:ext uri="{FF2B5EF4-FFF2-40B4-BE49-F238E27FC236}">
-                <a16:creationId xmlns:a16="http://schemas.microsoft.com/office/drawing/2014/main" id="{42461AAF-F423-4891-9602-4BA16D281DF5}"/>
+                <a16:creationId xmlns:a16="http://schemas.microsoft.com/office/drawing/2014/main" id="{41CD04B5-04CD-4445-A7A2-ABF050D949A5}"/>
               </a:ext>
             </a:extLst>
           </p:cNvPr>
@@ -7207,7 +7207,7 @@
           <p:cNvPr id="2" name="">
             <a:extLst xmlns:a="http://schemas.openxmlformats.org/drawingml/2006/main">
               <a:ext uri="{FF2B5EF4-FFF2-40B4-BE49-F238E27FC236}">
-                <a16:creationId xmlns:a16="http://schemas.microsoft.com/office/drawing/2014/main" id="{8F633B17-95B6-4BE8-9920-CF494D60CC8C}"/>
+                <a16:creationId xmlns:a16="http://schemas.microsoft.com/office/drawing/2014/main" id="{87031196-2DE0-41E9-B3E3-75A6780EFD82}"/>
               </a:ext>
             </a:extLst>
           </p:cNvPr>
@@ -7264,7 +7264,7 @@
           <p:cNvPr id="3" name="">
             <a:extLst xmlns:a="http://schemas.openxmlformats.org/drawingml/2006/main">
               <a:ext uri="{FF2B5EF4-FFF2-40B4-BE49-F238E27FC236}">
-                <a16:creationId xmlns:a16="http://schemas.microsoft.com/office/drawing/2014/main" id="{8B1742DA-107E-4AB3-8CF6-8F65F7B7A7D3}"/>
+                <a16:creationId xmlns:a16="http://schemas.microsoft.com/office/drawing/2014/main" id="{2E1E7897-68E0-4FE6-8507-3881C9A03162}"/>
               </a:ext>
             </a:extLst>
           </p:cNvPr>
@@ -7321,7 +7321,7 @@
           <p:cNvPr id="4" name="">
             <a:extLst xmlns:a="http://schemas.openxmlformats.org/drawingml/2006/main">
               <a:ext uri="{FF2B5EF4-FFF2-40B4-BE49-F238E27FC236}">
-                <a16:creationId xmlns:a16="http://schemas.microsoft.com/office/drawing/2014/main" id="{57977740-B7FB-41CD-9000-BB89525D1437}"/>
+                <a16:creationId xmlns:a16="http://schemas.microsoft.com/office/drawing/2014/main" id="{4485641B-7CD0-4153-B8C4-B67A119BFC3D}"/>
               </a:ext>
             </a:extLst>
           </p:cNvPr>
@@ -7382,7 +7382,7 @@
           <p:nvPr/>
         </p:nvPicPr>
         <p:blipFill>
-          <a:blip xmlns:r="http://schemas.openxmlformats.org/officeDocument/2006/relationships" xmlns:a="http://schemas.openxmlformats.org/drawingml/2006/main" r:embed="R667665bc9e9d4c06"/>
+          <a:blip xmlns:r="http://schemas.openxmlformats.org/officeDocument/2006/relationships" xmlns:a="http://schemas.openxmlformats.org/drawingml/2006/main" r:embed="R36d106b8f7af4b74"/>
           <a:stretch xmlns:a="http://schemas.openxmlformats.org/drawingml/2006/main"/>
         </p:blipFill>
         <p:spPr>
@@ -7400,7 +7400,7 @@
           <p:cNvPr id="6" name="">
             <a:extLst xmlns:a="http://schemas.openxmlformats.org/drawingml/2006/main">
               <a:ext uri="{FF2B5EF4-FFF2-40B4-BE49-F238E27FC236}">
-                <a16:creationId xmlns:a16="http://schemas.microsoft.com/office/drawing/2014/main" id="{8DB392AF-8657-4503-91F0-CA4B89339C22}"/>
+                <a16:creationId xmlns:a16="http://schemas.microsoft.com/office/drawing/2014/main" id="{AB4C1A17-10B5-4CD8-ACA1-97837ACE30E8}"/>
               </a:ext>
             </a:extLst>
           </p:cNvPr>
@@ -7447,7 +7447,7 @@
                 <a:ea typeface="Microsoft JhengHei"/>
                 <a:cs typeface="Microsoft JhengHei"/>
               </a:rPr>
-              <a:t>FDR &lt; 0.10</a:t>
+              <a:t>FDR &lt; 0.05</a:t>
             </a:r>
           </a:p>
           <a:p xmlns:a="http://schemas.openxmlformats.org/drawingml/2006/main">
@@ -7475,7 +7475,7 @@
                 <a:ea typeface="Microsoft JhengHei"/>
                 <a:cs typeface="Microsoft JhengHei"/>
               </a:rPr>
-              <a:t>上調 83 條</a:t>
+              <a:t>上調 61 條</a:t>
             </a:r>
           </a:p>
           <a:p xmlns:a="http://schemas.openxmlformats.org/drawingml/2006/main">
@@ -7498,7 +7498,7 @@
                 <a:ea typeface="Microsoft JhengHei"/>
                 <a:cs typeface="Microsoft JhengHei"/>
               </a:rPr>
-              <a:t>下調 5 條</a:t>
+              <a:t>下調 2 條</a:t>
             </a:r>
           </a:p>
         </p:txBody>
@@ -7508,7 +7508,7 @@
           <p:cNvPr id="7" name="">
             <a:extLst xmlns:a="http://schemas.openxmlformats.org/drawingml/2006/main">
               <a:ext uri="{FF2B5EF4-FFF2-40B4-BE49-F238E27FC236}">
-                <a16:creationId xmlns:a16="http://schemas.microsoft.com/office/drawing/2014/main" id="{C5ACCFD8-D017-4514-8BBB-5866E93FED35}"/>
+                <a16:creationId xmlns:a16="http://schemas.microsoft.com/office/drawing/2014/main" id="{48FA257F-C71E-4958-B7B5-3066DBC2D33F}"/>
               </a:ext>
             </a:extLst>
           </p:cNvPr>
@@ -7555,7 +7555,7 @@
                 <a:ea typeface="Microsoft JhengHei"/>
                 <a:cs typeface="Microsoft JhengHei"/>
               </a:rPr>
-              <a:t>圖依 FDR 排序，沒有預先只挑 mitophagy。完整結果在 Table04。</a:t>
+              <a:t>主圖依 FDR 排序。完整結果在 Table04，顯著清單在 Table11。</a:t>
             </a:r>
           </a:p>
         </p:txBody>
@@ -7563,7 +7563,7 @@
     </p:spTree>
     <p:extLst>
       <p:ext uri="{BB962C8B-B14F-4D97-AF65-F5344CB8AC3E}">
-        <p14:creationId xmlns:p14="http://schemas.microsoft.com/office/powerpoint/2010/main" val="2059000664"/>
+        <p14:creationId xmlns:p14="http://schemas.microsoft.com/office/powerpoint/2010/main" val="1497007802"/>
       </p:ext>
     </p:extLst>
   </p:cSld>
@@ -7594,7 +7594,7 @@
           <p:cNvPr id="8" name="">
             <a:extLst xmlns:a="http://schemas.openxmlformats.org/drawingml/2006/main">
               <a:ext uri="{FF2B5EF4-FFF2-40B4-BE49-F238E27FC236}">
-                <a16:creationId xmlns:a16="http://schemas.microsoft.com/office/drawing/2014/main" id="{EF456B34-CD88-48EE-A756-AA23B8226E38}"/>
+                <a16:creationId xmlns:a16="http://schemas.microsoft.com/office/drawing/2014/main" id="{5585420B-6562-4AD6-AA37-3C0841E2AC8C}"/>
               </a:ext>
             </a:extLst>
           </p:cNvPr>
@@ -7651,7 +7651,7 @@
           <p:cNvPr id="2" name="">
             <a:extLst xmlns:a="http://schemas.openxmlformats.org/drawingml/2006/main">
               <a:ext uri="{FF2B5EF4-FFF2-40B4-BE49-F238E27FC236}">
-                <a16:creationId xmlns:a16="http://schemas.microsoft.com/office/drawing/2014/main" id="{74C41D35-6D40-4B23-BC05-67D6238DA63A}"/>
+                <a16:creationId xmlns:a16="http://schemas.microsoft.com/office/drawing/2014/main" id="{7F224BA5-4DD5-48A7-A96B-49E4D3D686EA}"/>
               </a:ext>
             </a:extLst>
           </p:cNvPr>
@@ -7708,7 +7708,7 @@
           <p:cNvPr id="3" name="">
             <a:extLst xmlns:a="http://schemas.openxmlformats.org/drawingml/2006/main">
               <a:ext uri="{FF2B5EF4-FFF2-40B4-BE49-F238E27FC236}">
-                <a16:creationId xmlns:a16="http://schemas.microsoft.com/office/drawing/2014/main" id="{B180788D-AD72-42A7-958D-CEA95FCDE1E5}"/>
+                <a16:creationId xmlns:a16="http://schemas.microsoft.com/office/drawing/2014/main" id="{5B1CE012-158D-45B1-AD00-EFC3171821E8}"/>
               </a:ext>
             </a:extLst>
           </p:cNvPr>
@@ -7765,7 +7765,7 @@
           <p:cNvPr id="4" name="">
             <a:extLst xmlns:a="http://schemas.openxmlformats.org/drawingml/2006/main">
               <a:ext uri="{FF2B5EF4-FFF2-40B4-BE49-F238E27FC236}">
-                <a16:creationId xmlns:a16="http://schemas.microsoft.com/office/drawing/2014/main" id="{4D70E678-35E7-4EED-A53A-01838DE8FD9D}"/>
+                <a16:creationId xmlns:a16="http://schemas.microsoft.com/office/drawing/2014/main" id="{BCD2D41D-7969-47AC-87CD-BDF247E3A23D}"/>
               </a:ext>
             </a:extLst>
           </p:cNvPr>
@@ -7826,7 +7826,7 @@
           <p:nvPr/>
         </p:nvPicPr>
         <p:blipFill>
-          <a:blip xmlns:r="http://schemas.openxmlformats.org/officeDocument/2006/relationships" xmlns:a="http://schemas.openxmlformats.org/drawingml/2006/main" r:embed="R82e0dafb98dc4516"/>
+          <a:blip xmlns:r="http://schemas.openxmlformats.org/officeDocument/2006/relationships" xmlns:a="http://schemas.openxmlformats.org/drawingml/2006/main" r:embed="R366b61e122d04a50"/>
           <a:stretch xmlns:a="http://schemas.openxmlformats.org/drawingml/2006/main"/>
         </p:blipFill>
         <p:spPr>
@@ -7844,7 +7844,7 @@
           <p:cNvPr id="6" name="">
             <a:extLst xmlns:a="http://schemas.openxmlformats.org/drawingml/2006/main">
               <a:ext uri="{FF2B5EF4-FFF2-40B4-BE49-F238E27FC236}">
-                <a16:creationId xmlns:a16="http://schemas.microsoft.com/office/drawing/2014/main" id="{EF8E344A-4DA3-4A3B-80B2-33044D220FE4}"/>
+                <a16:creationId xmlns:a16="http://schemas.microsoft.com/office/drawing/2014/main" id="{0F21EEF9-5BDC-4BD1-B897-F92658ED9FC7}"/>
               </a:ext>
             </a:extLst>
           </p:cNvPr>
@@ -7891,7 +7891,7 @@
                 <a:ea typeface="Microsoft JhengHei"/>
                 <a:cs typeface="Microsoft JhengHei"/>
               </a:rPr>
-              <a:t>FDR &lt; 0.10</a:t>
+              <a:t>FDR &lt; 0.05</a:t>
             </a:r>
           </a:p>
           <a:p xmlns:a="http://schemas.openxmlformats.org/drawingml/2006/main">
@@ -7919,7 +7919,7 @@
                 <a:ea typeface="Microsoft JhengHei"/>
                 <a:cs typeface="Microsoft JhengHei"/>
               </a:rPr>
-              <a:t>上調 128 條</a:t>
+              <a:t>上調 107 條</a:t>
             </a:r>
           </a:p>
           <a:p xmlns:a="http://schemas.openxmlformats.org/drawingml/2006/main">
@@ -7942,7 +7942,7 @@
                 <a:ea typeface="Microsoft JhengHei"/>
                 <a:cs typeface="Microsoft JhengHei"/>
               </a:rPr>
-              <a:t>下調 8 條</a:t>
+              <a:t>下調 6 條</a:t>
             </a:r>
           </a:p>
         </p:txBody>
@@ -7952,7 +7952,7 @@
           <p:cNvPr id="7" name="">
             <a:extLst xmlns:a="http://schemas.openxmlformats.org/drawingml/2006/main">
               <a:ext uri="{FF2B5EF4-FFF2-40B4-BE49-F238E27FC236}">
-                <a16:creationId xmlns:a16="http://schemas.microsoft.com/office/drawing/2014/main" id="{53A9DAF5-2EFD-405F-A1DA-05F75DAFBEEC}"/>
+                <a16:creationId xmlns:a16="http://schemas.microsoft.com/office/drawing/2014/main" id="{D0EE8720-3CC8-4591-8C7E-AA5DA4FB8CCD}"/>
               </a:ext>
             </a:extLst>
           </p:cNvPr>
@@ -8007,7 +8007,7 @@
     </p:spTree>
     <p:extLst>
       <p:ext uri="{BB962C8B-B14F-4D97-AF65-F5344CB8AC3E}">
-        <p14:creationId xmlns:p14="http://schemas.microsoft.com/office/powerpoint/2010/main" val="257407119"/>
+        <p14:creationId xmlns:p14="http://schemas.microsoft.com/office/powerpoint/2010/main" val="1502474852"/>
       </p:ext>
     </p:extLst>
   </p:cSld>
@@ -8038,7 +8038,7 @@
           <p:cNvPr id="8" name="">
             <a:extLst xmlns:a="http://schemas.openxmlformats.org/drawingml/2006/main">
               <a:ext uri="{FF2B5EF4-FFF2-40B4-BE49-F238E27FC236}">
-                <a16:creationId xmlns:a16="http://schemas.microsoft.com/office/drawing/2014/main" id="{ABFBA07B-0737-498A-B3C1-196D402FDBBA}"/>
+                <a16:creationId xmlns:a16="http://schemas.microsoft.com/office/drawing/2014/main" id="{11BEEBD0-94F0-45E8-A7EE-0F0352A002BF}"/>
               </a:ext>
             </a:extLst>
           </p:cNvPr>
@@ -8095,7 +8095,7 @@
           <p:cNvPr id="2" name="">
             <a:extLst xmlns:a="http://schemas.openxmlformats.org/drawingml/2006/main">
               <a:ext uri="{FF2B5EF4-FFF2-40B4-BE49-F238E27FC236}">
-                <a16:creationId xmlns:a16="http://schemas.microsoft.com/office/drawing/2014/main" id="{058E1832-485A-48B0-B0F0-9A68D4A322D8}"/>
+                <a16:creationId xmlns:a16="http://schemas.microsoft.com/office/drawing/2014/main" id="{CBD6F2B0-CC4F-4435-B351-BC77803F5F04}"/>
               </a:ext>
             </a:extLst>
           </p:cNvPr>
@@ -8142,7 +8142,7 @@
                 <a:ea typeface="Microsoft JhengHei"/>
                 <a:cs typeface="Microsoft JhengHei"/>
               </a:rPr>
-              <a:t>先看同方向 pathway 交集</a:t>
+              <a:t>同方向 pathway 交集</a:t>
             </a:r>
           </a:p>
         </p:txBody>
@@ -8152,7 +8152,7 @@
           <p:cNvPr id="3" name="">
             <a:extLst xmlns:a="http://schemas.openxmlformats.org/drawingml/2006/main">
               <a:ext uri="{FF2B5EF4-FFF2-40B4-BE49-F238E27FC236}">
-                <a16:creationId xmlns:a16="http://schemas.microsoft.com/office/drawing/2014/main" id="{094C2F5F-B061-4675-8E8A-70FF1131C038}"/>
+                <a16:creationId xmlns:a16="http://schemas.microsoft.com/office/drawing/2014/main" id="{D2580DD0-8BCC-44DD-8E6B-60CB6298F1EB}"/>
               </a:ext>
             </a:extLst>
           </p:cNvPr>
@@ -8209,7 +8209,7 @@
           <p:cNvPr id="4" name="">
             <a:extLst xmlns:a="http://schemas.openxmlformats.org/drawingml/2006/main">
               <a:ext uri="{FF2B5EF4-FFF2-40B4-BE49-F238E27FC236}">
-                <a16:creationId xmlns:a16="http://schemas.microsoft.com/office/drawing/2014/main" id="{05BC2725-7318-4ED4-A8D9-3A3C476F67C8}"/>
+                <a16:creationId xmlns:a16="http://schemas.microsoft.com/office/drawing/2014/main" id="{AB6E04EB-E947-4F2E-BEAF-49C277A31268}"/>
               </a:ext>
             </a:extLst>
           </p:cNvPr>
@@ -8270,13 +8270,13 @@
           <p:nvPr/>
         </p:nvPicPr>
         <p:blipFill>
-          <a:blip xmlns:r="http://schemas.openxmlformats.org/officeDocument/2006/relationships" xmlns:a="http://schemas.openxmlformats.org/drawingml/2006/main" r:embed="R01ed2fedac68481d"/>
+          <a:blip xmlns:r="http://schemas.openxmlformats.org/officeDocument/2006/relationships" xmlns:a="http://schemas.openxmlformats.org/drawingml/2006/main" r:embed="Rdbe2b0facf844927"/>
           <a:stretch xmlns:a="http://schemas.openxmlformats.org/drawingml/2006/main"/>
         </p:blipFill>
         <p:spPr>
           <a:xfrm xmlns:a="http://schemas.openxmlformats.org/drawingml/2006/main">
-            <a:off x="1539666" y="1038225"/>
-            <a:ext cx="6350418" cy="5362575"/>
+            <a:off x="333375" y="1381125"/>
+            <a:ext cx="8763000" cy="4381500"/>
           </a:xfrm>
           <a:prstGeom xmlns:a="http://schemas.openxmlformats.org/drawingml/2006/main" prst="rect">
             <a:avLst/>
@@ -8288,7 +8288,7 @@
           <p:cNvPr id="6" name="">
             <a:extLst xmlns:a="http://schemas.openxmlformats.org/drawingml/2006/main">
               <a:ext uri="{FF2B5EF4-FFF2-40B4-BE49-F238E27FC236}">
-                <a16:creationId xmlns:a16="http://schemas.microsoft.com/office/drawing/2014/main" id="{FCBA34F6-98B2-4490-8653-09B37489988A}"/>
+                <a16:creationId xmlns:a16="http://schemas.microsoft.com/office/drawing/2014/main" id="{F3CC6C2C-3BAD-419E-8D01-FDE1EB7AC304}"/>
               </a:ext>
             </a:extLst>
           </p:cNvPr>
@@ -8363,7 +8363,7 @@
                 <a:ea typeface="Microsoft JhengHei"/>
                 <a:cs typeface="Microsoft JhengHei"/>
               </a:rPr>
-              <a:t>共同上調 54 條</a:t>
+              <a:t>共同上調 40 條</a:t>
             </a:r>
           </a:p>
           <a:p xmlns:a="http://schemas.openxmlformats.org/drawingml/2006/main">
@@ -8396,7 +8396,7 @@
           <p:cNvPr id="7" name="">
             <a:extLst xmlns:a="http://schemas.openxmlformats.org/drawingml/2006/main">
               <a:ext uri="{FF2B5EF4-FFF2-40B4-BE49-F238E27FC236}">
-                <a16:creationId xmlns:a16="http://schemas.microsoft.com/office/drawing/2014/main" id="{58871E48-9A76-439B-8DA9-CA66AC485F80}"/>
+                <a16:creationId xmlns:a16="http://schemas.microsoft.com/office/drawing/2014/main" id="{97EADBA2-9B4E-4212-8C4A-68360E225BC5}"/>
               </a:ext>
             </a:extLst>
           </p:cNvPr>
@@ -8466,7 +8466,7 @@
                 <a:ea typeface="Microsoft JhengHei"/>
                 <a:cs typeface="Microsoft JhengHei"/>
               </a:rPr>
-              <a:t>兩邊都需 FDR &lt; 0.10，且 NES 同號。</a:t>
+              <a:t>兩邊都需 FDR &lt; 0.05，且 NES 同號。</a:t>
             </a:r>
           </a:p>
           <a:p xmlns:a="http://schemas.openxmlformats.org/drawingml/2006/main">
@@ -8494,7 +8494,7 @@
                 <a:ea typeface="Microsoft JhengHei"/>
                 <a:cs typeface="Microsoft JhengHei"/>
               </a:rPr>
-              <a:t>下排保留原始 top 25% 對照。</a:t>
+              <a:t>其他 cutoff 與原始 top 25% 放在補充分析。</a:t>
             </a:r>
           </a:p>
         </p:txBody>
@@ -8502,7 +8502,7 @@
     </p:spTree>
     <p:extLst>
       <p:ext uri="{BB962C8B-B14F-4D97-AF65-F5344CB8AC3E}">
-        <p14:creationId xmlns:p14="http://schemas.microsoft.com/office/powerpoint/2010/main" val="1499049048"/>
+        <p14:creationId xmlns:p14="http://schemas.microsoft.com/office/powerpoint/2010/main" val="1831706074"/>
       </p:ext>
     </p:extLst>
   </p:cSld>
@@ -8533,7 +8533,7 @@
           <p:cNvPr id="6" name="">
             <a:extLst xmlns:a="http://schemas.openxmlformats.org/drawingml/2006/main">
               <a:ext uri="{FF2B5EF4-FFF2-40B4-BE49-F238E27FC236}">
-                <a16:creationId xmlns:a16="http://schemas.microsoft.com/office/drawing/2014/main" id="{74F4C97A-DCB2-4A9F-82EF-61F4ED0F508B}"/>
+                <a16:creationId xmlns:a16="http://schemas.microsoft.com/office/drawing/2014/main" id="{8A70EF99-7DD2-468C-B6E2-8966A3306C3B}"/>
               </a:ext>
             </a:extLst>
           </p:cNvPr>
@@ -8590,7 +8590,7 @@
           <p:cNvPr id="2" name="">
             <a:extLst xmlns:a="http://schemas.openxmlformats.org/drawingml/2006/main">
               <a:ext uri="{FF2B5EF4-FFF2-40B4-BE49-F238E27FC236}">
-                <a16:creationId xmlns:a16="http://schemas.microsoft.com/office/drawing/2014/main" id="{899E793D-6341-4C9B-8DF6-9B34856806D9}"/>
+                <a16:creationId xmlns:a16="http://schemas.microsoft.com/office/drawing/2014/main" id="{D9C6E819-3921-4805-81E8-14F91803176A}"/>
               </a:ext>
             </a:extLst>
           </p:cNvPr>
@@ -8647,7 +8647,7 @@
           <p:cNvPr id="3" name="">
             <a:extLst xmlns:a="http://schemas.openxmlformats.org/drawingml/2006/main">
               <a:ext uri="{FF2B5EF4-FFF2-40B4-BE49-F238E27FC236}">
-                <a16:creationId xmlns:a16="http://schemas.microsoft.com/office/drawing/2014/main" id="{9ABBF5DD-5D6F-4651-84E8-9BEADBEBEAC9}"/>
+                <a16:creationId xmlns:a16="http://schemas.microsoft.com/office/drawing/2014/main" id="{A7823722-F1B2-44F5-BEA2-74CC8E95C381}"/>
               </a:ext>
             </a:extLst>
           </p:cNvPr>
@@ -8704,7 +8704,7 @@
           <p:cNvPr id="4" name="">
             <a:extLst xmlns:a="http://schemas.openxmlformats.org/drawingml/2006/main">
               <a:ext uri="{FF2B5EF4-FFF2-40B4-BE49-F238E27FC236}">
-                <a16:creationId xmlns:a16="http://schemas.microsoft.com/office/drawing/2014/main" id="{D28D0706-0B17-4049-8DDC-55BCCA2F3D46}"/>
+                <a16:creationId xmlns:a16="http://schemas.microsoft.com/office/drawing/2014/main" id="{82BA95E4-B578-4F9A-B433-027904FB0ABB}"/>
               </a:ext>
             </a:extLst>
           </p:cNvPr>
@@ -8765,7 +8765,7 @@
           <p:nvPr/>
         </p:nvPicPr>
         <p:blipFill>
-          <a:blip xmlns:r="http://schemas.openxmlformats.org/officeDocument/2006/relationships" xmlns:a="http://schemas.openxmlformats.org/drawingml/2006/main" r:embed="Rad93e427406f497f"/>
+          <a:blip xmlns:r="http://schemas.openxmlformats.org/officeDocument/2006/relationships" xmlns:a="http://schemas.openxmlformats.org/drawingml/2006/main" r:embed="R50fb8ae6ac74409d"/>
           <a:stretch xmlns:a="http://schemas.openxmlformats.org/drawingml/2006/main"/>
         </p:blipFill>
         <p:spPr>
@@ -8781,7 +8781,7 @@
     </p:spTree>
     <p:extLst>
       <p:ext uri="{BB962C8B-B14F-4D97-AF65-F5344CB8AC3E}">
-        <p14:creationId xmlns:p14="http://schemas.microsoft.com/office/powerpoint/2010/main" val="1828861557"/>
+        <p14:creationId xmlns:p14="http://schemas.microsoft.com/office/powerpoint/2010/main" val="1542495709"/>
       </p:ext>
     </p:extLst>
   </p:cSld>

</xml_diff>

<commit_message>
Redraw all40 shared KEGG pathways and synchronize handoff slides
</commit_message>
<xml_diff>
--- a/projects/GSE262271_TALL_relapse_scRNAseq/07_Student_Handoff/01_Summary/Leukemia_scRNAseq_STAT5B_reviewed.pptx
+++ b/projects/GSE262271_TALL_relapse_scRNAseq/07_Student_Handoff/01_Summary/Leukemia_scRNAseq_STAT5B_reviewed.pptx
@@ -2,26 +2,27 @@
 <file path=ppt/presentation.xml><?xml version="1.0" encoding="utf-8"?>
 <p:presentation xmlns:p="http://schemas.openxmlformats.org/presentationml/2006/main">
   <p:sldMasterIdLst>
-    <p:sldMasterId xmlns:r="http://schemas.openxmlformats.org/officeDocument/2006/relationships" id="2147483648" r:id="R17a29904a7e34fe2"/>
+    <p:sldMasterId xmlns:r="http://schemas.openxmlformats.org/officeDocument/2006/relationships" id="2147483648" r:id="R7c6c7086868e4eba"/>
   </p:sldMasterIdLst>
   <p:notesMasterIdLst>
-    <p:notesMasterId xmlns:r="http://schemas.openxmlformats.org/officeDocument/2006/relationships" r:id="Rc89f8f8522f54fba"/>
+    <p:notesMasterId xmlns:r="http://schemas.openxmlformats.org/officeDocument/2006/relationships" r:id="Rdb32df5b10ae4582"/>
   </p:notesMasterIdLst>
   <p:sldIdLst>
-    <p:sldId xmlns:r="http://schemas.openxmlformats.org/officeDocument/2006/relationships" id="256" r:id="R5f60c4c641da4cd4"/>
-    <p:sldId xmlns:r="http://schemas.openxmlformats.org/officeDocument/2006/relationships" id="257" r:id="Rb9f0b3cf3e2948d9"/>
-    <p:sldId xmlns:r="http://schemas.openxmlformats.org/officeDocument/2006/relationships" id="258" r:id="Re2de27cb1ef2427c"/>
-    <p:sldId xmlns:r="http://schemas.openxmlformats.org/officeDocument/2006/relationships" id="259" r:id="R7317dfb164c948e2"/>
-    <p:sldId xmlns:r="http://schemas.openxmlformats.org/officeDocument/2006/relationships" id="260" r:id="R47d507ef7ccf4b49"/>
-    <p:sldId xmlns:r="http://schemas.openxmlformats.org/officeDocument/2006/relationships" id="261" r:id="R005ab2211d4b404c"/>
-    <p:sldId xmlns:r="http://schemas.openxmlformats.org/officeDocument/2006/relationships" id="262" r:id="Ra415a6cf4b6c4d4d"/>
-    <p:sldId xmlns:r="http://schemas.openxmlformats.org/officeDocument/2006/relationships" id="263" r:id="Rb424d6403ddd4ace"/>
-    <p:sldId xmlns:r="http://schemas.openxmlformats.org/officeDocument/2006/relationships" id="264" r:id="R08eaef45b97842b9"/>
-    <p:sldId xmlns:r="http://schemas.openxmlformats.org/officeDocument/2006/relationships" id="265" r:id="Rdbb11098723946d1"/>
-    <p:sldId xmlns:r="http://schemas.openxmlformats.org/officeDocument/2006/relationships" id="266" r:id="Rb7a87ab838614feb"/>
-    <p:sldId xmlns:r="http://schemas.openxmlformats.org/officeDocument/2006/relationships" id="267" r:id="Re9f330a615234426"/>
-    <p:sldId xmlns:r="http://schemas.openxmlformats.org/officeDocument/2006/relationships" id="268" r:id="R4b6d1588762b407f"/>
-    <p:sldId xmlns:r="http://schemas.openxmlformats.org/officeDocument/2006/relationships" id="269" r:id="Rcd730057a98f43b3"/>
+    <p:sldId xmlns:r="http://schemas.openxmlformats.org/officeDocument/2006/relationships" id="256" r:id="R64e882b4751a4568"/>
+    <p:sldId xmlns:r="http://schemas.openxmlformats.org/officeDocument/2006/relationships" id="257" r:id="Re738212d4ff94b28"/>
+    <p:sldId xmlns:r="http://schemas.openxmlformats.org/officeDocument/2006/relationships" id="258" r:id="Ref3cb69697354ddf"/>
+    <p:sldId xmlns:r="http://schemas.openxmlformats.org/officeDocument/2006/relationships" id="259" r:id="R5a351d7f7c484907"/>
+    <p:sldId xmlns:r="http://schemas.openxmlformats.org/officeDocument/2006/relationships" id="260" r:id="R6856b2e685384d7f"/>
+    <p:sldId xmlns:r="http://schemas.openxmlformats.org/officeDocument/2006/relationships" id="261" r:id="R7c1c2bc854e54a00"/>
+    <p:sldId xmlns:r="http://schemas.openxmlformats.org/officeDocument/2006/relationships" id="262" r:id="R83b2088941524f63"/>
+    <p:sldId xmlns:r="http://schemas.openxmlformats.org/officeDocument/2006/relationships" id="263" r:id="R8ef5c3e5c1014c04"/>
+    <p:sldId xmlns:r="http://schemas.openxmlformats.org/officeDocument/2006/relationships" id="264" r:id="R59bac43f2caa4213"/>
+    <p:sldId xmlns:r="http://schemas.openxmlformats.org/officeDocument/2006/relationships" id="265" r:id="R22dc68c251bc4425"/>
+    <p:sldId xmlns:r="http://schemas.openxmlformats.org/officeDocument/2006/relationships" id="266" r:id="Rc364a3d5dbbe400b"/>
+    <p:sldId xmlns:r="http://schemas.openxmlformats.org/officeDocument/2006/relationships" id="267" r:id="Rc370e7c0d8974607"/>
+    <p:sldId xmlns:r="http://schemas.openxmlformats.org/officeDocument/2006/relationships" id="268" r:id="R7562d54a582045db"/>
+    <p:sldId xmlns:r="http://schemas.openxmlformats.org/officeDocument/2006/relationships" id="269" r:id="R039c8bc954f44473"/>
+    <p:sldId xmlns:r="http://schemas.openxmlformats.org/officeDocument/2006/relationships" id="270" r:id="R95706312c62f4dc7"/>
   </p:sldIdLst>
   <p:sldSz cx="12192000" cy="6858000"/>
   <p:notesSz cx="6858000" cy="9144000"/>
@@ -525,7 +526,7 @@
           <a:lstStyle xmlns:a="http://schemas.openxmlformats.org/drawingml/2006/main"/>
           <a:p xmlns:a="http://schemas.openxmlformats.org/drawingml/2006/main">
             <a:r>
-              <a:t>Numeric results are read from regenerated tables, not hard-coded historical values. q means whole KEGG BH, not nominal P or two-target correction. Within15 is exploratory because cutoff was selected after multiverse results.</a:t>
+              <a:t>Continuation of the complete40-pathway intersection. Both datasets use full-collection BH FDR&lt;0.05. Positive NES means higher in relapse (left) or N642H (right). scRNAseq Proteasome FDR=0.00837925505996343, Mitophagy=0.0131970176091592; bulk Proteasome=0.00107780111297412, Mitophagy=0.028233910102446. Disease/infection-labeled gene sets do not establish those diagnoses. Abbreviated display labels retain exact original names in Table07.</a:t>
             </a:r>
           </a:p>
         </p:txBody>
@@ -595,7 +596,7 @@
           <a:lstStyle xmlns:a="http://schemas.openxmlformats.org/drawingml/2006/main"/>
           <a:p xmlns:a="http://schemas.openxmlformats.org/drawingml/2006/main">
             <a:r>
-              <a:t>Three patients limit inference. A gene need not rise in all three pairs for fitting a paired model. Gene-level DEG FDR and gene-set GSEA FDR answer different hypotheses.</a:t>
+              <a:t>Numeric results are read from regenerated tables, not hard-coded historical values. q means whole KEGG BH, not nominal P or two-target correction. Within15 is exploratory because cutoff was selected after multiverse results.</a:t>
             </a:r>
           </a:p>
         </p:txBody>
@@ -665,7 +666,7 @@
           <a:lstStyle xmlns:a="http://schemas.openxmlformats.org/drawingml/2006/main"/>
           <a:p xmlns:a="http://schemas.openxmlformats.org/drawingml/2006/main">
             <a:r>
-              <a:t>inferCNV score is RNA-based deviation from reference, not measured DNA copy number, a probability of cancer, or a patient-independent validated specificity threshold. Reference sample/cell-type composition is unbalanced. Official workflow: https://github.com/broadinstitute/inferCNV/wiki/Running-InferCNV</a:t>
+              <a:t>Three patients limit inference. A gene need not rise in all three pairs for fitting a paired model. Gene-level DEG FDR and gene-set GSEA FDR answer different hypotheses.</a:t>
             </a:r>
           </a:p>
         </p:txBody>
@@ -735,7 +736,7 @@
           <a:lstStyle xmlns:a="http://schemas.openxmlformats.org/drawingml/2006/main"/>
           <a:p xmlns:a="http://schemas.openxmlformats.org/drawingml/2006/main">
             <a:r>
-              <a:t>These are limits of the actual contrasts. General autophagy is not interchangeable with mitophagy. Inspect shared leading-edge genes and full FDR tables before choosing individual targets.</a:t>
+              <a:t>inferCNV score is RNA-based deviation from reference, not measured DNA copy number, a probability of cancer, or a patient-independent validated specificity threshold. Reference sample/cell-type composition is unbalanced. Official workflow: https://github.com/broadinstitute/inferCNV/wiki/Running-InferCNV</a:t>
             </a:r>
           </a:p>
         </p:txBody>
@@ -805,6 +806,76 @@
           <a:lstStyle xmlns:a="http://schemas.openxmlformats.org/drawingml/2006/main"/>
           <a:p xmlns:a="http://schemas.openxmlformats.org/drawingml/2006/main">
             <a:r>
+              <a:t>These are limits of the actual contrasts. General autophagy is not interchangeable with mitophagy. Inspect shared leading-edge genes and full FDR tables before choosing individual targets.</a:t>
+            </a:r>
+          </a:p>
+        </p:txBody>
+      </p:sp>
+      <p:sp>
+        <p:nvSpPr>
+          <p:cNvPr id="4" name="Slide Number Placeholder 3"/>
+          <p:cNvSpPr>
+            <a:spLocks xmlns:a="http://schemas.openxmlformats.org/drawingml/2006/main" noGrp="1"/>
+          </p:cNvSpPr>
+          <p:nvPr>
+            <p:ph type="sldNum" idx="5"/>
+          </p:nvPr>
+        </p:nvSpPr>
+        <p:spPr/>
+        <p:txBody>
+          <a:bodyPr xmlns:a="http://schemas.openxmlformats.org/drawingml/2006/main"/>
+          <a:lstStyle xmlns:a="http://schemas.openxmlformats.org/drawingml/2006/main"/>
+          <a:p xmlns:a="http://schemas.openxmlformats.org/drawingml/2006/main"/>
+        </p:txBody>
+      </p:sp>
+    </p:spTree>
+  </p:cSld>
+  <p:clrMapOvr>
+    <a:masterClrMapping xmlns:a="http://schemas.openxmlformats.org/drawingml/2006/main"/>
+  </p:clrMapOvr>
+</p:notes>
+</file>
+
+<file path=ppt/notesSlides/notesSlide15.xml><?xml version="1.0" encoding="utf-8"?>
+<p:notes xmlns:p="http://schemas.openxmlformats.org/presentationml/2006/main">
+  <p:cSld>
+    <p:spTree>
+      <p:nvGrpSpPr>
+        <p:cNvPr id="1" name=""/>
+        <p:cNvGrpSpPr/>
+        <p:nvPr/>
+      </p:nvGrpSpPr>
+      <p:grpSpPr>
+        <a:xfrm xmlns:a="http://schemas.openxmlformats.org/drawingml/2006/main"/>
+      </p:grpSpPr>
+      <p:sp>
+        <p:nvSpPr>
+          <p:cNvPr id="2" name="Slide Image Placeholder 1"/>
+          <p:cNvSpPr>
+            <a:spLocks xmlns:a="http://schemas.openxmlformats.org/drawingml/2006/main" noGrp="1"/>
+          </p:cNvSpPr>
+          <p:nvPr>
+            <p:ph type="sldImg" idx="0"/>
+          </p:nvPr>
+        </p:nvSpPr>
+        <p:spPr/>
+      </p:sp>
+      <p:sp>
+        <p:nvSpPr>
+          <p:cNvPr id="3" name="Notes Placeholder 2"/>
+          <p:cNvSpPr>
+            <a:spLocks xmlns:a="http://schemas.openxmlformats.org/drawingml/2006/main" noGrp="1"/>
+          </p:cNvSpPr>
+          <p:nvPr>
+            <p:ph type="body" idx="1"/>
+          </p:nvPr>
+        </p:nvSpPr>
+        <p:spPr/>
+        <p:txBody>
+          <a:bodyPr xmlns:a="http://schemas.openxmlformats.org/drawingml/2006/main"/>
+          <a:lstStyle xmlns:a="http://schemas.openxmlformats.org/drawingml/2006/main"/>
+          <a:p xmlns:a="http://schemas.openxmlformats.org/drawingml/2006/main">
+            <a:r>
               <a:t>Code22 recomputes count-based models and high-precision GSEA. Code23 renders reader figures/tables. The audit reports historical discrepancies rather than silently replacing provenance. No raw data, patient identifiers or large R objects are uploaded.</a:t>
             </a:r>
           </a:p>
@@ -1365,7 +1436,7 @@
           <a:lstStyle xmlns:a="http://schemas.openxmlformats.org/drawingml/2006/main"/>
           <a:p xmlns:a="http://schemas.openxmlformats.org/drawingml/2006/main">
             <a:r>
-              <a:t>All same-direction intersections are provided in Table07 and full Figure06. This slide shows at most15 pathways ranked by the worse FDR across the two datasets, not a target-selected list. Each tile contains NES and whole-collection significance.</a:t>
+              <a:t>Table07 and complete Figure06 use exactly the same order: increasing max(sc_FDR, bulk_FDR), with alphabetical pathway-name ties. The maximum is a display ordering key, not a combined FDR. Position indicates NES; color indicates full-catalog BH FDR on a -log10 scale capped at6. All40 satisfy FDR&lt;0.05 in both datasets. Bold labels identify hypothesis targets without changing ordering. Layout reference: Reis-de-Oliveira et al., Nature Communications (2024), Figures3B and4D, https://www.nature.com/articles/s41467-024-50875-z . Only the plot layout is adapted; the reference article uses other enrichment statistics.</a:t>
             </a:r>
           </a:p>
         </p:txBody>
@@ -1433,7 +1504,7 @@
   </p:cSld>
   <p:clrMap bg1="lt1" tx1="dk1" bg2="lt2" tx2="dk2" accent1="accent1" accent2="accent2" accent3="accent3" accent4="accent4" accent5="accent5" accent6="accent6" hlink="hlink" folHlink="folHlink"/>
   <p:sldLayoutIdLst>
-    <p:sldLayoutId xmlns:r="http://schemas.openxmlformats.org/officeDocument/2006/relationships" id="2147483649" r:id="R484a6def0a1f47ac"/>
+    <p:sldLayoutId xmlns:r="http://schemas.openxmlformats.org/officeDocument/2006/relationships" id="2147483649" r:id="Rcdb8ce7ff1fc401f"/>
   </p:sldLayoutIdLst>
   <p:txStyles>
     <p:titleStyle>
@@ -1984,7 +2055,7 @@
           <p:cNvPr id="9" name="">
             <a:extLst xmlns:a="http://schemas.openxmlformats.org/drawingml/2006/main">
               <a:ext uri="{FF2B5EF4-FFF2-40B4-BE49-F238E27FC236}">
-                <a16:creationId xmlns:a16="http://schemas.microsoft.com/office/drawing/2014/main" id="{91E6CCD2-64CB-4CF5-8FFF-3B6F4AE356E8}"/>
+                <a16:creationId xmlns:a16="http://schemas.microsoft.com/office/drawing/2014/main" id="{6F224678-8C24-4F87-9716-A5EE6242E567}"/>
               </a:ext>
             </a:extLst>
           </p:cNvPr>
@@ -2041,7 +2112,7 @@
           <p:cNvPr id="2" name="">
             <a:extLst xmlns:a="http://schemas.openxmlformats.org/drawingml/2006/main">
               <a:ext uri="{FF2B5EF4-FFF2-40B4-BE49-F238E27FC236}">
-                <a16:creationId xmlns:a16="http://schemas.microsoft.com/office/drawing/2014/main" id="{7C4495CA-8855-41A1-883D-F5C67CAC1CB9}"/>
+                <a16:creationId xmlns:a16="http://schemas.microsoft.com/office/drawing/2014/main" id="{122D88E6-AA0E-4C5F-8A23-E23046F0663F}"/>
               </a:ext>
             </a:extLst>
           </p:cNvPr>
@@ -2098,7 +2169,7 @@
           <p:cNvPr id="3" name="">
             <a:extLst xmlns:a="http://schemas.openxmlformats.org/drawingml/2006/main">
               <a:ext uri="{FF2B5EF4-FFF2-40B4-BE49-F238E27FC236}">
-                <a16:creationId xmlns:a16="http://schemas.microsoft.com/office/drawing/2014/main" id="{E23FD51F-4C69-4A5E-91DD-2AD394910338}"/>
+                <a16:creationId xmlns:a16="http://schemas.microsoft.com/office/drawing/2014/main" id="{65A36042-BEBA-46ED-A3BF-FACFF76487EB}"/>
               </a:ext>
             </a:extLst>
           </p:cNvPr>
@@ -2155,7 +2226,7 @@
           <p:cNvPr id="4" name="">
             <a:extLst xmlns:a="http://schemas.openxmlformats.org/drawingml/2006/main">
               <a:ext uri="{FF2B5EF4-FFF2-40B4-BE49-F238E27FC236}">
-                <a16:creationId xmlns:a16="http://schemas.microsoft.com/office/drawing/2014/main" id="{5171ECF3-CA9D-4DF3-9A0B-C8FF76109732}"/>
+                <a16:creationId xmlns:a16="http://schemas.microsoft.com/office/drawing/2014/main" id="{81F97B9C-E2A5-43CB-95DA-5D23850B34A5}"/>
               </a:ext>
             </a:extLst>
           </p:cNvPr>
@@ -2212,7 +2283,7 @@
           <p:cNvPr id="5" name="">
             <a:extLst xmlns:a="http://schemas.openxmlformats.org/drawingml/2006/main">
               <a:ext uri="{FF2B5EF4-FFF2-40B4-BE49-F238E27FC236}">
-                <a16:creationId xmlns:a16="http://schemas.microsoft.com/office/drawing/2014/main" id="{80B564FF-33D8-48D4-9435-B6A225DA249F}"/>
+                <a16:creationId xmlns:a16="http://schemas.microsoft.com/office/drawing/2014/main" id="{57C1A7F6-574B-469D-8FDB-5F674B6C73AC}"/>
               </a:ext>
             </a:extLst>
           </p:cNvPr>
@@ -2269,7 +2340,7 @@
           <p:cNvPr id="6" name="">
             <a:extLst xmlns:a="http://schemas.openxmlformats.org/drawingml/2006/main">
               <a:ext uri="{FF2B5EF4-FFF2-40B4-BE49-F238E27FC236}">
-                <a16:creationId xmlns:a16="http://schemas.microsoft.com/office/drawing/2014/main" id="{D5C9457E-489D-4013-810B-050DD8BCE50E}"/>
+                <a16:creationId xmlns:a16="http://schemas.microsoft.com/office/drawing/2014/main" id="{C8BC944C-3F0C-48B4-9950-1211FC761091}"/>
               </a:ext>
             </a:extLst>
           </p:cNvPr>
@@ -2326,7 +2397,7 @@
           <p:cNvPr id="7" name="">
             <a:extLst xmlns:a="http://schemas.openxmlformats.org/drawingml/2006/main">
               <a:ext uri="{FF2B5EF4-FFF2-40B4-BE49-F238E27FC236}">
-                <a16:creationId xmlns:a16="http://schemas.microsoft.com/office/drawing/2014/main" id="{13FFD5BF-1F61-4284-B90C-F642024AC01E}"/>
+                <a16:creationId xmlns:a16="http://schemas.microsoft.com/office/drawing/2014/main" id="{0279CE60-8AED-4E8A-8155-174922105606}"/>
               </a:ext>
             </a:extLst>
           </p:cNvPr>
@@ -2406,7 +2477,7 @@
           <p:cNvPr id="8" name="">
             <a:extLst xmlns:a="http://schemas.openxmlformats.org/drawingml/2006/main">
               <a:ext uri="{FF2B5EF4-FFF2-40B4-BE49-F238E27FC236}">
-                <a16:creationId xmlns:a16="http://schemas.microsoft.com/office/drawing/2014/main" id="{88D95EB9-C8F0-4256-BB11-BA59D12168D5}"/>
+                <a16:creationId xmlns:a16="http://schemas.microsoft.com/office/drawing/2014/main" id="{7EB7DFBE-A3FA-42E0-A525-5991A038F32F}"/>
               </a:ext>
             </a:extLst>
           </p:cNvPr>
@@ -2461,7 +2532,7 @@
     </p:spTree>
     <p:extLst>
       <p:ext uri="{BB962C8B-B14F-4D97-AF65-F5344CB8AC3E}">
-        <p14:creationId xmlns:p14="http://schemas.microsoft.com/office/powerpoint/2010/main" val="1423246754"/>
+        <p14:creationId xmlns:p14="http://schemas.microsoft.com/office/powerpoint/2010/main" val="770387514"/>
       </p:ext>
     </p:extLst>
   </p:cSld>
@@ -2492,7 +2563,7 @@
           <p:cNvPr id="7" name="">
             <a:extLst xmlns:a="http://schemas.openxmlformats.org/drawingml/2006/main">
               <a:ext uri="{FF2B5EF4-FFF2-40B4-BE49-F238E27FC236}">
-                <a16:creationId xmlns:a16="http://schemas.microsoft.com/office/drawing/2014/main" id="{1506798B-E2B7-4D0A-B89A-B8DB57C3AFB3}"/>
+                <a16:creationId xmlns:a16="http://schemas.microsoft.com/office/drawing/2014/main" id="{825A1070-2C9E-44C1-B90B-BEB0EA9639C1}"/>
               </a:ext>
             </a:extLst>
           </p:cNvPr>
@@ -2539,7 +2610,7 @@
                 <a:ea typeface="Microsoft JhengHei"/>
                 <a:cs typeface="Microsoft JhengHei"/>
               </a:rPr>
-              <a:t>TARGET PATHWAYS</a:t>
+              <a:t>SHARED PROGRAMS</a:t>
             </a:r>
           </a:p>
         </p:txBody>
@@ -2549,7 +2620,7 @@
           <p:cNvPr id="2" name="">
             <a:extLst xmlns:a="http://schemas.openxmlformats.org/drawingml/2006/main">
               <a:ext uri="{FF2B5EF4-FFF2-40B4-BE49-F238E27FC236}">
-                <a16:creationId xmlns:a16="http://schemas.microsoft.com/office/drawing/2014/main" id="{322AD55F-4621-40A3-94F4-A56C980EF2D3}"/>
+                <a16:creationId xmlns:a16="http://schemas.microsoft.com/office/drawing/2014/main" id="{8035CBBB-1CDC-421E-841C-5FC30B4FE5C8}"/>
               </a:ext>
             </a:extLst>
           </p:cNvPr>
@@ -2596,7 +2667,7 @@
                 <a:ea typeface="Microsoft JhengHei"/>
                 <a:cs typeface="Microsoft JhengHei"/>
               </a:rPr>
-              <a:t>Proteasome 與 mitophagy 的結果核對</a:t>
+              <a:t>40 條共同上調 pathway：第 21–40 條</a:t>
             </a:r>
           </a:p>
         </p:txBody>
@@ -2606,7 +2677,7 @@
           <p:cNvPr id="3" name="">
             <a:extLst xmlns:a="http://schemas.openxmlformats.org/drawingml/2006/main">
               <a:ext uri="{FF2B5EF4-FFF2-40B4-BE49-F238E27FC236}">
-                <a16:creationId xmlns:a16="http://schemas.microsoft.com/office/drawing/2014/main" id="{95820BA2-F3C6-4C8A-AABB-F0D889B99201}"/>
+                <a16:creationId xmlns:a16="http://schemas.microsoft.com/office/drawing/2014/main" id="{36F1A355-FAA6-443D-9F5C-028F2B274F5E}"/>
               </a:ext>
             </a:extLst>
           </p:cNvPr>
@@ -2663,7 +2734,7 @@
           <p:cNvPr id="4" name="">
             <a:extLst xmlns:a="http://schemas.openxmlformats.org/drawingml/2006/main">
               <a:ext uri="{FF2B5EF4-FFF2-40B4-BE49-F238E27FC236}">
-                <a16:creationId xmlns:a16="http://schemas.microsoft.com/office/drawing/2014/main" id="{28C3B606-FF48-4635-8410-518A9A3BF68E}"/>
+                <a16:creationId xmlns:a16="http://schemas.microsoft.com/office/drawing/2014/main" id="{D78F14E2-07AD-4036-AF80-246D46842A42}"/>
               </a:ext>
             </a:extLst>
           </p:cNvPr>
@@ -2724,13 +2795,13 @@
           <p:nvPr/>
         </p:nvPicPr>
         <p:blipFill>
-          <a:blip xmlns:r="http://schemas.openxmlformats.org/officeDocument/2006/relationships" xmlns:a="http://schemas.openxmlformats.org/drawingml/2006/main" r:embed="R2ebcdfadf305483f"/>
+          <a:blip xmlns:r="http://schemas.openxmlformats.org/officeDocument/2006/relationships" xmlns:a="http://schemas.openxmlformats.org/drawingml/2006/main" r:embed="R4b279703e6344050"/>
           <a:stretch xmlns:a="http://schemas.openxmlformats.org/drawingml/2006/main"/>
         </p:blipFill>
         <p:spPr>
           <a:xfrm xmlns:a="http://schemas.openxmlformats.org/drawingml/2006/main">
-            <a:off x="2122289" y="1362075"/>
-            <a:ext cx="7947422" cy="4238625"/>
+            <a:off x="1262884" y="1028700"/>
+            <a:ext cx="9666233" cy="5143500"/>
           </a:xfrm>
           <a:prstGeom xmlns:a="http://schemas.openxmlformats.org/drawingml/2006/main" prst="rect">
             <a:avLst/>
@@ -2742,7 +2813,7 @@
           <p:cNvPr id="6" name="">
             <a:extLst xmlns:a="http://schemas.openxmlformats.org/drawingml/2006/main">
               <a:ext uri="{FF2B5EF4-FFF2-40B4-BE49-F238E27FC236}">
-                <a16:creationId xmlns:a16="http://schemas.microsoft.com/office/drawing/2014/main" id="{8E33C5E0-D39D-4A3D-9D9F-A366AEE9BDC3}"/>
+                <a16:creationId xmlns:a16="http://schemas.microsoft.com/office/drawing/2014/main" id="{937FEB36-2968-49ED-AA2B-596A44687713}"/>
               </a:ext>
             </a:extLst>
           </p:cNvPr>
@@ -2753,8 +2824,8 @@
         </p:nvSpPr>
         <p:spPr>
           <a:xfrm xmlns:a="http://schemas.openxmlformats.org/drawingml/2006/main">
-            <a:off x="619125" y="5791200"/>
-            <a:ext cx="10953750" cy="561975"/>
+            <a:off x="619125" y="6191250"/>
+            <a:ext cx="10953750" cy="285750"/>
           </a:xfrm>
           <a:prstGeom xmlns:a="http://schemas.openxmlformats.org/drawingml/2006/main" prst="rect">
             <a:avLst/>
@@ -2766,30 +2837,30 @@
         </p:spPr>
         <p:txBody>
           <a:bodyPr xmlns:a="http://schemas.openxmlformats.org/drawingml/2006/main">
-            <a:normAutofit fontScale="100000"/>
+            <a:normAutofit fontScale="94444"/>
           </a:bodyPr>
           <a:lstStyle xmlns:a="http://schemas.openxmlformats.org/drawingml/2006/main"/>
           <a:p xmlns:a="http://schemas.openxmlformats.org/drawingml/2006/main">
             <a:pPr>
-              <a:defRPr sz="1650" b="1">
-                <a:solidFill>
-                  <a:srgbClr val="D55E00"/>
-                </a:solidFill>
-                <a:latin typeface="Microsoft JhengHei"/>
-                <a:ea typeface="Microsoft JhengHei"/>
-                <a:cs typeface="Microsoft JhengHei"/>
-              </a:defRPr>
-            </a:pPr>
-            <a:r>
-              <a:rPr sz="1650" b="1">
-                <a:solidFill>
-                  <a:srgbClr val="D55E00"/>
-                </a:solidFill>
-                <a:latin typeface="Microsoft JhengHei"/>
-                <a:ea typeface="Microsoft JhengHei"/>
-                <a:cs typeface="Microsoft JhengHei"/>
-              </a:rPr>
-              <a:t>Proteasome、mitophagy 均上調，兩組資料的完整 KEGG FDR 都小於 0.05。</a:t>
+              <a:defRPr sz="1350" b="0">
+                <a:solidFill>
+                  <a:srgbClr val="142F43"/>
+                </a:solidFill>
+                <a:latin typeface="Microsoft JhengHei"/>
+                <a:ea typeface="Microsoft JhengHei"/>
+                <a:cs typeface="Microsoft JhengHei"/>
+              </a:defRPr>
+            </a:pPr>
+            <a:r>
+              <a:rPr sz="1350" b="0">
+                <a:solidFill>
+                  <a:srgbClr val="142F43"/>
+                </a:solidFill>
+                <a:latin typeface="Microsoft JhengHei"/>
+                <a:ea typeface="Microsoft JhengHei"/>
+                <a:cs typeface="Microsoft JhengHei"/>
+              </a:rPr>
+              <a:t>Mitophagy 位於第 28 條。Single-cell FDR = 0.0132，bulk FDR = 0.0282。</a:t>
             </a:r>
           </a:p>
         </p:txBody>
@@ -2797,7 +2868,7 @@
     </p:spTree>
     <p:extLst>
       <p:ext uri="{BB962C8B-B14F-4D97-AF65-F5344CB8AC3E}">
-        <p14:creationId xmlns:p14="http://schemas.microsoft.com/office/powerpoint/2010/main" val="1479276253"/>
+        <p14:creationId xmlns:p14="http://schemas.microsoft.com/office/powerpoint/2010/main" val="251180789"/>
       </p:ext>
     </p:extLst>
   </p:cSld>
@@ -2825,10 +2896,10 @@
       </p:grpSpPr>
       <p:sp>
         <p:nvSpPr>
-          <p:cNvPr id="8" name="">
+          <p:cNvPr id="7" name="">
             <a:extLst xmlns:a="http://schemas.openxmlformats.org/drawingml/2006/main">
               <a:ext uri="{FF2B5EF4-FFF2-40B4-BE49-F238E27FC236}">
-                <a16:creationId xmlns:a16="http://schemas.microsoft.com/office/drawing/2014/main" id="{12B8CB02-5257-434D-909A-2D70F1C5FD71}"/>
+                <a16:creationId xmlns:a16="http://schemas.microsoft.com/office/drawing/2014/main" id="{5AD6739D-8028-45FD-946F-9EFFE3BE8B90}"/>
               </a:ext>
             </a:extLst>
           </p:cNvPr>
@@ -2875,7 +2946,7 @@
                 <a:ea typeface="Microsoft JhengHei"/>
                 <a:cs typeface="Microsoft JhengHei"/>
               </a:rPr>
-              <a:t>PAIRED DIRECTION</a:t>
+              <a:t>TARGET PATHWAYS</a:t>
             </a:r>
           </a:p>
         </p:txBody>
@@ -2885,7 +2956,7 @@
           <p:cNvPr id="2" name="">
             <a:extLst xmlns:a="http://schemas.openxmlformats.org/drawingml/2006/main">
               <a:ext uri="{FF2B5EF4-FFF2-40B4-BE49-F238E27FC236}">
-                <a16:creationId xmlns:a16="http://schemas.microsoft.com/office/drawing/2014/main" id="{DA9F256B-A29C-4BB5-A07F-D03909475925}"/>
+                <a16:creationId xmlns:a16="http://schemas.microsoft.com/office/drawing/2014/main" id="{9677DF46-6302-4306-9B68-3F01DFD855ED}"/>
               </a:ext>
             </a:extLst>
           </p:cNvPr>
@@ -2932,7 +3003,7 @@
                 <a:ea typeface="Microsoft JhengHei"/>
                 <a:cs typeface="Microsoft JhengHei"/>
               </a:rPr>
-              <a:t>三位病人的變化方向</a:t>
+              <a:t>Proteasome 與 mitophagy 的結果核對</a:t>
             </a:r>
           </a:p>
         </p:txBody>
@@ -2942,7 +3013,7 @@
           <p:cNvPr id="3" name="">
             <a:extLst xmlns:a="http://schemas.openxmlformats.org/drawingml/2006/main">
               <a:ext uri="{FF2B5EF4-FFF2-40B4-BE49-F238E27FC236}">
-                <a16:creationId xmlns:a16="http://schemas.microsoft.com/office/drawing/2014/main" id="{A5E5A68D-BBEE-4D32-B7AD-AAFDD731B600}"/>
+                <a16:creationId xmlns:a16="http://schemas.microsoft.com/office/drawing/2014/main" id="{2FD45CC3-0939-43EC-8E84-A04DCEE196E4}"/>
               </a:ext>
             </a:extLst>
           </p:cNvPr>
@@ -2999,7 +3070,7 @@
           <p:cNvPr id="4" name="">
             <a:extLst xmlns:a="http://schemas.openxmlformats.org/drawingml/2006/main">
               <a:ext uri="{FF2B5EF4-FFF2-40B4-BE49-F238E27FC236}">
-                <a16:creationId xmlns:a16="http://schemas.microsoft.com/office/drawing/2014/main" id="{4BBDAC00-A282-48CD-AADC-89B5CCA0B19A}"/>
+                <a16:creationId xmlns:a16="http://schemas.microsoft.com/office/drawing/2014/main" id="{01C0D05B-6291-4220-9D7A-C7532218FD16}"/>
               </a:ext>
             </a:extLst>
           </p:cNvPr>
@@ -3053,20 +3124,20 @@
       </p:sp>
       <p:pic>
         <p:nvPicPr>
-          <p:cNvPr id="12" name=""/>
+          <p:cNvPr id="11" name=""/>
           <p:cNvPicPr>
             <a:picLocks xmlns:a="http://schemas.openxmlformats.org/drawingml/2006/main" noChangeAspect="1"/>
           </p:cNvPicPr>
           <p:nvPr/>
         </p:nvPicPr>
         <p:blipFill>
-          <a:blip xmlns:r="http://schemas.openxmlformats.org/officeDocument/2006/relationships" xmlns:a="http://schemas.openxmlformats.org/drawingml/2006/main" r:embed="R25388103743748b3"/>
+          <a:blip xmlns:r="http://schemas.openxmlformats.org/officeDocument/2006/relationships" xmlns:a="http://schemas.openxmlformats.org/drawingml/2006/main" r:embed="R3f44a7801bfa485f"/>
           <a:stretch xmlns:a="http://schemas.openxmlformats.org/drawingml/2006/main"/>
         </p:blipFill>
         <p:spPr>
           <a:xfrm xmlns:a="http://schemas.openxmlformats.org/drawingml/2006/main">
-            <a:off x="445943" y="1190625"/>
-            <a:ext cx="8442614" cy="4953000"/>
+            <a:off x="2122289" y="1362075"/>
+            <a:ext cx="7947422" cy="4238625"/>
           </a:xfrm>
           <a:prstGeom xmlns:a="http://schemas.openxmlformats.org/drawingml/2006/main" prst="rect">
             <a:avLst/>
@@ -3078,7 +3149,7 @@
           <p:cNvPr id="6" name="">
             <a:extLst xmlns:a="http://schemas.openxmlformats.org/drawingml/2006/main">
               <a:ext uri="{FF2B5EF4-FFF2-40B4-BE49-F238E27FC236}">
-                <a16:creationId xmlns:a16="http://schemas.microsoft.com/office/drawing/2014/main" id="{33D19D66-5BD8-4E65-AAFC-A2349521F3DE}"/>
+                <a16:creationId xmlns:a16="http://schemas.microsoft.com/office/drawing/2014/main" id="{91488D28-98AE-498C-B876-ECD76EC87DC9}"/>
               </a:ext>
             </a:extLst>
           </p:cNvPr>
@@ -3089,8 +3160,8 @@
         </p:nvSpPr>
         <p:spPr>
           <a:xfrm xmlns:a="http://schemas.openxmlformats.org/drawingml/2006/main">
-            <a:off x="9239250" y="1905000"/>
-            <a:ext cx="2476500" cy="619125"/>
+            <a:off x="619125" y="5791200"/>
+            <a:ext cx="10953750" cy="561975"/>
           </a:xfrm>
           <a:prstGeom xmlns:a="http://schemas.openxmlformats.org/drawingml/2006/main" prst="rect">
             <a:avLst/>
@@ -3107,110 +3178,25 @@
           <a:lstStyle xmlns:a="http://schemas.openxmlformats.org/drawingml/2006/main"/>
           <a:p xmlns:a="http://schemas.openxmlformats.org/drawingml/2006/main">
             <a:pPr>
-              <a:defRPr sz="1875" b="1">
-                <a:solidFill>
-                  <a:srgbClr val="142F43"/>
-                </a:solidFill>
-                <a:latin typeface="Microsoft JhengHei"/>
-                <a:ea typeface="Microsoft JhengHei"/>
-                <a:cs typeface="Microsoft JhengHei"/>
-              </a:defRPr>
-            </a:pPr>
-            <a:r>
-              <a:rPr sz="1875" b="1">
-                <a:solidFill>
-                  <a:srgbClr val="142F43"/>
-                </a:solidFill>
-                <a:latin typeface="Microsoft JhengHei"/>
-                <a:ea typeface="Microsoft JhengHei"/>
-                <a:cs typeface="Microsoft JhengHei"/>
-              </a:rPr>
-              <a:t>每條線是一位病人</a:t>
-            </a:r>
-          </a:p>
-        </p:txBody>
-      </p:sp>
-      <p:sp>
-        <p:nvSpPr>
-          <p:cNvPr id="7" name="">
-            <a:extLst xmlns:a="http://schemas.openxmlformats.org/drawingml/2006/main">
-              <a:ext uri="{FF2B5EF4-FFF2-40B4-BE49-F238E27FC236}">
-                <a16:creationId xmlns:a16="http://schemas.microsoft.com/office/drawing/2014/main" id="{88378425-E98D-456B-B9C4-4A99F125D1F1}"/>
-              </a:ext>
-            </a:extLst>
-          </p:cNvPr>
-          <p:cNvSpPr>
-            <a:spLocks xmlns:a="http://schemas.openxmlformats.org/drawingml/2006/main" noGrp="1"/>
-          </p:cNvSpPr>
-          <p:nvPr/>
-        </p:nvSpPr>
-        <p:spPr>
-          <a:xfrm xmlns:a="http://schemas.openxmlformats.org/drawingml/2006/main">
-            <a:off x="9239250" y="2857500"/>
-            <a:ext cx="2476500" cy="2190750"/>
-          </a:xfrm>
-          <a:prstGeom xmlns:a="http://schemas.openxmlformats.org/drawingml/2006/main" prst="rect">
-            <a:avLst/>
-          </a:prstGeom>
-          <a:noFill xmlns:a="http://schemas.openxmlformats.org/drawingml/2006/main"/>
-          <a:ln xmlns:a="http://schemas.openxmlformats.org/drawingml/2006/main" w="0">
-            <a:noFill/>
-          </a:ln>
-        </p:spPr>
-        <p:txBody>
-          <a:bodyPr xmlns:a="http://schemas.openxmlformats.org/drawingml/2006/main">
-            <a:normAutofit fontScale="100000"/>
-          </a:bodyPr>
-          <a:lstStyle xmlns:a="http://schemas.openxmlformats.org/drawingml/2006/main"/>
-          <a:p xmlns:a="http://schemas.openxmlformats.org/drawingml/2006/main">
-            <a:pPr>
-              <a:defRPr sz="1650" b="0">
-                <a:solidFill>
-                  <a:srgbClr val="142F43"/>
-                </a:solidFill>
-                <a:latin typeface="Microsoft JhengHei"/>
-                <a:ea typeface="Microsoft JhengHei"/>
-                <a:cs typeface="Microsoft JhengHei"/>
-              </a:defRPr>
-            </a:pPr>
-            <a:r>
-              <a:rPr sz="1650" b="0">
-                <a:solidFill>
-                  <a:srgbClr val="142F43"/>
-                </a:solidFill>
-                <a:latin typeface="Microsoft JhengHei"/>
-                <a:ea typeface="Microsoft JhengHei"/>
-                <a:cs typeface="Microsoft JhengHei"/>
-              </a:rPr>
-              <a:t>Leading-edge genes 由同一份 GSEA 選出。</a:t>
-            </a:r>
-          </a:p>
-          <a:p xmlns:a="http://schemas.openxmlformats.org/drawingml/2006/main">
-            <a:r>
-              <a:t/>
-            </a:r>
-          </a:p>
-          <a:p xmlns:a="http://schemas.openxmlformats.org/drawingml/2006/main">
-            <a:pPr>
-              <a:defRPr sz="1650" b="0">
-                <a:solidFill>
-                  <a:srgbClr val="142F43"/>
-                </a:solidFill>
-                <a:latin typeface="Microsoft JhengHei"/>
-                <a:ea typeface="Microsoft JhengHei"/>
-                <a:cs typeface="Microsoft JhengHei"/>
-              </a:defRPr>
-            </a:pPr>
-            <a:r>
-              <a:rPr sz="1650" b="0">
-                <a:solidFill>
-                  <a:srgbClr val="142F43"/>
-                </a:solidFill>
-                <a:latin typeface="Microsoft JhengHei"/>
-                <a:ea typeface="Microsoft JhengHei"/>
-                <a:cs typeface="Microsoft JhengHei"/>
-              </a:rPr>
-              <a:t>這裡只描述三位病人的方向，不作額外的獨立驗證。</a:t>
+              <a:defRPr sz="1650" b="1">
+                <a:solidFill>
+                  <a:srgbClr val="D55E00"/>
+                </a:solidFill>
+                <a:latin typeface="Microsoft JhengHei"/>
+                <a:ea typeface="Microsoft JhengHei"/>
+                <a:cs typeface="Microsoft JhengHei"/>
+              </a:defRPr>
+            </a:pPr>
+            <a:r>
+              <a:rPr sz="1650" b="1">
+                <a:solidFill>
+                  <a:srgbClr val="D55E00"/>
+                </a:solidFill>
+                <a:latin typeface="Microsoft JhengHei"/>
+                <a:ea typeface="Microsoft JhengHei"/>
+                <a:cs typeface="Microsoft JhengHei"/>
+              </a:rPr>
+              <a:t>Proteasome、mitophagy 均上調，兩組資料的完整 KEGG FDR 都小於 0.05。</a:t>
             </a:r>
           </a:p>
         </p:txBody>
@@ -3218,7 +3204,7 @@
     </p:spTree>
     <p:extLst>
       <p:ext uri="{BB962C8B-B14F-4D97-AF65-F5344CB8AC3E}">
-        <p14:creationId xmlns:p14="http://schemas.microsoft.com/office/powerpoint/2010/main" val="1241329555"/>
+        <p14:creationId xmlns:p14="http://schemas.microsoft.com/office/powerpoint/2010/main" val="1317863225"/>
       </p:ext>
     </p:extLst>
   </p:cSld>
@@ -3246,10 +3232,10 @@
       </p:grpSpPr>
       <p:sp>
         <p:nvSpPr>
-          <p:cNvPr id="9" name="">
+          <p:cNvPr id="8" name="">
             <a:extLst xmlns:a="http://schemas.openxmlformats.org/drawingml/2006/main">
               <a:ext uri="{FF2B5EF4-FFF2-40B4-BE49-F238E27FC236}">
-                <a16:creationId xmlns:a16="http://schemas.microsoft.com/office/drawing/2014/main" id="{16E4BF93-4904-4CFE-A168-264AD43FFBEC}"/>
+                <a16:creationId xmlns:a16="http://schemas.microsoft.com/office/drawing/2014/main" id="{EAFDFD02-A2B2-4D6F-BD1C-909C6FF26F01}"/>
               </a:ext>
             </a:extLst>
           </p:cNvPr>
@@ -3296,7 +3282,7 @@
                 <a:ea typeface="Microsoft JhengHei"/>
                 <a:cs typeface="Microsoft JhengHei"/>
               </a:rPr>
-              <a:t>CUTOFF INTERPRETATION</a:t>
+              <a:t>PAIRED DIRECTION</a:t>
             </a:r>
           </a:p>
         </p:txBody>
@@ -3306,7 +3292,7 @@
           <p:cNvPr id="2" name="">
             <a:extLst xmlns:a="http://schemas.openxmlformats.org/drawingml/2006/main">
               <a:ext uri="{FF2B5EF4-FFF2-40B4-BE49-F238E27FC236}">
-                <a16:creationId xmlns:a16="http://schemas.microsoft.com/office/drawing/2014/main" id="{DC4E71E9-075A-441D-BFA4-B928E5E43046}"/>
+                <a16:creationId xmlns:a16="http://schemas.microsoft.com/office/drawing/2014/main" id="{5E1AC2A5-43A5-4526-82C3-664B0D45091E}"/>
               </a:ext>
             </a:extLst>
           </p:cNvPr>
@@ -3353,7 +3339,7 @@
                 <a:ea typeface="Microsoft JhengHei"/>
                 <a:cs typeface="Microsoft JhengHei"/>
               </a:rPr>
-              <a:t>CNV top 15% 設定與 reference 對照</a:t>
+              <a:t>三位病人的變化方向</a:t>
             </a:r>
           </a:p>
         </p:txBody>
@@ -3363,7 +3349,7 @@
           <p:cNvPr id="3" name="">
             <a:extLst xmlns:a="http://schemas.openxmlformats.org/drawingml/2006/main">
               <a:ext uri="{FF2B5EF4-FFF2-40B4-BE49-F238E27FC236}">
-                <a16:creationId xmlns:a16="http://schemas.microsoft.com/office/drawing/2014/main" id="{ADBFA3F9-2002-4E63-8CCB-7687217D1DB6}"/>
+                <a16:creationId xmlns:a16="http://schemas.microsoft.com/office/drawing/2014/main" id="{41FF9BE0-0B89-4E6C-BFA0-4F2150322561}"/>
               </a:ext>
             </a:extLst>
           </p:cNvPr>
@@ -3420,7 +3406,7 @@
           <p:cNvPr id="4" name="">
             <a:extLst xmlns:a="http://schemas.openxmlformats.org/drawingml/2006/main">
               <a:ext uri="{FF2B5EF4-FFF2-40B4-BE49-F238E27FC236}">
-                <a16:creationId xmlns:a16="http://schemas.microsoft.com/office/drawing/2014/main" id="{E77A0E46-2EC3-4566-BF4E-0D97F1B54169}"/>
+                <a16:creationId xmlns:a16="http://schemas.microsoft.com/office/drawing/2014/main" id="{25BEAA8F-1092-4694-A7B9-4623CA62B3DC}"/>
               </a:ext>
             </a:extLst>
           </p:cNvPr>
@@ -3472,12 +3458,433 @@
           </a:p>
         </p:txBody>
       </p:sp>
+      <p:pic>
+        <p:nvPicPr>
+          <p:cNvPr id="12" name=""/>
+          <p:cNvPicPr>
+            <a:picLocks xmlns:a="http://schemas.openxmlformats.org/drawingml/2006/main" noChangeAspect="1"/>
+          </p:cNvPicPr>
+          <p:nvPr/>
+        </p:nvPicPr>
+        <p:blipFill>
+          <a:blip xmlns:r="http://schemas.openxmlformats.org/officeDocument/2006/relationships" xmlns:a="http://schemas.openxmlformats.org/drawingml/2006/main" r:embed="Rc7155f9de3334533"/>
+          <a:stretch xmlns:a="http://schemas.openxmlformats.org/drawingml/2006/main"/>
+        </p:blipFill>
+        <p:spPr>
+          <a:xfrm xmlns:a="http://schemas.openxmlformats.org/drawingml/2006/main">
+            <a:off x="445943" y="1190625"/>
+            <a:ext cx="8442614" cy="4953000"/>
+          </a:xfrm>
+          <a:prstGeom xmlns:a="http://schemas.openxmlformats.org/drawingml/2006/main" prst="rect">
+            <a:avLst/>
+          </a:prstGeom>
+        </p:spPr>
+      </p:pic>
+      <p:sp>
+        <p:nvSpPr>
+          <p:cNvPr id="6" name="">
+            <a:extLst xmlns:a="http://schemas.openxmlformats.org/drawingml/2006/main">
+              <a:ext uri="{FF2B5EF4-FFF2-40B4-BE49-F238E27FC236}">
+                <a16:creationId xmlns:a16="http://schemas.microsoft.com/office/drawing/2014/main" id="{FB1673DC-F9F3-4C15-B598-21BA31B6C16C}"/>
+              </a:ext>
+            </a:extLst>
+          </p:cNvPr>
+          <p:cNvSpPr>
+            <a:spLocks xmlns:a="http://schemas.openxmlformats.org/drawingml/2006/main" noGrp="1"/>
+          </p:cNvSpPr>
+          <p:nvPr/>
+        </p:nvSpPr>
+        <p:spPr>
+          <a:xfrm xmlns:a="http://schemas.openxmlformats.org/drawingml/2006/main">
+            <a:off x="9239250" y="1905000"/>
+            <a:ext cx="2476500" cy="619125"/>
+          </a:xfrm>
+          <a:prstGeom xmlns:a="http://schemas.openxmlformats.org/drawingml/2006/main" prst="rect">
+            <a:avLst/>
+          </a:prstGeom>
+          <a:noFill xmlns:a="http://schemas.openxmlformats.org/drawingml/2006/main"/>
+          <a:ln xmlns:a="http://schemas.openxmlformats.org/drawingml/2006/main" w="0">
+            <a:noFill/>
+          </a:ln>
+        </p:spPr>
+        <p:txBody>
+          <a:bodyPr xmlns:a="http://schemas.openxmlformats.org/drawingml/2006/main">
+            <a:normAutofit fontScale="100000"/>
+          </a:bodyPr>
+          <a:lstStyle xmlns:a="http://schemas.openxmlformats.org/drawingml/2006/main"/>
+          <a:p xmlns:a="http://schemas.openxmlformats.org/drawingml/2006/main">
+            <a:pPr>
+              <a:defRPr sz="1875" b="1">
+                <a:solidFill>
+                  <a:srgbClr val="142F43"/>
+                </a:solidFill>
+                <a:latin typeface="Microsoft JhengHei"/>
+                <a:ea typeface="Microsoft JhengHei"/>
+                <a:cs typeface="Microsoft JhengHei"/>
+              </a:defRPr>
+            </a:pPr>
+            <a:r>
+              <a:rPr sz="1875" b="1">
+                <a:solidFill>
+                  <a:srgbClr val="142F43"/>
+                </a:solidFill>
+                <a:latin typeface="Microsoft JhengHei"/>
+                <a:ea typeface="Microsoft JhengHei"/>
+                <a:cs typeface="Microsoft JhengHei"/>
+              </a:rPr>
+              <a:t>每條線是一位病人</a:t>
+            </a:r>
+          </a:p>
+        </p:txBody>
+      </p:sp>
+      <p:sp>
+        <p:nvSpPr>
+          <p:cNvPr id="7" name="">
+            <a:extLst xmlns:a="http://schemas.openxmlformats.org/drawingml/2006/main">
+              <a:ext uri="{FF2B5EF4-FFF2-40B4-BE49-F238E27FC236}">
+                <a16:creationId xmlns:a16="http://schemas.microsoft.com/office/drawing/2014/main" id="{1552A820-E265-4E1E-AF48-07FCB494E0C3}"/>
+              </a:ext>
+            </a:extLst>
+          </p:cNvPr>
+          <p:cNvSpPr>
+            <a:spLocks xmlns:a="http://schemas.openxmlformats.org/drawingml/2006/main" noGrp="1"/>
+          </p:cNvSpPr>
+          <p:nvPr/>
+        </p:nvSpPr>
+        <p:spPr>
+          <a:xfrm xmlns:a="http://schemas.openxmlformats.org/drawingml/2006/main">
+            <a:off x="9239250" y="2857500"/>
+            <a:ext cx="2476500" cy="2190750"/>
+          </a:xfrm>
+          <a:prstGeom xmlns:a="http://schemas.openxmlformats.org/drawingml/2006/main" prst="rect">
+            <a:avLst/>
+          </a:prstGeom>
+          <a:noFill xmlns:a="http://schemas.openxmlformats.org/drawingml/2006/main"/>
+          <a:ln xmlns:a="http://schemas.openxmlformats.org/drawingml/2006/main" w="0">
+            <a:noFill/>
+          </a:ln>
+        </p:spPr>
+        <p:txBody>
+          <a:bodyPr xmlns:a="http://schemas.openxmlformats.org/drawingml/2006/main">
+            <a:normAutofit fontScale="100000"/>
+          </a:bodyPr>
+          <a:lstStyle xmlns:a="http://schemas.openxmlformats.org/drawingml/2006/main"/>
+          <a:p xmlns:a="http://schemas.openxmlformats.org/drawingml/2006/main">
+            <a:pPr>
+              <a:defRPr sz="1650" b="0">
+                <a:solidFill>
+                  <a:srgbClr val="142F43"/>
+                </a:solidFill>
+                <a:latin typeface="Microsoft JhengHei"/>
+                <a:ea typeface="Microsoft JhengHei"/>
+                <a:cs typeface="Microsoft JhengHei"/>
+              </a:defRPr>
+            </a:pPr>
+            <a:r>
+              <a:rPr sz="1650" b="0">
+                <a:solidFill>
+                  <a:srgbClr val="142F43"/>
+                </a:solidFill>
+                <a:latin typeface="Microsoft JhengHei"/>
+                <a:ea typeface="Microsoft JhengHei"/>
+                <a:cs typeface="Microsoft JhengHei"/>
+              </a:rPr>
+              <a:t>Leading-edge genes 由同一份 GSEA 選出。</a:t>
+            </a:r>
+          </a:p>
+          <a:p xmlns:a="http://schemas.openxmlformats.org/drawingml/2006/main">
+            <a:r>
+              <a:t/>
+            </a:r>
+          </a:p>
+          <a:p xmlns:a="http://schemas.openxmlformats.org/drawingml/2006/main">
+            <a:pPr>
+              <a:defRPr sz="1650" b="0">
+                <a:solidFill>
+                  <a:srgbClr val="142F43"/>
+                </a:solidFill>
+                <a:latin typeface="Microsoft JhengHei"/>
+                <a:ea typeface="Microsoft JhengHei"/>
+                <a:cs typeface="Microsoft JhengHei"/>
+              </a:defRPr>
+            </a:pPr>
+            <a:r>
+              <a:rPr sz="1650" b="0">
+                <a:solidFill>
+                  <a:srgbClr val="142F43"/>
+                </a:solidFill>
+                <a:latin typeface="Microsoft JhengHei"/>
+                <a:ea typeface="Microsoft JhengHei"/>
+                <a:cs typeface="Microsoft JhengHei"/>
+              </a:rPr>
+              <a:t>這裡只描述三位病人的方向，不作額外的獨立驗證。</a:t>
+            </a:r>
+          </a:p>
+        </p:txBody>
+      </p:sp>
+    </p:spTree>
+    <p:extLst>
+      <p:ext uri="{BB962C8B-B14F-4D97-AF65-F5344CB8AC3E}">
+        <p14:creationId xmlns:p14="http://schemas.microsoft.com/office/powerpoint/2010/main" val="429133491"/>
+      </p:ext>
+    </p:extLst>
+  </p:cSld>
+</p:sld>
+</file>
+
+<file path=ppt/slides/slide13.xml><?xml version="1.0" encoding="utf-8"?>
+<p:sld xmlns:p="http://schemas.openxmlformats.org/presentationml/2006/main">
+  <p:cSld>
+    <p:bg>
+      <p:bgPr>
+        <a:solidFill xmlns:a="http://schemas.openxmlformats.org/drawingml/2006/main">
+          <a:srgbClr val="FFFFFF"/>
+        </a:solidFill>
+      </p:bgPr>
+    </p:bg>
+    <p:spTree>
+      <p:nvGrpSpPr>
+        <p:cNvPr id="1" name=""/>
+        <p:cNvGrpSpPr/>
+        <p:nvPr/>
+      </p:nvGrpSpPr>
+      <p:grpSpPr>
+        <a:xfrm xmlns:a="http://schemas.openxmlformats.org/drawingml/2006/main"/>
+      </p:grpSpPr>
+      <p:sp>
+        <p:nvSpPr>
+          <p:cNvPr id="9" name="">
+            <a:extLst xmlns:a="http://schemas.openxmlformats.org/drawingml/2006/main">
+              <a:ext uri="{FF2B5EF4-FFF2-40B4-BE49-F238E27FC236}">
+                <a16:creationId xmlns:a16="http://schemas.microsoft.com/office/drawing/2014/main" id="{321236D8-FB1E-4557-80CC-AB72AFBB6E21}"/>
+              </a:ext>
+            </a:extLst>
+          </p:cNvPr>
+          <p:cNvSpPr>
+            <a:spLocks xmlns:a="http://schemas.openxmlformats.org/drawingml/2006/main" noGrp="1"/>
+          </p:cNvSpPr>
+          <p:nvPr/>
+        </p:nvSpPr>
+        <p:spPr>
+          <a:xfrm xmlns:a="http://schemas.openxmlformats.org/drawingml/2006/main">
+            <a:off x="476250" y="190500"/>
+            <a:ext cx="10477500" cy="209550"/>
+          </a:xfrm>
+          <a:prstGeom xmlns:a="http://schemas.openxmlformats.org/drawingml/2006/main" prst="rect">
+            <a:avLst/>
+          </a:prstGeom>
+          <a:noFill xmlns:a="http://schemas.openxmlformats.org/drawingml/2006/main"/>
+          <a:ln xmlns:a="http://schemas.openxmlformats.org/drawingml/2006/main" w="0">
+            <a:noFill/>
+          </a:ln>
+        </p:spPr>
+        <p:txBody>
+          <a:bodyPr xmlns:a="http://schemas.openxmlformats.org/drawingml/2006/main">
+            <a:normAutofit fontScale="79487"/>
+          </a:bodyPr>
+          <a:lstStyle xmlns:a="http://schemas.openxmlformats.org/drawingml/2006/main"/>
+          <a:p xmlns:a="http://schemas.openxmlformats.org/drawingml/2006/main">
+            <a:pPr>
+              <a:defRPr sz="975" b="1">
+                <a:solidFill>
+                  <a:srgbClr val="D55E00"/>
+                </a:solidFill>
+                <a:latin typeface="Microsoft JhengHei"/>
+                <a:ea typeface="Microsoft JhengHei"/>
+                <a:cs typeface="Microsoft JhengHei"/>
+              </a:defRPr>
+            </a:pPr>
+            <a:r>
+              <a:rPr sz="975" b="1">
+                <a:solidFill>
+                  <a:srgbClr val="D55E00"/>
+                </a:solidFill>
+                <a:latin typeface="Microsoft JhengHei"/>
+                <a:ea typeface="Microsoft JhengHei"/>
+                <a:cs typeface="Microsoft JhengHei"/>
+              </a:rPr>
+              <a:t>CUTOFF INTERPRETATION</a:t>
+            </a:r>
+          </a:p>
+        </p:txBody>
+      </p:sp>
+      <p:sp>
+        <p:nvSpPr>
+          <p:cNvPr id="2" name="">
+            <a:extLst xmlns:a="http://schemas.openxmlformats.org/drawingml/2006/main">
+              <a:ext uri="{FF2B5EF4-FFF2-40B4-BE49-F238E27FC236}">
+                <a16:creationId xmlns:a16="http://schemas.microsoft.com/office/drawing/2014/main" id="{46A21852-B7D9-4EB2-90F7-0DCFA28D4ED5}"/>
+              </a:ext>
+            </a:extLst>
+          </p:cNvPr>
+          <p:cNvSpPr>
+            <a:spLocks xmlns:a="http://schemas.openxmlformats.org/drawingml/2006/main" noGrp="1"/>
+          </p:cNvSpPr>
+          <p:nvPr/>
+        </p:nvSpPr>
+        <p:spPr>
+          <a:xfrm xmlns:a="http://schemas.openxmlformats.org/drawingml/2006/main">
+            <a:off x="476250" y="523875"/>
+            <a:ext cx="11144250" cy="476250"/>
+          </a:xfrm>
+          <a:prstGeom xmlns:a="http://schemas.openxmlformats.org/drawingml/2006/main" prst="rect">
+            <a:avLst/>
+          </a:prstGeom>
+          <a:noFill xmlns:a="http://schemas.openxmlformats.org/drawingml/2006/main"/>
+          <a:ln xmlns:a="http://schemas.openxmlformats.org/drawingml/2006/main" w="0">
+            <a:noFill/>
+          </a:ln>
+        </p:spPr>
+        <p:txBody>
+          <a:bodyPr xmlns:a="http://schemas.openxmlformats.org/drawingml/2006/main">
+            <a:normAutofit fontScale="100000"/>
+          </a:bodyPr>
+          <a:lstStyle xmlns:a="http://schemas.openxmlformats.org/drawingml/2006/main"/>
+          <a:p xmlns:a="http://schemas.openxmlformats.org/drawingml/2006/main">
+            <a:pPr>
+              <a:defRPr sz="2400" b="1">
+                <a:solidFill>
+                  <a:srgbClr val="142F43"/>
+                </a:solidFill>
+                <a:latin typeface="Microsoft JhengHei"/>
+                <a:ea typeface="Microsoft JhengHei"/>
+                <a:cs typeface="Microsoft JhengHei"/>
+              </a:defRPr>
+            </a:pPr>
+            <a:r>
+              <a:rPr sz="2400" b="1">
+                <a:solidFill>
+                  <a:srgbClr val="142F43"/>
+                </a:solidFill>
+                <a:latin typeface="Microsoft JhengHei"/>
+                <a:ea typeface="Microsoft JhengHei"/>
+                <a:cs typeface="Microsoft JhengHei"/>
+              </a:rPr>
+              <a:t>CNV top 15% 設定與 reference 對照</a:t>
+            </a:r>
+          </a:p>
+        </p:txBody>
+      </p:sp>
+      <p:sp>
+        <p:nvSpPr>
+          <p:cNvPr id="3" name="">
+            <a:extLst xmlns:a="http://schemas.openxmlformats.org/drawingml/2006/main">
+              <a:ext uri="{FF2B5EF4-FFF2-40B4-BE49-F238E27FC236}">
+                <a16:creationId xmlns:a16="http://schemas.microsoft.com/office/drawing/2014/main" id="{0C3FB69E-FC5D-4853-A2BA-302591086F7A}"/>
+              </a:ext>
+            </a:extLst>
+          </p:cNvPr>
+          <p:cNvSpPr>
+            <a:spLocks xmlns:a="http://schemas.openxmlformats.org/drawingml/2006/main" noGrp="1"/>
+          </p:cNvSpPr>
+          <p:nvPr/>
+        </p:nvSpPr>
+        <p:spPr>
+          <a:xfrm xmlns:a="http://schemas.openxmlformats.org/drawingml/2006/main">
+            <a:off x="476250" y="6543675"/>
+            <a:ext cx="10287000" cy="171450"/>
+          </a:xfrm>
+          <a:prstGeom xmlns:a="http://schemas.openxmlformats.org/drawingml/2006/main" prst="rect">
+            <a:avLst/>
+          </a:prstGeom>
+          <a:noFill xmlns:a="http://schemas.openxmlformats.org/drawingml/2006/main"/>
+          <a:ln xmlns:a="http://schemas.openxmlformats.org/drawingml/2006/main" w="0">
+            <a:noFill/>
+          </a:ln>
+        </p:spPr>
+        <p:txBody>
+          <a:bodyPr xmlns:a="http://schemas.openxmlformats.org/drawingml/2006/main">
+            <a:normAutofit fontScale="63636"/>
+          </a:bodyPr>
+          <a:lstStyle xmlns:a="http://schemas.openxmlformats.org/drawingml/2006/main"/>
+          <a:p xmlns:a="http://schemas.openxmlformats.org/drawingml/2006/main">
+            <a:pPr>
+              <a:defRPr sz="825" b="0">
+                <a:solidFill>
+                  <a:srgbClr val="4D5B66"/>
+                </a:solidFill>
+                <a:latin typeface="Microsoft JhengHei"/>
+                <a:ea typeface="Microsoft JhengHei"/>
+                <a:cs typeface="Microsoft JhengHei"/>
+              </a:defRPr>
+            </a:pPr>
+            <a:r>
+              <a:rPr sz="825" b="0">
+                <a:solidFill>
+                  <a:srgbClr val="4D5B66"/>
+                </a:solidFill>
+                <a:latin typeface="Microsoft JhengHei"/>
+                <a:ea typeface="Microsoft JhengHei"/>
+                <a:cs typeface="Microsoft JhengHei"/>
+              </a:rPr>
+              <a:t>GSE262271 / GSE218858  |  Reviewed 15 September 2026</a:t>
+            </a:r>
+          </a:p>
+        </p:txBody>
+      </p:sp>
+      <p:sp>
+        <p:nvSpPr>
+          <p:cNvPr id="4" name="">
+            <a:extLst xmlns:a="http://schemas.openxmlformats.org/drawingml/2006/main">
+              <a:ext uri="{FF2B5EF4-FFF2-40B4-BE49-F238E27FC236}">
+                <a16:creationId xmlns:a16="http://schemas.microsoft.com/office/drawing/2014/main" id="{359327B8-83C0-4826-9705-87F39F2BFC30}"/>
+              </a:ext>
+            </a:extLst>
+          </p:cNvPr>
+          <p:cNvSpPr>
+            <a:spLocks xmlns:a="http://schemas.openxmlformats.org/drawingml/2006/main" noGrp="1"/>
+          </p:cNvSpPr>
+          <p:nvPr/>
+        </p:nvSpPr>
+        <p:spPr>
+          <a:xfrm xmlns:a="http://schemas.openxmlformats.org/drawingml/2006/main">
+            <a:off x="11334750" y="6543675"/>
+            <a:ext cx="381000" cy="171450"/>
+          </a:xfrm>
+          <a:prstGeom xmlns:a="http://schemas.openxmlformats.org/drawingml/2006/main" prst="rect">
+            <a:avLst/>
+          </a:prstGeom>
+          <a:noFill xmlns:a="http://schemas.openxmlformats.org/drawingml/2006/main"/>
+          <a:ln xmlns:a="http://schemas.openxmlformats.org/drawingml/2006/main" w="0">
+            <a:noFill/>
+          </a:ln>
+        </p:spPr>
+        <p:txBody>
+          <a:bodyPr xmlns:a="http://schemas.openxmlformats.org/drawingml/2006/main">
+            <a:normAutofit fontScale="63636"/>
+          </a:bodyPr>
+          <a:lstStyle xmlns:a="http://schemas.openxmlformats.org/drawingml/2006/main"/>
+          <a:p xmlns:a="http://schemas.openxmlformats.org/drawingml/2006/main">
+            <a:pPr>
+              <a:defRPr sz="825" b="0">
+                <a:solidFill>
+                  <a:srgbClr val="142F43"/>
+                </a:solidFill>
+                <a:latin typeface="Microsoft JhengHei"/>
+                <a:ea typeface="Microsoft JhengHei"/>
+                <a:cs typeface="Microsoft JhengHei"/>
+              </a:defRPr>
+            </a:pPr>
+            <a:r>
+              <a:rPr sz="825" b="0">
+                <a:solidFill>
+                  <a:srgbClr val="142F43"/>
+                </a:solidFill>
+                <a:latin typeface="Microsoft JhengHei"/>
+                <a:ea typeface="Microsoft JhengHei"/>
+                <a:cs typeface="Microsoft JhengHei"/>
+              </a:rPr>
+              <a:t>13</a:t>
+            </a:r>
+          </a:p>
+        </p:txBody>
+      </p:sp>
       <p:sp>
         <p:nvSpPr>
           <p:cNvPr id="5" name="">
             <a:extLst xmlns:a="http://schemas.openxmlformats.org/drawingml/2006/main">
               <a:ext uri="{FF2B5EF4-FFF2-40B4-BE49-F238E27FC236}">
-                <a16:creationId xmlns:a16="http://schemas.microsoft.com/office/drawing/2014/main" id="{E7BC03BA-BAA7-4829-B6A5-AC8145BF22E0}"/>
+                <a16:creationId xmlns:a16="http://schemas.microsoft.com/office/drawing/2014/main" id="{F960B70B-F035-4B04-A321-DE2F57BB4E13}"/>
               </a:ext>
             </a:extLst>
           </p:cNvPr>
@@ -3781,7 +4188,7 @@
           <p:cNvPr id="7" name="">
             <a:extLst xmlns:a="http://schemas.openxmlformats.org/drawingml/2006/main">
               <a:ext uri="{FF2B5EF4-FFF2-40B4-BE49-F238E27FC236}">
-                <a16:creationId xmlns:a16="http://schemas.microsoft.com/office/drawing/2014/main" id="{67465EEF-2553-4B36-A006-89BDD098131D}"/>
+                <a16:creationId xmlns:a16="http://schemas.microsoft.com/office/drawing/2014/main" id="{48618F6B-73F6-4DF0-9582-24A61344881A}"/>
               </a:ext>
             </a:extLst>
           </p:cNvPr>
@@ -3838,7 +4245,7 @@
           <p:cNvPr id="8" name="">
             <a:extLst xmlns:a="http://schemas.openxmlformats.org/drawingml/2006/main">
               <a:ext uri="{FF2B5EF4-FFF2-40B4-BE49-F238E27FC236}">
-                <a16:creationId xmlns:a16="http://schemas.microsoft.com/office/drawing/2014/main" id="{158ED145-073F-44BC-A535-02A3E63E1818}"/>
+                <a16:creationId xmlns:a16="http://schemas.microsoft.com/office/drawing/2014/main" id="{D091CFC0-FBA9-4B3E-AD70-A1C8E3B44D33}"/>
               </a:ext>
             </a:extLst>
           </p:cNvPr>
@@ -3893,435 +4300,7 @@
     </p:spTree>
     <p:extLst>
       <p:ext uri="{BB962C8B-B14F-4D97-AF65-F5344CB8AC3E}">
-        <p14:creationId xmlns:p14="http://schemas.microsoft.com/office/powerpoint/2010/main" val="1078628514"/>
-      </p:ext>
-    </p:extLst>
-  </p:cSld>
-</p:sld>
-</file>
-
-<file path=ppt/slides/slide13.xml><?xml version="1.0" encoding="utf-8"?>
-<p:sld xmlns:p="http://schemas.openxmlformats.org/presentationml/2006/main">
-  <p:cSld>
-    <p:bg>
-      <p:bgPr>
-        <a:solidFill xmlns:a="http://schemas.openxmlformats.org/drawingml/2006/main">
-          <a:srgbClr val="FFFFFF"/>
-        </a:solidFill>
-      </p:bgPr>
-    </p:bg>
-    <p:spTree>
-      <p:nvGrpSpPr>
-        <p:cNvPr id="1" name=""/>
-        <p:cNvGrpSpPr/>
-        <p:nvPr/>
-      </p:nvGrpSpPr>
-      <p:grpSpPr>
-        <a:xfrm xmlns:a="http://schemas.openxmlformats.org/drawingml/2006/main"/>
-      </p:grpSpPr>
-      <p:sp>
-        <p:nvSpPr>
-          <p:cNvPr id="8" name="">
-            <a:extLst xmlns:a="http://schemas.openxmlformats.org/drawingml/2006/main">
-              <a:ext uri="{FF2B5EF4-FFF2-40B4-BE49-F238E27FC236}">
-                <a16:creationId xmlns:a16="http://schemas.microsoft.com/office/drawing/2014/main" id="{41678ED5-EAC8-47C3-83D1-9FF178B6FAC5}"/>
-              </a:ext>
-            </a:extLst>
-          </p:cNvPr>
-          <p:cNvSpPr>
-            <a:spLocks xmlns:a="http://schemas.openxmlformats.org/drawingml/2006/main" noGrp="1"/>
-          </p:cNvSpPr>
-          <p:nvPr/>
-        </p:nvSpPr>
-        <p:spPr>
-          <a:xfrm xmlns:a="http://schemas.openxmlformats.org/drawingml/2006/main">
-            <a:off x="476250" y="190500"/>
-            <a:ext cx="10477500" cy="209550"/>
-          </a:xfrm>
-          <a:prstGeom xmlns:a="http://schemas.openxmlformats.org/drawingml/2006/main" prst="rect">
-            <a:avLst/>
-          </a:prstGeom>
-          <a:noFill xmlns:a="http://schemas.openxmlformats.org/drawingml/2006/main"/>
-          <a:ln xmlns:a="http://schemas.openxmlformats.org/drawingml/2006/main" w="0">
-            <a:noFill/>
-          </a:ln>
-        </p:spPr>
-        <p:txBody>
-          <a:bodyPr xmlns:a="http://schemas.openxmlformats.org/drawingml/2006/main">
-            <a:normAutofit fontScale="79487"/>
-          </a:bodyPr>
-          <a:lstStyle xmlns:a="http://schemas.openxmlformats.org/drawingml/2006/main"/>
-          <a:p xmlns:a="http://schemas.openxmlformats.org/drawingml/2006/main">
-            <a:pPr>
-              <a:defRPr sz="975" b="1">
-                <a:solidFill>
-                  <a:srgbClr val="D55E00"/>
-                </a:solidFill>
-                <a:latin typeface="Microsoft JhengHei"/>
-                <a:ea typeface="Microsoft JhengHei"/>
-                <a:cs typeface="Microsoft JhengHei"/>
-              </a:defRPr>
-            </a:pPr>
-            <a:r>
-              <a:rPr sz="975" b="1">
-                <a:solidFill>
-                  <a:srgbClr val="D55E00"/>
-                </a:solidFill>
-                <a:latin typeface="Microsoft JhengHei"/>
-                <a:ea typeface="Microsoft JhengHei"/>
-                <a:cs typeface="Microsoft JhengHei"/>
-              </a:rPr>
-              <a:t>INTERPRETATION</a:t>
-            </a:r>
-          </a:p>
-        </p:txBody>
-      </p:sp>
-      <p:sp>
-        <p:nvSpPr>
-          <p:cNvPr id="2" name="">
-            <a:extLst xmlns:a="http://schemas.openxmlformats.org/drawingml/2006/main">
-              <a:ext uri="{FF2B5EF4-FFF2-40B4-BE49-F238E27FC236}">
-                <a16:creationId xmlns:a16="http://schemas.microsoft.com/office/drawing/2014/main" id="{5DCCD8A8-51A4-4D94-B940-D6CCE072FD56}"/>
-              </a:ext>
-            </a:extLst>
-          </p:cNvPr>
-          <p:cNvSpPr>
-            <a:spLocks xmlns:a="http://schemas.openxmlformats.org/drawingml/2006/main" noGrp="1"/>
-          </p:cNvSpPr>
-          <p:nvPr/>
-        </p:nvSpPr>
-        <p:spPr>
-          <a:xfrm xmlns:a="http://schemas.openxmlformats.org/drawingml/2006/main">
-            <a:off x="476250" y="523875"/>
-            <a:ext cx="11144250" cy="476250"/>
-          </a:xfrm>
-          <a:prstGeom xmlns:a="http://schemas.openxmlformats.org/drawingml/2006/main" prst="rect">
-            <a:avLst/>
-          </a:prstGeom>
-          <a:noFill xmlns:a="http://schemas.openxmlformats.org/drawingml/2006/main"/>
-          <a:ln xmlns:a="http://schemas.openxmlformats.org/drawingml/2006/main" w="0">
-            <a:noFill/>
-          </a:ln>
-        </p:spPr>
-        <p:txBody>
-          <a:bodyPr xmlns:a="http://schemas.openxmlformats.org/drawingml/2006/main">
-            <a:normAutofit fontScale="100000"/>
-          </a:bodyPr>
-          <a:lstStyle xmlns:a="http://schemas.openxmlformats.org/drawingml/2006/main"/>
-          <a:p xmlns:a="http://schemas.openxmlformats.org/drawingml/2006/main">
-            <a:pPr>
-              <a:defRPr sz="2400" b="1">
-                <a:solidFill>
-                  <a:srgbClr val="142F43"/>
-                </a:solidFill>
-                <a:latin typeface="Microsoft JhengHei"/>
-                <a:ea typeface="Microsoft JhengHei"/>
-                <a:cs typeface="Microsoft JhengHei"/>
-              </a:defRPr>
-            </a:pPr>
-            <a:r>
-              <a:rPr sz="2400" b="1">
-                <a:solidFill>
-                  <a:srgbClr val="142F43"/>
-                </a:solidFill>
-                <a:latin typeface="Microsoft JhengHei"/>
-                <a:ea typeface="Microsoft JhengHei"/>
-                <a:cs typeface="Microsoft JhengHei"/>
-              </a:rPr>
-              <a:t>生物意義與待驗證問題</a:t>
-            </a:r>
-          </a:p>
-        </p:txBody>
-      </p:sp>
-      <p:sp>
-        <p:nvSpPr>
-          <p:cNvPr id="3" name="">
-            <a:extLst xmlns:a="http://schemas.openxmlformats.org/drawingml/2006/main">
-              <a:ext uri="{FF2B5EF4-FFF2-40B4-BE49-F238E27FC236}">
-                <a16:creationId xmlns:a16="http://schemas.microsoft.com/office/drawing/2014/main" id="{5C8AA5BD-8D05-480C-B80D-F1DB047F262D}"/>
-              </a:ext>
-            </a:extLst>
-          </p:cNvPr>
-          <p:cNvSpPr>
-            <a:spLocks xmlns:a="http://schemas.openxmlformats.org/drawingml/2006/main" noGrp="1"/>
-          </p:cNvSpPr>
-          <p:nvPr/>
-        </p:nvSpPr>
-        <p:spPr>
-          <a:xfrm xmlns:a="http://schemas.openxmlformats.org/drawingml/2006/main">
-            <a:off x="476250" y="6543675"/>
-            <a:ext cx="10287000" cy="171450"/>
-          </a:xfrm>
-          <a:prstGeom xmlns:a="http://schemas.openxmlformats.org/drawingml/2006/main" prst="rect">
-            <a:avLst/>
-          </a:prstGeom>
-          <a:noFill xmlns:a="http://schemas.openxmlformats.org/drawingml/2006/main"/>
-          <a:ln xmlns:a="http://schemas.openxmlformats.org/drawingml/2006/main" w="0">
-            <a:noFill/>
-          </a:ln>
-        </p:spPr>
-        <p:txBody>
-          <a:bodyPr xmlns:a="http://schemas.openxmlformats.org/drawingml/2006/main">
-            <a:normAutofit fontScale="63636"/>
-          </a:bodyPr>
-          <a:lstStyle xmlns:a="http://schemas.openxmlformats.org/drawingml/2006/main"/>
-          <a:p xmlns:a="http://schemas.openxmlformats.org/drawingml/2006/main">
-            <a:pPr>
-              <a:defRPr sz="825" b="0">
-                <a:solidFill>
-                  <a:srgbClr val="4D5B66"/>
-                </a:solidFill>
-                <a:latin typeface="Microsoft JhengHei"/>
-                <a:ea typeface="Microsoft JhengHei"/>
-                <a:cs typeface="Microsoft JhengHei"/>
-              </a:defRPr>
-            </a:pPr>
-            <a:r>
-              <a:rPr sz="825" b="0">
-                <a:solidFill>
-                  <a:srgbClr val="4D5B66"/>
-                </a:solidFill>
-                <a:latin typeface="Microsoft JhengHei"/>
-                <a:ea typeface="Microsoft JhengHei"/>
-                <a:cs typeface="Microsoft JhengHei"/>
-              </a:rPr>
-              <a:t>GSE262271 / GSE218858  |  Reviewed 15 September 2026</a:t>
-            </a:r>
-          </a:p>
-        </p:txBody>
-      </p:sp>
-      <p:sp>
-        <p:nvSpPr>
-          <p:cNvPr id="4" name="">
-            <a:extLst xmlns:a="http://schemas.openxmlformats.org/drawingml/2006/main">
-              <a:ext uri="{FF2B5EF4-FFF2-40B4-BE49-F238E27FC236}">
-                <a16:creationId xmlns:a16="http://schemas.microsoft.com/office/drawing/2014/main" id="{71503BDF-C64F-4677-BCCF-B58C4A7203EE}"/>
-              </a:ext>
-            </a:extLst>
-          </p:cNvPr>
-          <p:cNvSpPr>
-            <a:spLocks xmlns:a="http://schemas.openxmlformats.org/drawingml/2006/main" noGrp="1"/>
-          </p:cNvSpPr>
-          <p:nvPr/>
-        </p:nvSpPr>
-        <p:spPr>
-          <a:xfrm xmlns:a="http://schemas.openxmlformats.org/drawingml/2006/main">
-            <a:off x="11334750" y="6543675"/>
-            <a:ext cx="381000" cy="171450"/>
-          </a:xfrm>
-          <a:prstGeom xmlns:a="http://schemas.openxmlformats.org/drawingml/2006/main" prst="rect">
-            <a:avLst/>
-          </a:prstGeom>
-          <a:noFill xmlns:a="http://schemas.openxmlformats.org/drawingml/2006/main"/>
-          <a:ln xmlns:a="http://schemas.openxmlformats.org/drawingml/2006/main" w="0">
-            <a:noFill/>
-          </a:ln>
-        </p:spPr>
-        <p:txBody>
-          <a:bodyPr xmlns:a="http://schemas.openxmlformats.org/drawingml/2006/main">
-            <a:normAutofit fontScale="63636"/>
-          </a:bodyPr>
-          <a:lstStyle xmlns:a="http://schemas.openxmlformats.org/drawingml/2006/main"/>
-          <a:p xmlns:a="http://schemas.openxmlformats.org/drawingml/2006/main">
-            <a:pPr>
-              <a:defRPr sz="825" b="0">
-                <a:solidFill>
-                  <a:srgbClr val="142F43"/>
-                </a:solidFill>
-                <a:latin typeface="Microsoft JhengHei"/>
-                <a:ea typeface="Microsoft JhengHei"/>
-                <a:cs typeface="Microsoft JhengHei"/>
-              </a:defRPr>
-            </a:pPr>
-            <a:r>
-              <a:rPr sz="825" b="0">
-                <a:solidFill>
-                  <a:srgbClr val="142F43"/>
-                </a:solidFill>
-                <a:latin typeface="Microsoft JhengHei"/>
-                <a:ea typeface="Microsoft JhengHei"/>
-                <a:cs typeface="Microsoft JhengHei"/>
-              </a:rPr>
-              <a:t>13</a:t>
-            </a:r>
-          </a:p>
-        </p:txBody>
-      </p:sp>
-      <p:sp>
-        <p:nvSpPr>
-          <p:cNvPr id="5" name="">
-            <a:extLst xmlns:a="http://schemas.openxmlformats.org/drawingml/2006/main">
-              <a:ext uri="{FF2B5EF4-FFF2-40B4-BE49-F238E27FC236}">
-                <a16:creationId xmlns:a16="http://schemas.microsoft.com/office/drawing/2014/main" id="{B9EF9F9D-40E9-4AF5-89B7-B9B364D0E26E}"/>
-              </a:ext>
-            </a:extLst>
-          </p:cNvPr>
-          <p:cNvSpPr>
-            <a:spLocks xmlns:a="http://schemas.openxmlformats.org/drawingml/2006/main" noGrp="1"/>
-          </p:cNvSpPr>
-          <p:nvPr/>
-        </p:nvSpPr>
-        <p:spPr>
-          <a:xfrm xmlns:a="http://schemas.openxmlformats.org/drawingml/2006/main">
-            <a:off x="619125" y="1428750"/>
-            <a:ext cx="10668000" cy="1000125"/>
-          </a:xfrm>
-          <a:prstGeom xmlns:a="http://schemas.openxmlformats.org/drawingml/2006/main" prst="rect">
-            <a:avLst/>
-          </a:prstGeom>
-          <a:noFill xmlns:a="http://schemas.openxmlformats.org/drawingml/2006/main"/>
-          <a:ln xmlns:a="http://schemas.openxmlformats.org/drawingml/2006/main" w="0">
-            <a:noFill/>
-          </a:ln>
-        </p:spPr>
-        <p:txBody>
-          <a:bodyPr xmlns:a="http://schemas.openxmlformats.org/drawingml/2006/main">
-            <a:normAutofit fontScale="100000"/>
-          </a:bodyPr>
-          <a:lstStyle xmlns:a="http://schemas.openxmlformats.org/drawingml/2006/main"/>
-          <a:p xmlns:a="http://schemas.openxmlformats.org/drawingml/2006/main">
-            <a:pPr>
-              <a:defRPr sz="2175" b="1">
-                <a:solidFill>
-                  <a:srgbClr val="142F43"/>
-                </a:solidFill>
-                <a:latin typeface="Microsoft JhengHei"/>
-                <a:ea typeface="Microsoft JhengHei"/>
-                <a:cs typeface="Microsoft JhengHei"/>
-              </a:defRPr>
-            </a:pPr>
-            <a:r>
-              <a:rPr sz="2175" b="1">
-                <a:solidFill>
-                  <a:srgbClr val="142F43"/>
-                </a:solidFill>
-                <a:latin typeface="Microsoft JhengHei"/>
-                <a:ea typeface="Microsoft JhengHei"/>
-                <a:cs typeface="Microsoft JhengHei"/>
-              </a:rPr>
-              <a:t>共同富集支持：復發與 STAT5B 活化可能伴隨相似的蛋白質穩態與代謝程式。</a:t>
-            </a:r>
-          </a:p>
-        </p:txBody>
-      </p:sp>
-      <p:sp>
-        <p:nvSpPr>
-          <p:cNvPr id="6" name="">
-            <a:extLst xmlns:a="http://schemas.openxmlformats.org/drawingml/2006/main">
-              <a:ext uri="{FF2B5EF4-FFF2-40B4-BE49-F238E27FC236}">
-                <a16:creationId xmlns:a16="http://schemas.microsoft.com/office/drawing/2014/main" id="{33E8C953-0726-4F5C-AF81-ACEEDCD3E75F}"/>
-              </a:ext>
-            </a:extLst>
-          </p:cNvPr>
-          <p:cNvSpPr>
-            <a:spLocks xmlns:a="http://schemas.openxmlformats.org/drawingml/2006/main" noGrp="1"/>
-          </p:cNvSpPr>
-          <p:nvPr/>
-        </p:nvSpPr>
-        <p:spPr>
-          <a:xfrm xmlns:a="http://schemas.openxmlformats.org/drawingml/2006/main">
-            <a:off x="619125" y="2952750"/>
-            <a:ext cx="10668000" cy="1285875"/>
-          </a:xfrm>
-          <a:prstGeom xmlns:a="http://schemas.openxmlformats.org/drawingml/2006/main" prst="rect">
-            <a:avLst/>
-          </a:prstGeom>
-          <a:noFill xmlns:a="http://schemas.openxmlformats.org/drawingml/2006/main"/>
-          <a:ln xmlns:a="http://schemas.openxmlformats.org/drawingml/2006/main" w="0">
-            <a:noFill/>
-          </a:ln>
-        </p:spPr>
-        <p:txBody>
-          <a:bodyPr xmlns:a="http://schemas.openxmlformats.org/drawingml/2006/main">
-            <a:normAutofit fontScale="100000"/>
-          </a:bodyPr>
-          <a:lstStyle xmlns:a="http://schemas.openxmlformats.org/drawingml/2006/main"/>
-          <a:p xmlns:a="http://schemas.openxmlformats.org/drawingml/2006/main">
-            <a:pPr>
-              <a:defRPr sz="1950" b="0">
-                <a:solidFill>
-                  <a:srgbClr val="142F43"/>
-                </a:solidFill>
-                <a:latin typeface="Microsoft JhengHei"/>
-                <a:ea typeface="Microsoft JhengHei"/>
-                <a:cs typeface="Microsoft JhengHei"/>
-              </a:defRPr>
-            </a:pPr>
-            <a:r>
-              <a:rPr sz="1950" b="0">
-                <a:solidFill>
-                  <a:srgbClr val="142F43"/>
-                </a:solidFill>
-                <a:latin typeface="Microsoft JhengHei"/>
-                <a:ea typeface="Microsoft JhengHei"/>
-                <a:cs typeface="Microsoft JhengHei"/>
-              </a:rPr>
-              <a:t>Proteasome / mitophagy 的 transcript enrichment 可以用來形成後續假說。它尚未證明蛋白質降解活性、mitophagy flux 或 STAT5 的粒線體定位。</a:t>
-            </a:r>
-          </a:p>
-        </p:txBody>
-      </p:sp>
-      <p:sp>
-        <p:nvSpPr>
-          <p:cNvPr id="7" name="">
-            <a:extLst xmlns:a="http://schemas.openxmlformats.org/drawingml/2006/main">
-              <a:ext uri="{FF2B5EF4-FFF2-40B4-BE49-F238E27FC236}">
-                <a16:creationId xmlns:a16="http://schemas.microsoft.com/office/drawing/2014/main" id="{84A85ABF-F71C-43AB-99E2-BC8911647396}"/>
-              </a:ext>
-            </a:extLst>
-          </p:cNvPr>
-          <p:cNvSpPr>
-            <a:spLocks xmlns:a="http://schemas.openxmlformats.org/drawingml/2006/main" noGrp="1"/>
-          </p:cNvSpPr>
-          <p:nvPr/>
-        </p:nvSpPr>
-        <p:spPr>
-          <a:xfrm xmlns:a="http://schemas.openxmlformats.org/drawingml/2006/main">
-            <a:off x="619125" y="4791075"/>
-            <a:ext cx="10668000" cy="1190625"/>
-          </a:xfrm>
-          <a:prstGeom xmlns:a="http://schemas.openxmlformats.org/drawingml/2006/main" prst="rect">
-            <a:avLst/>
-          </a:prstGeom>
-          <a:noFill xmlns:a="http://schemas.openxmlformats.org/drawingml/2006/main"/>
-          <a:ln xmlns:a="http://schemas.openxmlformats.org/drawingml/2006/main" w="0">
-            <a:noFill/>
-          </a:ln>
-        </p:spPr>
-        <p:txBody>
-          <a:bodyPr xmlns:a="http://schemas.openxmlformats.org/drawingml/2006/main">
-            <a:normAutofit fontScale="100000"/>
-          </a:bodyPr>
-          <a:lstStyle xmlns:a="http://schemas.openxmlformats.org/drawingml/2006/main"/>
-          <a:p xmlns:a="http://schemas.openxmlformats.org/drawingml/2006/main">
-            <a:pPr>
-              <a:defRPr sz="1875" b="0">
-                <a:solidFill>
-                  <a:srgbClr val="D55E00"/>
-                </a:solidFill>
-                <a:latin typeface="Microsoft JhengHei"/>
-                <a:ea typeface="Microsoft JhengHei"/>
-                <a:cs typeface="Microsoft JhengHei"/>
-              </a:defRPr>
-            </a:pPr>
-            <a:r>
-              <a:rPr sz="1875" b="0">
-                <a:solidFill>
-                  <a:srgbClr val="D55E00"/>
-                </a:solidFill>
-                <a:latin typeface="Microsoft JhengHei"/>
-                <a:ea typeface="Microsoft JhengHei"/>
-                <a:cs typeface="Microsoft JhengHei"/>
-              </a:rPr>
-              <a:t>這兩組資料也沒有直接比較 bortezomib responder 與 resistant samples，因此不能從交集直接推論 proteasome inhibitor resistance。</a:t>
-            </a:r>
-          </a:p>
-        </p:txBody>
-      </p:sp>
-    </p:spTree>
-    <p:extLst>
-      <p:ext uri="{BB962C8B-B14F-4D97-AF65-F5344CB8AC3E}">
-        <p14:creationId xmlns:p14="http://schemas.microsoft.com/office/powerpoint/2010/main" val="1428910776"/>
+        <p14:creationId xmlns:p14="http://schemas.microsoft.com/office/powerpoint/2010/main" val="1116444970"/>
       </p:ext>
     </p:extLst>
   </p:cSld>
@@ -4352,7 +4331,7 @@
           <p:cNvPr id="8" name="">
             <a:extLst xmlns:a="http://schemas.openxmlformats.org/drawingml/2006/main">
               <a:ext uri="{FF2B5EF4-FFF2-40B4-BE49-F238E27FC236}">
-                <a16:creationId xmlns:a16="http://schemas.microsoft.com/office/drawing/2014/main" id="{B636F826-3F4A-4AF4-93AB-DB9310AD131F}"/>
+                <a16:creationId xmlns:a16="http://schemas.microsoft.com/office/drawing/2014/main" id="{1F97F416-7675-4BBF-9CBB-B2C9C1DAB26D}"/>
               </a:ext>
             </a:extLst>
           </p:cNvPr>
@@ -4399,7 +4378,7 @@
                 <a:ea typeface="Microsoft JhengHei"/>
                 <a:cs typeface="Microsoft JhengHei"/>
               </a:rPr>
-              <a:t>HANDOFF</a:t>
+              <a:t>INTERPRETATION</a:t>
             </a:r>
           </a:p>
         </p:txBody>
@@ -4409,7 +4388,7 @@
           <p:cNvPr id="2" name="">
             <a:extLst xmlns:a="http://schemas.openxmlformats.org/drawingml/2006/main">
               <a:ext uri="{FF2B5EF4-FFF2-40B4-BE49-F238E27FC236}">
-                <a16:creationId xmlns:a16="http://schemas.microsoft.com/office/drawing/2014/main" id="{63D410B5-0D76-4248-8019-D8988B7C500D}"/>
+                <a16:creationId xmlns:a16="http://schemas.microsoft.com/office/drawing/2014/main" id="{26DADC63-782C-4170-AC67-09EFD30EE3D8}"/>
               </a:ext>
             </a:extLst>
           </p:cNvPr>
@@ -4456,7 +4435,7 @@
                 <a:ea typeface="Microsoft JhengHei"/>
                 <a:cs typeface="Microsoft JhengHei"/>
               </a:rPr>
-              <a:t>交接檔案與可重現性</a:t>
+              <a:t>生物意義與待驗證問題</a:t>
             </a:r>
           </a:p>
         </p:txBody>
@@ -4466,7 +4445,7 @@
           <p:cNvPr id="3" name="">
             <a:extLst xmlns:a="http://schemas.openxmlformats.org/drawingml/2006/main">
               <a:ext uri="{FF2B5EF4-FFF2-40B4-BE49-F238E27FC236}">
-                <a16:creationId xmlns:a16="http://schemas.microsoft.com/office/drawing/2014/main" id="{B474F5DE-0917-41A3-8098-26B595BD082A}"/>
+                <a16:creationId xmlns:a16="http://schemas.microsoft.com/office/drawing/2014/main" id="{25D14D91-BF95-40EF-AA52-BDB2ED23ECE6}"/>
               </a:ext>
             </a:extLst>
           </p:cNvPr>
@@ -4523,7 +4502,7 @@
           <p:cNvPr id="4" name="">
             <a:extLst xmlns:a="http://schemas.openxmlformats.org/drawingml/2006/main">
               <a:ext uri="{FF2B5EF4-FFF2-40B4-BE49-F238E27FC236}">
-                <a16:creationId xmlns:a16="http://schemas.microsoft.com/office/drawing/2014/main" id="{806FB2D0-3099-4D8A-9968-CE88BB0ADA64}"/>
+                <a16:creationId xmlns:a16="http://schemas.microsoft.com/office/drawing/2014/main" id="{526BDCE2-2A62-483A-81C4-0F6F332561DD}"/>
               </a:ext>
             </a:extLst>
           </p:cNvPr>
@@ -4571,6 +4550,434 @@
                 <a:cs typeface="Microsoft JhengHei"/>
               </a:rPr>
               <a:t>14</a:t>
+            </a:r>
+          </a:p>
+        </p:txBody>
+      </p:sp>
+      <p:sp>
+        <p:nvSpPr>
+          <p:cNvPr id="5" name="">
+            <a:extLst xmlns:a="http://schemas.openxmlformats.org/drawingml/2006/main">
+              <a:ext uri="{FF2B5EF4-FFF2-40B4-BE49-F238E27FC236}">
+                <a16:creationId xmlns:a16="http://schemas.microsoft.com/office/drawing/2014/main" id="{811B6381-9765-4E66-B3AF-6C2AAC391449}"/>
+              </a:ext>
+            </a:extLst>
+          </p:cNvPr>
+          <p:cNvSpPr>
+            <a:spLocks xmlns:a="http://schemas.openxmlformats.org/drawingml/2006/main" noGrp="1"/>
+          </p:cNvSpPr>
+          <p:nvPr/>
+        </p:nvSpPr>
+        <p:spPr>
+          <a:xfrm xmlns:a="http://schemas.openxmlformats.org/drawingml/2006/main">
+            <a:off x="619125" y="1428750"/>
+            <a:ext cx="10668000" cy="1000125"/>
+          </a:xfrm>
+          <a:prstGeom xmlns:a="http://schemas.openxmlformats.org/drawingml/2006/main" prst="rect">
+            <a:avLst/>
+          </a:prstGeom>
+          <a:noFill xmlns:a="http://schemas.openxmlformats.org/drawingml/2006/main"/>
+          <a:ln xmlns:a="http://schemas.openxmlformats.org/drawingml/2006/main" w="0">
+            <a:noFill/>
+          </a:ln>
+        </p:spPr>
+        <p:txBody>
+          <a:bodyPr xmlns:a="http://schemas.openxmlformats.org/drawingml/2006/main">
+            <a:normAutofit fontScale="100000"/>
+          </a:bodyPr>
+          <a:lstStyle xmlns:a="http://schemas.openxmlformats.org/drawingml/2006/main"/>
+          <a:p xmlns:a="http://schemas.openxmlformats.org/drawingml/2006/main">
+            <a:pPr>
+              <a:defRPr sz="2175" b="1">
+                <a:solidFill>
+                  <a:srgbClr val="142F43"/>
+                </a:solidFill>
+                <a:latin typeface="Microsoft JhengHei"/>
+                <a:ea typeface="Microsoft JhengHei"/>
+                <a:cs typeface="Microsoft JhengHei"/>
+              </a:defRPr>
+            </a:pPr>
+            <a:r>
+              <a:rPr sz="2175" b="1">
+                <a:solidFill>
+                  <a:srgbClr val="142F43"/>
+                </a:solidFill>
+                <a:latin typeface="Microsoft JhengHei"/>
+                <a:ea typeface="Microsoft JhengHei"/>
+                <a:cs typeface="Microsoft JhengHei"/>
+              </a:rPr>
+              <a:t>共同富集支持：復發與 STAT5B 活化可能伴隨相似的蛋白質穩態與代謝程式。</a:t>
+            </a:r>
+          </a:p>
+        </p:txBody>
+      </p:sp>
+      <p:sp>
+        <p:nvSpPr>
+          <p:cNvPr id="6" name="">
+            <a:extLst xmlns:a="http://schemas.openxmlformats.org/drawingml/2006/main">
+              <a:ext uri="{FF2B5EF4-FFF2-40B4-BE49-F238E27FC236}">
+                <a16:creationId xmlns:a16="http://schemas.microsoft.com/office/drawing/2014/main" id="{D3B13E93-F698-4527-9C07-2BE3F971BFE1}"/>
+              </a:ext>
+            </a:extLst>
+          </p:cNvPr>
+          <p:cNvSpPr>
+            <a:spLocks xmlns:a="http://schemas.openxmlformats.org/drawingml/2006/main" noGrp="1"/>
+          </p:cNvSpPr>
+          <p:nvPr/>
+        </p:nvSpPr>
+        <p:spPr>
+          <a:xfrm xmlns:a="http://schemas.openxmlformats.org/drawingml/2006/main">
+            <a:off x="619125" y="2952750"/>
+            <a:ext cx="10668000" cy="1285875"/>
+          </a:xfrm>
+          <a:prstGeom xmlns:a="http://schemas.openxmlformats.org/drawingml/2006/main" prst="rect">
+            <a:avLst/>
+          </a:prstGeom>
+          <a:noFill xmlns:a="http://schemas.openxmlformats.org/drawingml/2006/main"/>
+          <a:ln xmlns:a="http://schemas.openxmlformats.org/drawingml/2006/main" w="0">
+            <a:noFill/>
+          </a:ln>
+        </p:spPr>
+        <p:txBody>
+          <a:bodyPr xmlns:a="http://schemas.openxmlformats.org/drawingml/2006/main">
+            <a:normAutofit fontScale="100000"/>
+          </a:bodyPr>
+          <a:lstStyle xmlns:a="http://schemas.openxmlformats.org/drawingml/2006/main"/>
+          <a:p xmlns:a="http://schemas.openxmlformats.org/drawingml/2006/main">
+            <a:pPr>
+              <a:defRPr sz="1950" b="0">
+                <a:solidFill>
+                  <a:srgbClr val="142F43"/>
+                </a:solidFill>
+                <a:latin typeface="Microsoft JhengHei"/>
+                <a:ea typeface="Microsoft JhengHei"/>
+                <a:cs typeface="Microsoft JhengHei"/>
+              </a:defRPr>
+            </a:pPr>
+            <a:r>
+              <a:rPr sz="1950" b="0">
+                <a:solidFill>
+                  <a:srgbClr val="142F43"/>
+                </a:solidFill>
+                <a:latin typeface="Microsoft JhengHei"/>
+                <a:ea typeface="Microsoft JhengHei"/>
+                <a:cs typeface="Microsoft JhengHei"/>
+              </a:rPr>
+              <a:t>Proteasome / mitophagy 的 transcript enrichment 可以用來形成後續假說。它尚未證明蛋白質降解活性、mitophagy flux 或 STAT5 的粒線體定位。</a:t>
+            </a:r>
+          </a:p>
+        </p:txBody>
+      </p:sp>
+      <p:sp>
+        <p:nvSpPr>
+          <p:cNvPr id="7" name="">
+            <a:extLst xmlns:a="http://schemas.openxmlformats.org/drawingml/2006/main">
+              <a:ext uri="{FF2B5EF4-FFF2-40B4-BE49-F238E27FC236}">
+                <a16:creationId xmlns:a16="http://schemas.microsoft.com/office/drawing/2014/main" id="{8A0401EC-5B75-4BCC-AC53-985909101359}"/>
+              </a:ext>
+            </a:extLst>
+          </p:cNvPr>
+          <p:cNvSpPr>
+            <a:spLocks xmlns:a="http://schemas.openxmlformats.org/drawingml/2006/main" noGrp="1"/>
+          </p:cNvSpPr>
+          <p:nvPr/>
+        </p:nvSpPr>
+        <p:spPr>
+          <a:xfrm xmlns:a="http://schemas.openxmlformats.org/drawingml/2006/main">
+            <a:off x="619125" y="4791075"/>
+            <a:ext cx="10668000" cy="1190625"/>
+          </a:xfrm>
+          <a:prstGeom xmlns:a="http://schemas.openxmlformats.org/drawingml/2006/main" prst="rect">
+            <a:avLst/>
+          </a:prstGeom>
+          <a:noFill xmlns:a="http://schemas.openxmlformats.org/drawingml/2006/main"/>
+          <a:ln xmlns:a="http://schemas.openxmlformats.org/drawingml/2006/main" w="0">
+            <a:noFill/>
+          </a:ln>
+        </p:spPr>
+        <p:txBody>
+          <a:bodyPr xmlns:a="http://schemas.openxmlformats.org/drawingml/2006/main">
+            <a:normAutofit fontScale="100000"/>
+          </a:bodyPr>
+          <a:lstStyle xmlns:a="http://schemas.openxmlformats.org/drawingml/2006/main"/>
+          <a:p xmlns:a="http://schemas.openxmlformats.org/drawingml/2006/main">
+            <a:pPr>
+              <a:defRPr sz="1875" b="0">
+                <a:solidFill>
+                  <a:srgbClr val="D55E00"/>
+                </a:solidFill>
+                <a:latin typeface="Microsoft JhengHei"/>
+                <a:ea typeface="Microsoft JhengHei"/>
+                <a:cs typeface="Microsoft JhengHei"/>
+              </a:defRPr>
+            </a:pPr>
+            <a:r>
+              <a:rPr sz="1875" b="0">
+                <a:solidFill>
+                  <a:srgbClr val="D55E00"/>
+                </a:solidFill>
+                <a:latin typeface="Microsoft JhengHei"/>
+                <a:ea typeface="Microsoft JhengHei"/>
+                <a:cs typeface="Microsoft JhengHei"/>
+              </a:rPr>
+              <a:t>這兩組資料也沒有直接比較 bortezomib responder 與 resistant samples，因此不能從交集直接推論 proteasome inhibitor resistance。</a:t>
+            </a:r>
+          </a:p>
+        </p:txBody>
+      </p:sp>
+    </p:spTree>
+    <p:extLst>
+      <p:ext uri="{BB962C8B-B14F-4D97-AF65-F5344CB8AC3E}">
+        <p14:creationId xmlns:p14="http://schemas.microsoft.com/office/powerpoint/2010/main" val="101256378"/>
+      </p:ext>
+    </p:extLst>
+  </p:cSld>
+</p:sld>
+</file>
+
+<file path=ppt/slides/slide15.xml><?xml version="1.0" encoding="utf-8"?>
+<p:sld xmlns:p="http://schemas.openxmlformats.org/presentationml/2006/main">
+  <p:cSld>
+    <p:bg>
+      <p:bgPr>
+        <a:solidFill xmlns:a="http://schemas.openxmlformats.org/drawingml/2006/main">
+          <a:srgbClr val="FFFFFF"/>
+        </a:solidFill>
+      </p:bgPr>
+    </p:bg>
+    <p:spTree>
+      <p:nvGrpSpPr>
+        <p:cNvPr id="1" name=""/>
+        <p:cNvGrpSpPr/>
+        <p:nvPr/>
+      </p:nvGrpSpPr>
+      <p:grpSpPr>
+        <a:xfrm xmlns:a="http://schemas.openxmlformats.org/drawingml/2006/main"/>
+      </p:grpSpPr>
+      <p:sp>
+        <p:nvSpPr>
+          <p:cNvPr id="8" name="">
+            <a:extLst xmlns:a="http://schemas.openxmlformats.org/drawingml/2006/main">
+              <a:ext uri="{FF2B5EF4-FFF2-40B4-BE49-F238E27FC236}">
+                <a16:creationId xmlns:a16="http://schemas.microsoft.com/office/drawing/2014/main" id="{AC42142E-187C-421B-88AA-33A1F86C41CD}"/>
+              </a:ext>
+            </a:extLst>
+          </p:cNvPr>
+          <p:cNvSpPr>
+            <a:spLocks xmlns:a="http://schemas.openxmlformats.org/drawingml/2006/main" noGrp="1"/>
+          </p:cNvSpPr>
+          <p:nvPr/>
+        </p:nvSpPr>
+        <p:spPr>
+          <a:xfrm xmlns:a="http://schemas.openxmlformats.org/drawingml/2006/main">
+            <a:off x="476250" y="190500"/>
+            <a:ext cx="10477500" cy="209550"/>
+          </a:xfrm>
+          <a:prstGeom xmlns:a="http://schemas.openxmlformats.org/drawingml/2006/main" prst="rect">
+            <a:avLst/>
+          </a:prstGeom>
+          <a:noFill xmlns:a="http://schemas.openxmlformats.org/drawingml/2006/main"/>
+          <a:ln xmlns:a="http://schemas.openxmlformats.org/drawingml/2006/main" w="0">
+            <a:noFill/>
+          </a:ln>
+        </p:spPr>
+        <p:txBody>
+          <a:bodyPr xmlns:a="http://schemas.openxmlformats.org/drawingml/2006/main">
+            <a:normAutofit fontScale="79487"/>
+          </a:bodyPr>
+          <a:lstStyle xmlns:a="http://schemas.openxmlformats.org/drawingml/2006/main"/>
+          <a:p xmlns:a="http://schemas.openxmlformats.org/drawingml/2006/main">
+            <a:pPr>
+              <a:defRPr sz="975" b="1">
+                <a:solidFill>
+                  <a:srgbClr val="D55E00"/>
+                </a:solidFill>
+                <a:latin typeface="Microsoft JhengHei"/>
+                <a:ea typeface="Microsoft JhengHei"/>
+                <a:cs typeface="Microsoft JhengHei"/>
+              </a:defRPr>
+            </a:pPr>
+            <a:r>
+              <a:rPr sz="975" b="1">
+                <a:solidFill>
+                  <a:srgbClr val="D55E00"/>
+                </a:solidFill>
+                <a:latin typeface="Microsoft JhengHei"/>
+                <a:ea typeface="Microsoft JhengHei"/>
+                <a:cs typeface="Microsoft JhengHei"/>
+              </a:rPr>
+              <a:t>HANDOFF</a:t>
+            </a:r>
+          </a:p>
+        </p:txBody>
+      </p:sp>
+      <p:sp>
+        <p:nvSpPr>
+          <p:cNvPr id="2" name="">
+            <a:extLst xmlns:a="http://schemas.openxmlformats.org/drawingml/2006/main">
+              <a:ext uri="{FF2B5EF4-FFF2-40B4-BE49-F238E27FC236}">
+                <a16:creationId xmlns:a16="http://schemas.microsoft.com/office/drawing/2014/main" id="{E09E0294-989D-4F9F-9EC6-86177B325AD3}"/>
+              </a:ext>
+            </a:extLst>
+          </p:cNvPr>
+          <p:cNvSpPr>
+            <a:spLocks xmlns:a="http://schemas.openxmlformats.org/drawingml/2006/main" noGrp="1"/>
+          </p:cNvSpPr>
+          <p:nvPr/>
+        </p:nvSpPr>
+        <p:spPr>
+          <a:xfrm xmlns:a="http://schemas.openxmlformats.org/drawingml/2006/main">
+            <a:off x="476250" y="523875"/>
+            <a:ext cx="11144250" cy="476250"/>
+          </a:xfrm>
+          <a:prstGeom xmlns:a="http://schemas.openxmlformats.org/drawingml/2006/main" prst="rect">
+            <a:avLst/>
+          </a:prstGeom>
+          <a:noFill xmlns:a="http://schemas.openxmlformats.org/drawingml/2006/main"/>
+          <a:ln xmlns:a="http://schemas.openxmlformats.org/drawingml/2006/main" w="0">
+            <a:noFill/>
+          </a:ln>
+        </p:spPr>
+        <p:txBody>
+          <a:bodyPr xmlns:a="http://schemas.openxmlformats.org/drawingml/2006/main">
+            <a:normAutofit fontScale="100000"/>
+          </a:bodyPr>
+          <a:lstStyle xmlns:a="http://schemas.openxmlformats.org/drawingml/2006/main"/>
+          <a:p xmlns:a="http://schemas.openxmlformats.org/drawingml/2006/main">
+            <a:pPr>
+              <a:defRPr sz="2400" b="1">
+                <a:solidFill>
+                  <a:srgbClr val="142F43"/>
+                </a:solidFill>
+                <a:latin typeface="Microsoft JhengHei"/>
+                <a:ea typeface="Microsoft JhengHei"/>
+                <a:cs typeface="Microsoft JhengHei"/>
+              </a:defRPr>
+            </a:pPr>
+            <a:r>
+              <a:rPr sz="2400" b="1">
+                <a:solidFill>
+                  <a:srgbClr val="142F43"/>
+                </a:solidFill>
+                <a:latin typeface="Microsoft JhengHei"/>
+                <a:ea typeface="Microsoft JhengHei"/>
+                <a:cs typeface="Microsoft JhengHei"/>
+              </a:rPr>
+              <a:t>交接檔案與可重現性</a:t>
+            </a:r>
+          </a:p>
+        </p:txBody>
+      </p:sp>
+      <p:sp>
+        <p:nvSpPr>
+          <p:cNvPr id="3" name="">
+            <a:extLst xmlns:a="http://schemas.openxmlformats.org/drawingml/2006/main">
+              <a:ext uri="{FF2B5EF4-FFF2-40B4-BE49-F238E27FC236}">
+                <a16:creationId xmlns:a16="http://schemas.microsoft.com/office/drawing/2014/main" id="{021DC6B3-B741-4867-B135-E6605236CCCC}"/>
+              </a:ext>
+            </a:extLst>
+          </p:cNvPr>
+          <p:cNvSpPr>
+            <a:spLocks xmlns:a="http://schemas.openxmlformats.org/drawingml/2006/main" noGrp="1"/>
+          </p:cNvSpPr>
+          <p:nvPr/>
+        </p:nvSpPr>
+        <p:spPr>
+          <a:xfrm xmlns:a="http://schemas.openxmlformats.org/drawingml/2006/main">
+            <a:off x="476250" y="6543675"/>
+            <a:ext cx="10287000" cy="171450"/>
+          </a:xfrm>
+          <a:prstGeom xmlns:a="http://schemas.openxmlformats.org/drawingml/2006/main" prst="rect">
+            <a:avLst/>
+          </a:prstGeom>
+          <a:noFill xmlns:a="http://schemas.openxmlformats.org/drawingml/2006/main"/>
+          <a:ln xmlns:a="http://schemas.openxmlformats.org/drawingml/2006/main" w="0">
+            <a:noFill/>
+          </a:ln>
+        </p:spPr>
+        <p:txBody>
+          <a:bodyPr xmlns:a="http://schemas.openxmlformats.org/drawingml/2006/main">
+            <a:normAutofit fontScale="63636"/>
+          </a:bodyPr>
+          <a:lstStyle xmlns:a="http://schemas.openxmlformats.org/drawingml/2006/main"/>
+          <a:p xmlns:a="http://schemas.openxmlformats.org/drawingml/2006/main">
+            <a:pPr>
+              <a:defRPr sz="825" b="0">
+                <a:solidFill>
+                  <a:srgbClr val="4D5B66"/>
+                </a:solidFill>
+                <a:latin typeface="Microsoft JhengHei"/>
+                <a:ea typeface="Microsoft JhengHei"/>
+                <a:cs typeface="Microsoft JhengHei"/>
+              </a:defRPr>
+            </a:pPr>
+            <a:r>
+              <a:rPr sz="825" b="0">
+                <a:solidFill>
+                  <a:srgbClr val="4D5B66"/>
+                </a:solidFill>
+                <a:latin typeface="Microsoft JhengHei"/>
+                <a:ea typeface="Microsoft JhengHei"/>
+                <a:cs typeface="Microsoft JhengHei"/>
+              </a:rPr>
+              <a:t>GSE262271 / GSE218858  |  Reviewed 15 September 2026</a:t>
+            </a:r>
+          </a:p>
+        </p:txBody>
+      </p:sp>
+      <p:sp>
+        <p:nvSpPr>
+          <p:cNvPr id="4" name="">
+            <a:extLst xmlns:a="http://schemas.openxmlformats.org/drawingml/2006/main">
+              <a:ext uri="{FF2B5EF4-FFF2-40B4-BE49-F238E27FC236}">
+                <a16:creationId xmlns:a16="http://schemas.microsoft.com/office/drawing/2014/main" id="{35F8E8A5-8344-485E-B399-2C70259929D4}"/>
+              </a:ext>
+            </a:extLst>
+          </p:cNvPr>
+          <p:cNvSpPr>
+            <a:spLocks xmlns:a="http://schemas.openxmlformats.org/drawingml/2006/main" noGrp="1"/>
+          </p:cNvSpPr>
+          <p:nvPr/>
+        </p:nvSpPr>
+        <p:spPr>
+          <a:xfrm xmlns:a="http://schemas.openxmlformats.org/drawingml/2006/main">
+            <a:off x="11334750" y="6543675"/>
+            <a:ext cx="381000" cy="171450"/>
+          </a:xfrm>
+          <a:prstGeom xmlns:a="http://schemas.openxmlformats.org/drawingml/2006/main" prst="rect">
+            <a:avLst/>
+          </a:prstGeom>
+          <a:noFill xmlns:a="http://schemas.openxmlformats.org/drawingml/2006/main"/>
+          <a:ln xmlns:a="http://schemas.openxmlformats.org/drawingml/2006/main" w="0">
+            <a:noFill/>
+          </a:ln>
+        </p:spPr>
+        <p:txBody>
+          <a:bodyPr xmlns:a="http://schemas.openxmlformats.org/drawingml/2006/main">
+            <a:normAutofit fontScale="63636"/>
+          </a:bodyPr>
+          <a:lstStyle xmlns:a="http://schemas.openxmlformats.org/drawingml/2006/main"/>
+          <a:p xmlns:a="http://schemas.openxmlformats.org/drawingml/2006/main">
+            <a:pPr>
+              <a:defRPr sz="825" b="0">
+                <a:solidFill>
+                  <a:srgbClr val="142F43"/>
+                </a:solidFill>
+                <a:latin typeface="Microsoft JhengHei"/>
+                <a:ea typeface="Microsoft JhengHei"/>
+                <a:cs typeface="Microsoft JhengHei"/>
+              </a:defRPr>
+            </a:pPr>
+            <a:r>
+              <a:rPr sz="825" b="0">
+                <a:solidFill>
+                  <a:srgbClr val="142F43"/>
+                </a:solidFill>
+                <a:latin typeface="Microsoft JhengHei"/>
+                <a:ea typeface="Microsoft JhengHei"/>
+                <a:cs typeface="Microsoft JhengHei"/>
+              </a:rPr>
+              <a:t>15</a:t>
             </a:r>
           </a:p>
         </p:txBody>
@@ -4804,7 +5211,7 @@
                           <a:ea typeface="Microsoft JhengHei"/>
                           <a:cs typeface="Microsoft JhengHei"/>
                         </a:rPr>
-                        <a:t>04_Code_Availability：R scripts 22–25、原始 bulk pipeline、版本與限制</a:t>
+                        <a:t>04_Code_Availability：R scripts 22–26、原始 bulk pipeline、版本與限制</a:t>
                       </a:r>
                     </a:p>
                   </a:txBody>
@@ -4862,7 +5269,7 @@
           <p:cNvPr id="6" name="">
             <a:extLst xmlns:a="http://schemas.openxmlformats.org/drawingml/2006/main">
               <a:ext uri="{FF2B5EF4-FFF2-40B4-BE49-F238E27FC236}">
-                <a16:creationId xmlns:a16="http://schemas.microsoft.com/office/drawing/2014/main" id="{D32E4F07-AFA0-46F0-857E-7048B70629C1}"/>
+                <a16:creationId xmlns:a16="http://schemas.microsoft.com/office/drawing/2014/main" id="{BD293830-BB62-458F-B326-9FC31949318B}"/>
               </a:ext>
             </a:extLst>
           </p:cNvPr>
@@ -4919,7 +5326,7 @@
           <p:cNvPr id="7" name="">
             <a:extLst xmlns:a="http://schemas.openxmlformats.org/drawingml/2006/main">
               <a:ext uri="{FF2B5EF4-FFF2-40B4-BE49-F238E27FC236}">
-                <a16:creationId xmlns:a16="http://schemas.microsoft.com/office/drawing/2014/main" id="{2CB4E885-DD31-41B2-AEB3-3AD275012F1B}"/>
+                <a16:creationId xmlns:a16="http://schemas.microsoft.com/office/drawing/2014/main" id="{8E9854AF-B743-4057-968E-30A708F95F88}"/>
               </a:ext>
             </a:extLst>
           </p:cNvPr>
@@ -4974,7 +5381,7 @@
     </p:spTree>
     <p:extLst>
       <p:ext uri="{BB962C8B-B14F-4D97-AF65-F5344CB8AC3E}">
-        <p14:creationId xmlns:p14="http://schemas.microsoft.com/office/powerpoint/2010/main" val="1037664592"/>
+        <p14:creationId xmlns:p14="http://schemas.microsoft.com/office/powerpoint/2010/main" val="381876132"/>
       </p:ext>
     </p:extLst>
   </p:cSld>
@@ -5005,7 +5412,7 @@
           <p:cNvPr id="7" name="">
             <a:extLst xmlns:a="http://schemas.openxmlformats.org/drawingml/2006/main">
               <a:ext uri="{FF2B5EF4-FFF2-40B4-BE49-F238E27FC236}">
-                <a16:creationId xmlns:a16="http://schemas.microsoft.com/office/drawing/2014/main" id="{6EF0FA12-371D-4576-AEFD-685B8497BA68}"/>
+                <a16:creationId xmlns:a16="http://schemas.microsoft.com/office/drawing/2014/main" id="{6708BA26-4E4A-4D07-A11D-DCFFADADB797}"/>
               </a:ext>
             </a:extLst>
           </p:cNvPr>
@@ -5062,7 +5469,7 @@
           <p:cNvPr id="2" name="">
             <a:extLst xmlns:a="http://schemas.openxmlformats.org/drawingml/2006/main">
               <a:ext uri="{FF2B5EF4-FFF2-40B4-BE49-F238E27FC236}">
-                <a16:creationId xmlns:a16="http://schemas.microsoft.com/office/drawing/2014/main" id="{6DF789B7-C11F-4601-912E-AE304B0A7790}"/>
+                <a16:creationId xmlns:a16="http://schemas.microsoft.com/office/drawing/2014/main" id="{D75E65B5-6012-4C13-BDF7-B64AF3061BD9}"/>
               </a:ext>
             </a:extLst>
           </p:cNvPr>
@@ -5119,7 +5526,7 @@
           <p:cNvPr id="3" name="">
             <a:extLst xmlns:a="http://schemas.openxmlformats.org/drawingml/2006/main">
               <a:ext uri="{FF2B5EF4-FFF2-40B4-BE49-F238E27FC236}">
-                <a16:creationId xmlns:a16="http://schemas.microsoft.com/office/drawing/2014/main" id="{CA60FDA1-DF61-4F9D-B939-81BDFFD9FA5D}"/>
+                <a16:creationId xmlns:a16="http://schemas.microsoft.com/office/drawing/2014/main" id="{7AF9ADB7-6EEC-4B25-BA8A-F09ADF5798E1}"/>
               </a:ext>
             </a:extLst>
           </p:cNvPr>
@@ -5176,7 +5583,7 @@
           <p:cNvPr id="4" name="">
             <a:extLst xmlns:a="http://schemas.openxmlformats.org/drawingml/2006/main">
               <a:ext uri="{FF2B5EF4-FFF2-40B4-BE49-F238E27FC236}">
-                <a16:creationId xmlns:a16="http://schemas.microsoft.com/office/drawing/2014/main" id="{498F86D3-575B-45ED-A0DA-02B7AFC3A0A3}"/>
+                <a16:creationId xmlns:a16="http://schemas.microsoft.com/office/drawing/2014/main" id="{06C93596-C79E-45B2-96B2-A96ACFA7F194}"/>
               </a:ext>
             </a:extLst>
           </p:cNvPr>
@@ -5610,7 +6017,7 @@
           <p:cNvPr id="6" name="">
             <a:extLst xmlns:a="http://schemas.openxmlformats.org/drawingml/2006/main">
               <a:ext uri="{FF2B5EF4-FFF2-40B4-BE49-F238E27FC236}">
-                <a16:creationId xmlns:a16="http://schemas.microsoft.com/office/drawing/2014/main" id="{C4F1B731-AEC3-4A3B-A671-CD49BA9248D1}"/>
+                <a16:creationId xmlns:a16="http://schemas.microsoft.com/office/drawing/2014/main" id="{827BC9FF-7C70-4EBF-8C18-F84D3079C89E}"/>
               </a:ext>
             </a:extLst>
           </p:cNvPr>
@@ -5665,7 +6072,7 @@
     </p:spTree>
     <p:extLst>
       <p:ext uri="{BB962C8B-B14F-4D97-AF65-F5344CB8AC3E}">
-        <p14:creationId xmlns:p14="http://schemas.microsoft.com/office/powerpoint/2010/main" val="2050427488"/>
+        <p14:creationId xmlns:p14="http://schemas.microsoft.com/office/powerpoint/2010/main" val="649372558"/>
       </p:ext>
     </p:extLst>
   </p:cSld>
@@ -5696,7 +6103,7 @@
           <p:cNvPr id="9" name="">
             <a:extLst xmlns:a="http://schemas.openxmlformats.org/drawingml/2006/main">
               <a:ext uri="{FF2B5EF4-FFF2-40B4-BE49-F238E27FC236}">
-                <a16:creationId xmlns:a16="http://schemas.microsoft.com/office/drawing/2014/main" id="{A3044CC2-C80B-4B43-AE4D-E8BA5ED6BF30}"/>
+                <a16:creationId xmlns:a16="http://schemas.microsoft.com/office/drawing/2014/main" id="{00FCF519-23D7-4F86-9904-0E689E7FC02A}"/>
               </a:ext>
             </a:extLst>
           </p:cNvPr>
@@ -5753,7 +6160,7 @@
           <p:cNvPr id="2" name="">
             <a:extLst xmlns:a="http://schemas.openxmlformats.org/drawingml/2006/main">
               <a:ext uri="{FF2B5EF4-FFF2-40B4-BE49-F238E27FC236}">
-                <a16:creationId xmlns:a16="http://schemas.microsoft.com/office/drawing/2014/main" id="{3E9C4ADE-4E98-4DC7-82B7-FE2F33A6761F}"/>
+                <a16:creationId xmlns:a16="http://schemas.microsoft.com/office/drawing/2014/main" id="{EA9EF959-A0BF-47AF-909F-89EADEFEBC8C}"/>
               </a:ext>
             </a:extLst>
           </p:cNvPr>
@@ -5810,7 +6217,7 @@
           <p:cNvPr id="3" name="">
             <a:extLst xmlns:a="http://schemas.openxmlformats.org/drawingml/2006/main">
               <a:ext uri="{FF2B5EF4-FFF2-40B4-BE49-F238E27FC236}">
-                <a16:creationId xmlns:a16="http://schemas.microsoft.com/office/drawing/2014/main" id="{3900DDB9-4454-4822-954D-216C2AB5EC1A}"/>
+                <a16:creationId xmlns:a16="http://schemas.microsoft.com/office/drawing/2014/main" id="{662BB04C-B9B4-4CBC-9231-38961C630C42}"/>
               </a:ext>
             </a:extLst>
           </p:cNvPr>
@@ -5867,7 +6274,7 @@
           <p:cNvPr id="4" name="">
             <a:extLst xmlns:a="http://schemas.openxmlformats.org/drawingml/2006/main">
               <a:ext uri="{FF2B5EF4-FFF2-40B4-BE49-F238E27FC236}">
-                <a16:creationId xmlns:a16="http://schemas.microsoft.com/office/drawing/2014/main" id="{475E32B0-2484-41DB-B3E7-123E064FA3B2}"/>
+                <a16:creationId xmlns:a16="http://schemas.microsoft.com/office/drawing/2014/main" id="{FF963E17-42BC-4D4A-AFF5-6E1ABBF1D6E8}"/>
               </a:ext>
             </a:extLst>
           </p:cNvPr>
@@ -5928,7 +6335,7 @@
           <p:nvPr/>
         </p:nvPicPr>
         <p:blipFill>
-          <a:blip xmlns:r="http://schemas.openxmlformats.org/officeDocument/2006/relationships" xmlns:a="http://schemas.openxmlformats.org/drawingml/2006/main" r:embed="R2e2d4a77c50848c4"/>
+          <a:blip xmlns:r="http://schemas.openxmlformats.org/officeDocument/2006/relationships" xmlns:a="http://schemas.openxmlformats.org/drawingml/2006/main" r:embed="Rb9e7fb062fd049e3"/>
           <a:stretch xmlns:a="http://schemas.openxmlformats.org/drawingml/2006/main"/>
         </p:blipFill>
         <p:spPr>
@@ -5946,7 +6353,7 @@
           <p:cNvPr id="6" name="">
             <a:extLst xmlns:a="http://schemas.openxmlformats.org/drawingml/2006/main">
               <a:ext uri="{FF2B5EF4-FFF2-40B4-BE49-F238E27FC236}">
-                <a16:creationId xmlns:a16="http://schemas.microsoft.com/office/drawing/2014/main" id="{C6959A2F-8919-4DD7-84D2-BCF6731BFF7D}"/>
+                <a16:creationId xmlns:a16="http://schemas.microsoft.com/office/drawing/2014/main" id="{6DB926BD-C574-495B-B0F8-003C3B1C5A23}"/>
               </a:ext>
             </a:extLst>
           </p:cNvPr>
@@ -6003,7 +6410,7 @@
           <p:cNvPr id="7" name="">
             <a:extLst xmlns:a="http://schemas.openxmlformats.org/drawingml/2006/main">
               <a:ext uri="{FF2B5EF4-FFF2-40B4-BE49-F238E27FC236}">
-                <a16:creationId xmlns:a16="http://schemas.microsoft.com/office/drawing/2014/main" id="{0907C1F4-889E-42F3-834A-44652244D8A7}"/>
+                <a16:creationId xmlns:a16="http://schemas.microsoft.com/office/drawing/2014/main" id="{F29B4003-DF04-439F-98C9-E4083C625ABA}"/>
               </a:ext>
             </a:extLst>
           </p:cNvPr>
@@ -6129,7 +6536,7 @@
           <p:cNvPr id="8" name="">
             <a:extLst xmlns:a="http://schemas.openxmlformats.org/drawingml/2006/main">
               <a:ext uri="{FF2B5EF4-FFF2-40B4-BE49-F238E27FC236}">
-                <a16:creationId xmlns:a16="http://schemas.microsoft.com/office/drawing/2014/main" id="{640398A2-DC75-4DF5-94A8-FBB3C75D5279}"/>
+                <a16:creationId xmlns:a16="http://schemas.microsoft.com/office/drawing/2014/main" id="{53A868D5-A782-4DEF-B9FD-3D9D88BC0FC0}"/>
               </a:ext>
             </a:extLst>
           </p:cNvPr>
@@ -6184,7 +6591,7 @@
     </p:spTree>
     <p:extLst>
       <p:ext uri="{BB962C8B-B14F-4D97-AF65-F5344CB8AC3E}">
-        <p14:creationId xmlns:p14="http://schemas.microsoft.com/office/powerpoint/2010/main" val="1736468625"/>
+        <p14:creationId xmlns:p14="http://schemas.microsoft.com/office/powerpoint/2010/main" val="1257553538"/>
       </p:ext>
     </p:extLst>
   </p:cSld>
@@ -6215,7 +6622,7 @@
           <p:cNvPr id="7" name="">
             <a:extLst xmlns:a="http://schemas.openxmlformats.org/drawingml/2006/main">
               <a:ext uri="{FF2B5EF4-FFF2-40B4-BE49-F238E27FC236}">
-                <a16:creationId xmlns:a16="http://schemas.microsoft.com/office/drawing/2014/main" id="{F5DE7D9F-5127-4DAE-A974-E8B4BF8ADFE9}"/>
+                <a16:creationId xmlns:a16="http://schemas.microsoft.com/office/drawing/2014/main" id="{4029D8D0-061B-4F9D-BC1C-CED6AB800437}"/>
               </a:ext>
             </a:extLst>
           </p:cNvPr>
@@ -6272,7 +6679,7 @@
           <p:cNvPr id="2" name="">
             <a:extLst xmlns:a="http://schemas.openxmlformats.org/drawingml/2006/main">
               <a:ext uri="{FF2B5EF4-FFF2-40B4-BE49-F238E27FC236}">
-                <a16:creationId xmlns:a16="http://schemas.microsoft.com/office/drawing/2014/main" id="{005CDB88-888D-4305-904B-4273DF561050}"/>
+                <a16:creationId xmlns:a16="http://schemas.microsoft.com/office/drawing/2014/main" id="{ED15D954-8941-4A4B-BF07-05C5F6FD86E9}"/>
               </a:ext>
             </a:extLst>
           </p:cNvPr>
@@ -6329,7 +6736,7 @@
           <p:cNvPr id="3" name="">
             <a:extLst xmlns:a="http://schemas.openxmlformats.org/drawingml/2006/main">
               <a:ext uri="{FF2B5EF4-FFF2-40B4-BE49-F238E27FC236}">
-                <a16:creationId xmlns:a16="http://schemas.microsoft.com/office/drawing/2014/main" id="{3A97FCAF-D020-443C-A79B-769ED23AC9EC}"/>
+                <a16:creationId xmlns:a16="http://schemas.microsoft.com/office/drawing/2014/main" id="{C45784C8-BCE6-41E0-9006-626C162EBD99}"/>
               </a:ext>
             </a:extLst>
           </p:cNvPr>
@@ -6386,7 +6793,7 @@
           <p:cNvPr id="4" name="">
             <a:extLst xmlns:a="http://schemas.openxmlformats.org/drawingml/2006/main">
               <a:ext uri="{FF2B5EF4-FFF2-40B4-BE49-F238E27FC236}">
-                <a16:creationId xmlns:a16="http://schemas.microsoft.com/office/drawing/2014/main" id="{66477DE0-CDE2-47A0-9D9A-1C1CE9D20B24}"/>
+                <a16:creationId xmlns:a16="http://schemas.microsoft.com/office/drawing/2014/main" id="{1FD95CB4-3453-473D-9B2E-9885BAC58C64}"/>
               </a:ext>
             </a:extLst>
           </p:cNvPr>
@@ -6447,7 +6854,7 @@
           <p:nvPr/>
         </p:nvPicPr>
         <p:blipFill>
-          <a:blip xmlns:r="http://schemas.openxmlformats.org/officeDocument/2006/relationships" xmlns:a="http://schemas.openxmlformats.org/drawingml/2006/main" r:embed="R4b0c1ab8beeb4088"/>
+          <a:blip xmlns:r="http://schemas.openxmlformats.org/officeDocument/2006/relationships" xmlns:a="http://schemas.openxmlformats.org/drawingml/2006/main" r:embed="Rc89eef3a58e54d06"/>
           <a:stretch xmlns:a="http://schemas.openxmlformats.org/drawingml/2006/main"/>
         </p:blipFill>
         <p:spPr>
@@ -6465,7 +6872,7 @@
           <p:cNvPr id="6" name="">
             <a:extLst xmlns:a="http://schemas.openxmlformats.org/drawingml/2006/main">
               <a:ext uri="{FF2B5EF4-FFF2-40B4-BE49-F238E27FC236}">
-                <a16:creationId xmlns:a16="http://schemas.microsoft.com/office/drawing/2014/main" id="{46FBBF90-A6F6-4721-A91C-5D148221DE05}"/>
+                <a16:creationId xmlns:a16="http://schemas.microsoft.com/office/drawing/2014/main" id="{C6A5FE2C-EF46-4754-9E6B-2162E599CFDB}"/>
               </a:ext>
             </a:extLst>
           </p:cNvPr>
@@ -6520,7 +6927,7 @@
     </p:spTree>
     <p:extLst>
       <p:ext uri="{BB962C8B-B14F-4D97-AF65-F5344CB8AC3E}">
-        <p14:creationId xmlns:p14="http://schemas.microsoft.com/office/powerpoint/2010/main" val="911398487"/>
+        <p14:creationId xmlns:p14="http://schemas.microsoft.com/office/powerpoint/2010/main" val="1805453070"/>
       </p:ext>
     </p:extLst>
   </p:cSld>
@@ -6551,7 +6958,7 @@
           <p:cNvPr id="10" name="">
             <a:extLst xmlns:a="http://schemas.openxmlformats.org/drawingml/2006/main">
               <a:ext uri="{FF2B5EF4-FFF2-40B4-BE49-F238E27FC236}">
-                <a16:creationId xmlns:a16="http://schemas.microsoft.com/office/drawing/2014/main" id="{A54718FC-1433-4090-AF29-DC2E87BFA205}"/>
+                <a16:creationId xmlns:a16="http://schemas.microsoft.com/office/drawing/2014/main" id="{D9A6593A-6E6D-427D-A795-5DEB521EB4D4}"/>
               </a:ext>
             </a:extLst>
           </p:cNvPr>
@@ -6608,7 +7015,7 @@
           <p:cNvPr id="2" name="">
             <a:extLst xmlns:a="http://schemas.openxmlformats.org/drawingml/2006/main">
               <a:ext uri="{FF2B5EF4-FFF2-40B4-BE49-F238E27FC236}">
-                <a16:creationId xmlns:a16="http://schemas.microsoft.com/office/drawing/2014/main" id="{BE479827-CC9C-4A8E-BDAB-9DAA948A9360}"/>
+                <a16:creationId xmlns:a16="http://schemas.microsoft.com/office/drawing/2014/main" id="{B4EAE52C-BD34-4979-AF2A-2B78EC8D32DB}"/>
               </a:ext>
             </a:extLst>
           </p:cNvPr>
@@ -6665,7 +7072,7 @@
           <p:cNvPr id="3" name="">
             <a:extLst xmlns:a="http://schemas.openxmlformats.org/drawingml/2006/main">
               <a:ext uri="{FF2B5EF4-FFF2-40B4-BE49-F238E27FC236}">
-                <a16:creationId xmlns:a16="http://schemas.microsoft.com/office/drawing/2014/main" id="{938F7DBE-09F0-4623-A30B-B89052EE4851}"/>
+                <a16:creationId xmlns:a16="http://schemas.microsoft.com/office/drawing/2014/main" id="{59010D7A-DDDD-4B09-992E-FFAF1A87D3B7}"/>
               </a:ext>
             </a:extLst>
           </p:cNvPr>
@@ -6722,7 +7129,7 @@
           <p:cNvPr id="4" name="">
             <a:extLst xmlns:a="http://schemas.openxmlformats.org/drawingml/2006/main">
               <a:ext uri="{FF2B5EF4-FFF2-40B4-BE49-F238E27FC236}">
-                <a16:creationId xmlns:a16="http://schemas.microsoft.com/office/drawing/2014/main" id="{545BC78F-BB33-4975-872D-2ED07904796D}"/>
+                <a16:creationId xmlns:a16="http://schemas.microsoft.com/office/drawing/2014/main" id="{D1A5F254-09E0-45F1-98C7-52A19B1A622B}"/>
               </a:ext>
             </a:extLst>
           </p:cNvPr>
@@ -6783,7 +7190,7 @@
           <p:nvPr/>
         </p:nvPicPr>
         <p:blipFill>
-          <a:blip xmlns:r="http://schemas.openxmlformats.org/officeDocument/2006/relationships" xmlns:a="http://schemas.openxmlformats.org/drawingml/2006/main" r:embed="R2a135bdfb7144324"/>
+          <a:blip xmlns:r="http://schemas.openxmlformats.org/officeDocument/2006/relationships" xmlns:a="http://schemas.openxmlformats.org/drawingml/2006/main" r:embed="Rd17e1403a0db42d0"/>
           <a:stretch xmlns:a="http://schemas.openxmlformats.org/drawingml/2006/main"/>
         </p:blipFill>
         <p:spPr>
@@ -6801,7 +7208,7 @@
           <p:cNvPr id="6" name="">
             <a:extLst xmlns:a="http://schemas.openxmlformats.org/drawingml/2006/main">
               <a:ext uri="{FF2B5EF4-FFF2-40B4-BE49-F238E27FC236}">
-                <a16:creationId xmlns:a16="http://schemas.microsoft.com/office/drawing/2014/main" id="{18933FD7-3E6D-47B4-9CD9-2C4D72AC6B42}"/>
+                <a16:creationId xmlns:a16="http://schemas.microsoft.com/office/drawing/2014/main" id="{7FF866AD-CA24-4E64-8437-892657ABF77C}"/>
               </a:ext>
             </a:extLst>
           </p:cNvPr>
@@ -6881,7 +7288,7 @@
           <p:cNvPr id="7" name="">
             <a:extLst xmlns:a="http://schemas.openxmlformats.org/drawingml/2006/main">
               <a:ext uri="{FF2B5EF4-FFF2-40B4-BE49-F238E27FC236}">
-                <a16:creationId xmlns:a16="http://schemas.microsoft.com/office/drawing/2014/main" id="{6718DFE0-760D-4349-966A-EF63D10C55D5}"/>
+                <a16:creationId xmlns:a16="http://schemas.microsoft.com/office/drawing/2014/main" id="{0C589080-0389-4866-BE7D-1DBB09738529}"/>
               </a:ext>
             </a:extLst>
           </p:cNvPr>
@@ -6961,7 +7368,7 @@
           <p:cNvPr id="8" name="">
             <a:extLst xmlns:a="http://schemas.openxmlformats.org/drawingml/2006/main">
               <a:ext uri="{FF2B5EF4-FFF2-40B4-BE49-F238E27FC236}">
-                <a16:creationId xmlns:a16="http://schemas.microsoft.com/office/drawing/2014/main" id="{E32BF426-9997-4D82-83A2-6067645965FF}"/>
+                <a16:creationId xmlns:a16="http://schemas.microsoft.com/office/drawing/2014/main" id="{7130A11B-59F9-4A76-8A49-64D6059EE510}"/>
               </a:ext>
             </a:extLst>
           </p:cNvPr>
@@ -7064,7 +7471,7 @@
           <p:cNvPr id="9" name="">
             <a:extLst xmlns:a="http://schemas.openxmlformats.org/drawingml/2006/main">
               <a:ext uri="{FF2B5EF4-FFF2-40B4-BE49-F238E27FC236}">
-                <a16:creationId xmlns:a16="http://schemas.microsoft.com/office/drawing/2014/main" id="{B04DC160-02C5-4068-A4F8-3781A23A1E4C}"/>
+                <a16:creationId xmlns:a16="http://schemas.microsoft.com/office/drawing/2014/main" id="{F6A24658-22A2-4FFB-9D83-FF190C863CCF}"/>
               </a:ext>
             </a:extLst>
           </p:cNvPr>
@@ -7119,7 +7526,7 @@
     </p:spTree>
     <p:extLst>
       <p:ext uri="{BB962C8B-B14F-4D97-AF65-F5344CB8AC3E}">
-        <p14:creationId xmlns:p14="http://schemas.microsoft.com/office/powerpoint/2010/main" val="842116807"/>
+        <p14:creationId xmlns:p14="http://schemas.microsoft.com/office/powerpoint/2010/main" val="1267506133"/>
       </p:ext>
     </p:extLst>
   </p:cSld>
@@ -7150,7 +7557,7 @@
           <p:cNvPr id="8" name="">
             <a:extLst xmlns:a="http://schemas.openxmlformats.org/drawingml/2006/main">
               <a:ext uri="{FF2B5EF4-FFF2-40B4-BE49-F238E27FC236}">
-                <a16:creationId xmlns:a16="http://schemas.microsoft.com/office/drawing/2014/main" id="{41CD04B5-04CD-4445-A7A2-ABF050D949A5}"/>
+                <a16:creationId xmlns:a16="http://schemas.microsoft.com/office/drawing/2014/main" id="{AA7ED736-487E-4F56-B396-BADBC5106310}"/>
               </a:ext>
             </a:extLst>
           </p:cNvPr>
@@ -7207,7 +7614,7 @@
           <p:cNvPr id="2" name="">
             <a:extLst xmlns:a="http://schemas.openxmlformats.org/drawingml/2006/main">
               <a:ext uri="{FF2B5EF4-FFF2-40B4-BE49-F238E27FC236}">
-                <a16:creationId xmlns:a16="http://schemas.microsoft.com/office/drawing/2014/main" id="{87031196-2DE0-41E9-B3E3-75A6780EFD82}"/>
+                <a16:creationId xmlns:a16="http://schemas.microsoft.com/office/drawing/2014/main" id="{40EBD3C0-AF05-4C41-8C6F-8AD824AA8B5F}"/>
               </a:ext>
             </a:extLst>
           </p:cNvPr>
@@ -7264,7 +7671,7 @@
           <p:cNvPr id="3" name="">
             <a:extLst xmlns:a="http://schemas.openxmlformats.org/drawingml/2006/main">
               <a:ext uri="{FF2B5EF4-FFF2-40B4-BE49-F238E27FC236}">
-                <a16:creationId xmlns:a16="http://schemas.microsoft.com/office/drawing/2014/main" id="{2E1E7897-68E0-4FE6-8507-3881C9A03162}"/>
+                <a16:creationId xmlns:a16="http://schemas.microsoft.com/office/drawing/2014/main" id="{41581309-B70E-443E-81D2-5328F54CBDD4}"/>
               </a:ext>
             </a:extLst>
           </p:cNvPr>
@@ -7321,7 +7728,7 @@
           <p:cNvPr id="4" name="">
             <a:extLst xmlns:a="http://schemas.openxmlformats.org/drawingml/2006/main">
               <a:ext uri="{FF2B5EF4-FFF2-40B4-BE49-F238E27FC236}">
-                <a16:creationId xmlns:a16="http://schemas.microsoft.com/office/drawing/2014/main" id="{4485641B-7CD0-4153-B8C4-B67A119BFC3D}"/>
+                <a16:creationId xmlns:a16="http://schemas.microsoft.com/office/drawing/2014/main" id="{0F44AAE9-3DE4-438D-BF75-2FFE5964E8A8}"/>
               </a:ext>
             </a:extLst>
           </p:cNvPr>
@@ -7382,7 +7789,7 @@
           <p:nvPr/>
         </p:nvPicPr>
         <p:blipFill>
-          <a:blip xmlns:r="http://schemas.openxmlformats.org/officeDocument/2006/relationships" xmlns:a="http://schemas.openxmlformats.org/drawingml/2006/main" r:embed="R36d106b8f7af4b74"/>
+          <a:blip xmlns:r="http://schemas.openxmlformats.org/officeDocument/2006/relationships" xmlns:a="http://schemas.openxmlformats.org/drawingml/2006/main" r:embed="Rc9868f3052a24924"/>
           <a:stretch xmlns:a="http://schemas.openxmlformats.org/drawingml/2006/main"/>
         </p:blipFill>
         <p:spPr>
@@ -7400,7 +7807,7 @@
           <p:cNvPr id="6" name="">
             <a:extLst xmlns:a="http://schemas.openxmlformats.org/drawingml/2006/main">
               <a:ext uri="{FF2B5EF4-FFF2-40B4-BE49-F238E27FC236}">
-                <a16:creationId xmlns:a16="http://schemas.microsoft.com/office/drawing/2014/main" id="{AB4C1A17-10B5-4CD8-ACA1-97837ACE30E8}"/>
+                <a16:creationId xmlns:a16="http://schemas.microsoft.com/office/drawing/2014/main" id="{61F1B9AA-FF64-49D1-A8BD-9C09CB15BBB3}"/>
               </a:ext>
             </a:extLst>
           </p:cNvPr>
@@ -7508,7 +7915,7 @@
           <p:cNvPr id="7" name="">
             <a:extLst xmlns:a="http://schemas.openxmlformats.org/drawingml/2006/main">
               <a:ext uri="{FF2B5EF4-FFF2-40B4-BE49-F238E27FC236}">
-                <a16:creationId xmlns:a16="http://schemas.microsoft.com/office/drawing/2014/main" id="{48FA257F-C71E-4958-B7B5-3066DBC2D33F}"/>
+                <a16:creationId xmlns:a16="http://schemas.microsoft.com/office/drawing/2014/main" id="{AF4A0256-F209-4D4E-A3EE-668600E043F9}"/>
               </a:ext>
             </a:extLst>
           </p:cNvPr>
@@ -7563,7 +7970,7 @@
     </p:spTree>
     <p:extLst>
       <p:ext uri="{BB962C8B-B14F-4D97-AF65-F5344CB8AC3E}">
-        <p14:creationId xmlns:p14="http://schemas.microsoft.com/office/powerpoint/2010/main" val="1497007802"/>
+        <p14:creationId xmlns:p14="http://schemas.microsoft.com/office/powerpoint/2010/main" val="352145769"/>
       </p:ext>
     </p:extLst>
   </p:cSld>
@@ -7594,7 +8001,7 @@
           <p:cNvPr id="8" name="">
             <a:extLst xmlns:a="http://schemas.openxmlformats.org/drawingml/2006/main">
               <a:ext uri="{FF2B5EF4-FFF2-40B4-BE49-F238E27FC236}">
-                <a16:creationId xmlns:a16="http://schemas.microsoft.com/office/drawing/2014/main" id="{5585420B-6562-4AD6-AA37-3C0841E2AC8C}"/>
+                <a16:creationId xmlns:a16="http://schemas.microsoft.com/office/drawing/2014/main" id="{4E46B0BC-6CAB-420F-86C1-3772455A74C3}"/>
               </a:ext>
             </a:extLst>
           </p:cNvPr>
@@ -7651,7 +8058,7 @@
           <p:cNvPr id="2" name="">
             <a:extLst xmlns:a="http://schemas.openxmlformats.org/drawingml/2006/main">
               <a:ext uri="{FF2B5EF4-FFF2-40B4-BE49-F238E27FC236}">
-                <a16:creationId xmlns:a16="http://schemas.microsoft.com/office/drawing/2014/main" id="{7F224BA5-4DD5-48A7-A96B-49E4D3D686EA}"/>
+                <a16:creationId xmlns:a16="http://schemas.microsoft.com/office/drawing/2014/main" id="{F945BF82-515A-4A64-85AC-D413016FBDDF}"/>
               </a:ext>
             </a:extLst>
           </p:cNvPr>
@@ -7708,7 +8115,7 @@
           <p:cNvPr id="3" name="">
             <a:extLst xmlns:a="http://schemas.openxmlformats.org/drawingml/2006/main">
               <a:ext uri="{FF2B5EF4-FFF2-40B4-BE49-F238E27FC236}">
-                <a16:creationId xmlns:a16="http://schemas.microsoft.com/office/drawing/2014/main" id="{5B1CE012-158D-45B1-AD00-EFC3171821E8}"/>
+                <a16:creationId xmlns:a16="http://schemas.microsoft.com/office/drawing/2014/main" id="{03F06B1A-3BF9-42F9-92F4-BB0AEEC944C7}"/>
               </a:ext>
             </a:extLst>
           </p:cNvPr>
@@ -7765,7 +8172,7 @@
           <p:cNvPr id="4" name="">
             <a:extLst xmlns:a="http://schemas.openxmlformats.org/drawingml/2006/main">
               <a:ext uri="{FF2B5EF4-FFF2-40B4-BE49-F238E27FC236}">
-                <a16:creationId xmlns:a16="http://schemas.microsoft.com/office/drawing/2014/main" id="{BCD2D41D-7969-47AC-87CD-BDF247E3A23D}"/>
+                <a16:creationId xmlns:a16="http://schemas.microsoft.com/office/drawing/2014/main" id="{09B646FE-95C0-492B-854A-B07CA305DB27}"/>
               </a:ext>
             </a:extLst>
           </p:cNvPr>
@@ -7826,7 +8233,7 @@
           <p:nvPr/>
         </p:nvPicPr>
         <p:blipFill>
-          <a:blip xmlns:r="http://schemas.openxmlformats.org/officeDocument/2006/relationships" xmlns:a="http://schemas.openxmlformats.org/drawingml/2006/main" r:embed="R366b61e122d04a50"/>
+          <a:blip xmlns:r="http://schemas.openxmlformats.org/officeDocument/2006/relationships" xmlns:a="http://schemas.openxmlformats.org/drawingml/2006/main" r:embed="Rec43b646ba544b0d"/>
           <a:stretch xmlns:a="http://schemas.openxmlformats.org/drawingml/2006/main"/>
         </p:blipFill>
         <p:spPr>
@@ -7844,7 +8251,7 @@
           <p:cNvPr id="6" name="">
             <a:extLst xmlns:a="http://schemas.openxmlformats.org/drawingml/2006/main">
               <a:ext uri="{FF2B5EF4-FFF2-40B4-BE49-F238E27FC236}">
-                <a16:creationId xmlns:a16="http://schemas.microsoft.com/office/drawing/2014/main" id="{0F21EEF9-5BDC-4BD1-B897-F92658ED9FC7}"/>
+                <a16:creationId xmlns:a16="http://schemas.microsoft.com/office/drawing/2014/main" id="{E2740392-4F40-42CB-820D-CE2342FE40A5}"/>
               </a:ext>
             </a:extLst>
           </p:cNvPr>
@@ -7952,7 +8359,7 @@
           <p:cNvPr id="7" name="">
             <a:extLst xmlns:a="http://schemas.openxmlformats.org/drawingml/2006/main">
               <a:ext uri="{FF2B5EF4-FFF2-40B4-BE49-F238E27FC236}">
-                <a16:creationId xmlns:a16="http://schemas.microsoft.com/office/drawing/2014/main" id="{D0EE8720-3CC8-4591-8C7E-AA5DA4FB8CCD}"/>
+                <a16:creationId xmlns:a16="http://schemas.microsoft.com/office/drawing/2014/main" id="{87E42520-5857-4ADB-BD43-ECE2B4778773}"/>
               </a:ext>
             </a:extLst>
           </p:cNvPr>
@@ -8007,7 +8414,7 @@
     </p:spTree>
     <p:extLst>
       <p:ext uri="{BB962C8B-B14F-4D97-AF65-F5344CB8AC3E}">
-        <p14:creationId xmlns:p14="http://schemas.microsoft.com/office/powerpoint/2010/main" val="1502474852"/>
+        <p14:creationId xmlns:p14="http://schemas.microsoft.com/office/powerpoint/2010/main" val="1569619973"/>
       </p:ext>
     </p:extLst>
   </p:cSld>
@@ -8038,7 +8445,7 @@
           <p:cNvPr id="8" name="">
             <a:extLst xmlns:a="http://schemas.openxmlformats.org/drawingml/2006/main">
               <a:ext uri="{FF2B5EF4-FFF2-40B4-BE49-F238E27FC236}">
-                <a16:creationId xmlns:a16="http://schemas.microsoft.com/office/drawing/2014/main" id="{11BEEBD0-94F0-45E8-A7EE-0F0352A002BF}"/>
+                <a16:creationId xmlns:a16="http://schemas.microsoft.com/office/drawing/2014/main" id="{0DFF39F0-C6BD-49C7-A445-9C07F8BFD006}"/>
               </a:ext>
             </a:extLst>
           </p:cNvPr>
@@ -8095,7 +8502,7 @@
           <p:cNvPr id="2" name="">
             <a:extLst xmlns:a="http://schemas.openxmlformats.org/drawingml/2006/main">
               <a:ext uri="{FF2B5EF4-FFF2-40B4-BE49-F238E27FC236}">
-                <a16:creationId xmlns:a16="http://schemas.microsoft.com/office/drawing/2014/main" id="{CBD6F2B0-CC4F-4435-B351-BC77803F5F04}"/>
+                <a16:creationId xmlns:a16="http://schemas.microsoft.com/office/drawing/2014/main" id="{C7E92974-362F-48F0-BC32-B49EB44C3741}"/>
               </a:ext>
             </a:extLst>
           </p:cNvPr>
@@ -8152,7 +8559,7 @@
           <p:cNvPr id="3" name="">
             <a:extLst xmlns:a="http://schemas.openxmlformats.org/drawingml/2006/main">
               <a:ext uri="{FF2B5EF4-FFF2-40B4-BE49-F238E27FC236}">
-                <a16:creationId xmlns:a16="http://schemas.microsoft.com/office/drawing/2014/main" id="{D2580DD0-8BCC-44DD-8E6B-60CB6298F1EB}"/>
+                <a16:creationId xmlns:a16="http://schemas.microsoft.com/office/drawing/2014/main" id="{99348BF3-E1F5-468B-83E5-72023E6AD786}"/>
               </a:ext>
             </a:extLst>
           </p:cNvPr>
@@ -8209,7 +8616,7 @@
           <p:cNvPr id="4" name="">
             <a:extLst xmlns:a="http://schemas.openxmlformats.org/drawingml/2006/main">
               <a:ext uri="{FF2B5EF4-FFF2-40B4-BE49-F238E27FC236}">
-                <a16:creationId xmlns:a16="http://schemas.microsoft.com/office/drawing/2014/main" id="{AB6E04EB-E947-4F2E-BEAF-49C277A31268}"/>
+                <a16:creationId xmlns:a16="http://schemas.microsoft.com/office/drawing/2014/main" id="{23F43FCB-1241-47B1-AF1F-C9708B2E2638}"/>
               </a:ext>
             </a:extLst>
           </p:cNvPr>
@@ -8270,7 +8677,7 @@
           <p:nvPr/>
         </p:nvPicPr>
         <p:blipFill>
-          <a:blip xmlns:r="http://schemas.openxmlformats.org/officeDocument/2006/relationships" xmlns:a="http://schemas.openxmlformats.org/drawingml/2006/main" r:embed="Rdbe2b0facf844927"/>
+          <a:blip xmlns:r="http://schemas.openxmlformats.org/officeDocument/2006/relationships" xmlns:a="http://schemas.openxmlformats.org/drawingml/2006/main" r:embed="R2e6fb96c30cc493b"/>
           <a:stretch xmlns:a="http://schemas.openxmlformats.org/drawingml/2006/main"/>
         </p:blipFill>
         <p:spPr>
@@ -8288,7 +8695,7 @@
           <p:cNvPr id="6" name="">
             <a:extLst xmlns:a="http://schemas.openxmlformats.org/drawingml/2006/main">
               <a:ext uri="{FF2B5EF4-FFF2-40B4-BE49-F238E27FC236}">
-                <a16:creationId xmlns:a16="http://schemas.microsoft.com/office/drawing/2014/main" id="{F3CC6C2C-3BAD-419E-8D01-FDE1EB7AC304}"/>
+                <a16:creationId xmlns:a16="http://schemas.microsoft.com/office/drawing/2014/main" id="{9F450DD2-DE39-4EBF-8760-EB2862B9C786}"/>
               </a:ext>
             </a:extLst>
           </p:cNvPr>
@@ -8396,7 +8803,7 @@
           <p:cNvPr id="7" name="">
             <a:extLst xmlns:a="http://schemas.openxmlformats.org/drawingml/2006/main">
               <a:ext uri="{FF2B5EF4-FFF2-40B4-BE49-F238E27FC236}">
-                <a16:creationId xmlns:a16="http://schemas.microsoft.com/office/drawing/2014/main" id="{97EADBA2-9B4E-4212-8C4A-68360E225BC5}"/>
+                <a16:creationId xmlns:a16="http://schemas.microsoft.com/office/drawing/2014/main" id="{A96E5768-02D6-4696-850F-EC1DAAD69C46}"/>
               </a:ext>
             </a:extLst>
           </p:cNvPr>
@@ -8502,7 +8909,7 @@
     </p:spTree>
     <p:extLst>
       <p:ext uri="{BB962C8B-B14F-4D97-AF65-F5344CB8AC3E}">
-        <p14:creationId xmlns:p14="http://schemas.microsoft.com/office/powerpoint/2010/main" val="1831706074"/>
+        <p14:creationId xmlns:p14="http://schemas.microsoft.com/office/powerpoint/2010/main" val="694357439"/>
       </p:ext>
     </p:extLst>
   </p:cSld>
@@ -8530,10 +8937,10 @@
       </p:grpSpPr>
       <p:sp>
         <p:nvSpPr>
-          <p:cNvPr id="6" name="">
+          <p:cNvPr id="7" name="">
             <a:extLst xmlns:a="http://schemas.openxmlformats.org/drawingml/2006/main">
               <a:ext uri="{FF2B5EF4-FFF2-40B4-BE49-F238E27FC236}">
-                <a16:creationId xmlns:a16="http://schemas.microsoft.com/office/drawing/2014/main" id="{8A70EF99-7DD2-468C-B6E2-8966A3306C3B}"/>
+                <a16:creationId xmlns:a16="http://schemas.microsoft.com/office/drawing/2014/main" id="{4F239687-0003-4D5C-825E-87A6DF49366B}"/>
               </a:ext>
             </a:extLst>
           </p:cNvPr>
@@ -8590,7 +8997,7 @@
           <p:cNvPr id="2" name="">
             <a:extLst xmlns:a="http://schemas.openxmlformats.org/drawingml/2006/main">
               <a:ext uri="{FF2B5EF4-FFF2-40B4-BE49-F238E27FC236}">
-                <a16:creationId xmlns:a16="http://schemas.microsoft.com/office/drawing/2014/main" id="{D9C6E819-3921-4805-81E8-14F91803176A}"/>
+                <a16:creationId xmlns:a16="http://schemas.microsoft.com/office/drawing/2014/main" id="{34B9DE9D-C764-4BC3-9819-AC0BE9651DCE}"/>
               </a:ext>
             </a:extLst>
           </p:cNvPr>
@@ -8637,7 +9044,7 @@
                 <a:ea typeface="Microsoft JhengHei"/>
                 <a:cs typeface="Microsoft JhengHei"/>
               </a:rPr>
-              <a:t>交集中的 pathway 與 NES</a:t>
+              <a:t>40 條共同上調 pathway：第 1–20 條</a:t>
             </a:r>
           </a:p>
         </p:txBody>
@@ -8647,7 +9054,7 @@
           <p:cNvPr id="3" name="">
             <a:extLst xmlns:a="http://schemas.openxmlformats.org/drawingml/2006/main">
               <a:ext uri="{FF2B5EF4-FFF2-40B4-BE49-F238E27FC236}">
-                <a16:creationId xmlns:a16="http://schemas.microsoft.com/office/drawing/2014/main" id="{A7823722-F1B2-44F5-BEA2-74CC8E95C381}"/>
+                <a16:creationId xmlns:a16="http://schemas.microsoft.com/office/drawing/2014/main" id="{7E3DD063-A897-4BB7-8385-FF21731243BF}"/>
               </a:ext>
             </a:extLst>
           </p:cNvPr>
@@ -8704,7 +9111,7 @@
           <p:cNvPr id="4" name="">
             <a:extLst xmlns:a="http://schemas.openxmlformats.org/drawingml/2006/main">
               <a:ext uri="{FF2B5EF4-FFF2-40B4-BE49-F238E27FC236}">
-                <a16:creationId xmlns:a16="http://schemas.microsoft.com/office/drawing/2014/main" id="{82BA95E4-B578-4F9A-B433-027904FB0ABB}"/>
+                <a16:creationId xmlns:a16="http://schemas.microsoft.com/office/drawing/2014/main" id="{78556452-6553-482A-A06D-46BAD8A73143}"/>
               </a:ext>
             </a:extLst>
           </p:cNvPr>
@@ -8758,30 +9165,87 @@
       </p:sp>
       <p:pic>
         <p:nvPicPr>
-          <p:cNvPr id="10" name=""/>
+          <p:cNvPr id="11" name=""/>
           <p:cNvPicPr>
             <a:picLocks xmlns:a="http://schemas.openxmlformats.org/drawingml/2006/main" noChangeAspect="1"/>
           </p:cNvPicPr>
           <p:nvPr/>
         </p:nvPicPr>
         <p:blipFill>
-          <a:blip xmlns:r="http://schemas.openxmlformats.org/officeDocument/2006/relationships" xmlns:a="http://schemas.openxmlformats.org/drawingml/2006/main" r:embed="R50fb8ae6ac74409d"/>
+          <a:blip xmlns:r="http://schemas.openxmlformats.org/officeDocument/2006/relationships" xmlns:a="http://schemas.openxmlformats.org/drawingml/2006/main" r:embed="R2de39dacb0c6440d"/>
           <a:stretch xmlns:a="http://schemas.openxmlformats.org/drawingml/2006/main"/>
         </p:blipFill>
         <p:spPr>
           <a:xfrm xmlns:a="http://schemas.openxmlformats.org/drawingml/2006/main">
-            <a:off x="1293813" y="1066800"/>
-            <a:ext cx="9604375" cy="5238750"/>
+            <a:off x="1262884" y="1028700"/>
+            <a:ext cx="9666233" cy="5143500"/>
           </a:xfrm>
           <a:prstGeom xmlns:a="http://schemas.openxmlformats.org/drawingml/2006/main" prst="rect">
             <a:avLst/>
           </a:prstGeom>
         </p:spPr>
       </p:pic>
+      <p:sp>
+        <p:nvSpPr>
+          <p:cNvPr id="6" name="">
+            <a:extLst xmlns:a="http://schemas.openxmlformats.org/drawingml/2006/main">
+              <a:ext uri="{FF2B5EF4-FFF2-40B4-BE49-F238E27FC236}">
+                <a16:creationId xmlns:a16="http://schemas.microsoft.com/office/drawing/2014/main" id="{3666FAD1-6C6B-43B6-B21B-F8D5D5257BD3}"/>
+              </a:ext>
+            </a:extLst>
+          </p:cNvPr>
+          <p:cNvSpPr>
+            <a:spLocks xmlns:a="http://schemas.openxmlformats.org/drawingml/2006/main" noGrp="1"/>
+          </p:cNvSpPr>
+          <p:nvPr/>
+        </p:nvSpPr>
+        <p:spPr>
+          <a:xfrm xmlns:a="http://schemas.openxmlformats.org/drawingml/2006/main">
+            <a:off x="619125" y="6191250"/>
+            <a:ext cx="10953750" cy="285750"/>
+          </a:xfrm>
+          <a:prstGeom xmlns:a="http://schemas.openxmlformats.org/drawingml/2006/main" prst="rect">
+            <a:avLst/>
+          </a:prstGeom>
+          <a:noFill xmlns:a="http://schemas.openxmlformats.org/drawingml/2006/main"/>
+          <a:ln xmlns:a="http://schemas.openxmlformats.org/drawingml/2006/main" w="0">
+            <a:noFill/>
+          </a:ln>
+        </p:spPr>
+        <p:txBody>
+          <a:bodyPr xmlns:a="http://schemas.openxmlformats.org/drawingml/2006/main">
+            <a:normAutofit fontScale="94444"/>
+          </a:bodyPr>
+          <a:lstStyle xmlns:a="http://schemas.openxmlformats.org/drawingml/2006/main"/>
+          <a:p xmlns:a="http://schemas.openxmlformats.org/drawingml/2006/main">
+            <a:pPr>
+              <a:defRPr sz="1350" b="0">
+                <a:solidFill>
+                  <a:srgbClr val="142F43"/>
+                </a:solidFill>
+                <a:latin typeface="Microsoft JhengHei"/>
+                <a:ea typeface="Microsoft JhengHei"/>
+                <a:cs typeface="Microsoft JhengHei"/>
+              </a:defRPr>
+            </a:pPr>
+            <a:r>
+              <a:rPr sz="1350" b="0">
+                <a:solidFill>
+                  <a:srgbClr val="142F43"/>
+                </a:solidFill>
+                <a:latin typeface="Microsoft JhengHei"/>
+                <a:ea typeface="Microsoft JhengHei"/>
+                <a:cs typeface="Microsoft JhengHei"/>
+              </a:rPr>
+              <a:t>兩組均 FDR &lt; 0.05。依兩組較大的 FDR 由小到大排列，Proteasome 位於第 14 條。</a:t>
+            </a:r>
+          </a:p>
+        </p:txBody>
+      </p:sp>
     </p:spTree>
     <p:extLst>
       <p:ext uri="{BB962C8B-B14F-4D97-AF65-F5344CB8AC3E}">
-        <p14:creationId xmlns:p14="http://schemas.microsoft.com/office/powerpoint/2010/main" val="1542495709"/>
+        <p14:creationId xmlns:p14="http://schemas.microsoft.com/office/powerpoint/2010/main" val="1553630544"/>
       </p:ext>
     </p:extLst>
   </p:cSld>

</xml_diff>

<commit_message>
Show exact NES and separate FDR significance columns in pathway plots
</commit_message>
<xml_diff>
--- a/projects/GSE262271_TALL_relapse_scRNAseq/07_Student_Handoff/01_Summary/Leukemia_scRNAseq_STAT5B_reviewed.pptx
+++ b/projects/GSE262271_TALL_relapse_scRNAseq/07_Student_Handoff/01_Summary/Leukemia_scRNAseq_STAT5B_reviewed.pptx
@@ -2,27 +2,27 @@
 <file path=ppt/presentation.xml><?xml version="1.0" encoding="utf-8"?>
 <p:presentation xmlns:p="http://schemas.openxmlformats.org/presentationml/2006/main">
   <p:sldMasterIdLst>
-    <p:sldMasterId xmlns:r="http://schemas.openxmlformats.org/officeDocument/2006/relationships" id="2147483648" r:id="R7c6c7086868e4eba"/>
+    <p:sldMasterId xmlns:r="http://schemas.openxmlformats.org/officeDocument/2006/relationships" id="2147483648" r:id="R590ee19e09114a82"/>
   </p:sldMasterIdLst>
   <p:notesMasterIdLst>
-    <p:notesMasterId xmlns:r="http://schemas.openxmlformats.org/officeDocument/2006/relationships" r:id="Rdb32df5b10ae4582"/>
+    <p:notesMasterId xmlns:r="http://schemas.openxmlformats.org/officeDocument/2006/relationships" r:id="R5ca6111044fb4531"/>
   </p:notesMasterIdLst>
   <p:sldIdLst>
-    <p:sldId xmlns:r="http://schemas.openxmlformats.org/officeDocument/2006/relationships" id="256" r:id="R64e882b4751a4568"/>
-    <p:sldId xmlns:r="http://schemas.openxmlformats.org/officeDocument/2006/relationships" id="257" r:id="Re738212d4ff94b28"/>
-    <p:sldId xmlns:r="http://schemas.openxmlformats.org/officeDocument/2006/relationships" id="258" r:id="Ref3cb69697354ddf"/>
-    <p:sldId xmlns:r="http://schemas.openxmlformats.org/officeDocument/2006/relationships" id="259" r:id="R5a351d7f7c484907"/>
-    <p:sldId xmlns:r="http://schemas.openxmlformats.org/officeDocument/2006/relationships" id="260" r:id="R6856b2e685384d7f"/>
-    <p:sldId xmlns:r="http://schemas.openxmlformats.org/officeDocument/2006/relationships" id="261" r:id="R7c1c2bc854e54a00"/>
-    <p:sldId xmlns:r="http://schemas.openxmlformats.org/officeDocument/2006/relationships" id="262" r:id="R83b2088941524f63"/>
-    <p:sldId xmlns:r="http://schemas.openxmlformats.org/officeDocument/2006/relationships" id="263" r:id="R8ef5c3e5c1014c04"/>
-    <p:sldId xmlns:r="http://schemas.openxmlformats.org/officeDocument/2006/relationships" id="264" r:id="R59bac43f2caa4213"/>
-    <p:sldId xmlns:r="http://schemas.openxmlformats.org/officeDocument/2006/relationships" id="265" r:id="R22dc68c251bc4425"/>
-    <p:sldId xmlns:r="http://schemas.openxmlformats.org/officeDocument/2006/relationships" id="266" r:id="Rc364a3d5dbbe400b"/>
-    <p:sldId xmlns:r="http://schemas.openxmlformats.org/officeDocument/2006/relationships" id="267" r:id="Rc370e7c0d8974607"/>
-    <p:sldId xmlns:r="http://schemas.openxmlformats.org/officeDocument/2006/relationships" id="268" r:id="R7562d54a582045db"/>
-    <p:sldId xmlns:r="http://schemas.openxmlformats.org/officeDocument/2006/relationships" id="269" r:id="R039c8bc954f44473"/>
-    <p:sldId xmlns:r="http://schemas.openxmlformats.org/officeDocument/2006/relationships" id="270" r:id="R95706312c62f4dc7"/>
+    <p:sldId xmlns:r="http://schemas.openxmlformats.org/officeDocument/2006/relationships" id="256" r:id="R54ad0cd8ac16434f"/>
+    <p:sldId xmlns:r="http://schemas.openxmlformats.org/officeDocument/2006/relationships" id="257" r:id="R4d3c999119a74990"/>
+    <p:sldId xmlns:r="http://schemas.openxmlformats.org/officeDocument/2006/relationships" id="258" r:id="R4380cde91a8a47a2"/>
+    <p:sldId xmlns:r="http://schemas.openxmlformats.org/officeDocument/2006/relationships" id="259" r:id="R85bddb84a8c54e27"/>
+    <p:sldId xmlns:r="http://schemas.openxmlformats.org/officeDocument/2006/relationships" id="260" r:id="Rb94e9a245b9e4315"/>
+    <p:sldId xmlns:r="http://schemas.openxmlformats.org/officeDocument/2006/relationships" id="261" r:id="R6fa8f9a5200545bc"/>
+    <p:sldId xmlns:r="http://schemas.openxmlformats.org/officeDocument/2006/relationships" id="262" r:id="R31b7996278ad4189"/>
+    <p:sldId xmlns:r="http://schemas.openxmlformats.org/officeDocument/2006/relationships" id="263" r:id="Rca9f3baf37cb45eb"/>
+    <p:sldId xmlns:r="http://schemas.openxmlformats.org/officeDocument/2006/relationships" id="264" r:id="R88d27d6fdd0943de"/>
+    <p:sldId xmlns:r="http://schemas.openxmlformats.org/officeDocument/2006/relationships" id="265" r:id="Recc8fd061f5f4bdc"/>
+    <p:sldId xmlns:r="http://schemas.openxmlformats.org/officeDocument/2006/relationships" id="266" r:id="R11872d261cb74a9c"/>
+    <p:sldId xmlns:r="http://schemas.openxmlformats.org/officeDocument/2006/relationships" id="267" r:id="Rb2ad2d44505b4bfc"/>
+    <p:sldId xmlns:r="http://schemas.openxmlformats.org/officeDocument/2006/relationships" id="268" r:id="R2aa3148f059b4816"/>
+    <p:sldId xmlns:r="http://schemas.openxmlformats.org/officeDocument/2006/relationships" id="269" r:id="R69efec4be4604917"/>
+    <p:sldId xmlns:r="http://schemas.openxmlformats.org/officeDocument/2006/relationships" id="270" r:id="R88976e6beb6e4dc1"/>
   </p:sldIdLst>
   <p:sldSz cx="12192000" cy="6858000"/>
   <p:notesSz cx="6858000" cy="9144000"/>
@@ -1436,7 +1436,7 @@
           <a:lstStyle xmlns:a="http://schemas.openxmlformats.org/drawingml/2006/main"/>
           <a:p xmlns:a="http://schemas.openxmlformats.org/drawingml/2006/main">
             <a:r>
-              <a:t>Table07 and complete Figure06 use exactly the same order: increasing max(sc_FDR, bulk_FDR), with alphabetical pathway-name ties. The maximum is a display ordering key, not a combined FDR. Position indicates NES; color indicates full-catalog BH FDR on a -log10 scale capped at6. All40 satisfy FDR&lt;0.05 in both datasets. Bold labels identify hypothesis targets without changing ordering. Layout reference: Reis-de-Oliveira et al., Nature Communications (2024), Figures3B and4D, https://www.nature.com/articles/s41467-024-50875-z . Only the plot layout is adapted; the reference article uses other enrichment statistics.</a:t>
+              <a:t>Table07 and complete Figure06 use exactly the same order: increasing max(sc_FDR, bulk_FDR), with alphabetical pathway-name ties. The maximum is a display ordering key, not a combined FDR. Position and adjacent numbers indicate NES. Blue denotes relapse scRNAseq and orange denotes STAT5B N642H bulk. A separate aligned column shows full-catalog BH FDR and stars: *&lt;0.05, **&lt;0.01, ***&lt;0.001. Stars use unrounded FDR, never nominal P. All40 satisfy FDR&lt;0.05 in both datasets. Bold labels identify hypothesis targets without changing ordering. Layout reference: Reis-de-Oliveira et al., Nature Communications (2024), Figures3B and4D, https://www.nature.com/articles/s41467-024-50875-z . Only the plot layout is adapted; the reference article uses other enrichment statistics.</a:t>
             </a:r>
           </a:p>
         </p:txBody>
@@ -1504,7 +1504,7 @@
   </p:cSld>
   <p:clrMap bg1="lt1" tx1="dk1" bg2="lt2" tx2="dk2" accent1="accent1" accent2="accent2" accent3="accent3" accent4="accent4" accent5="accent5" accent6="accent6" hlink="hlink" folHlink="folHlink"/>
   <p:sldLayoutIdLst>
-    <p:sldLayoutId xmlns:r="http://schemas.openxmlformats.org/officeDocument/2006/relationships" id="2147483649" r:id="Rcdb8ce7ff1fc401f"/>
+    <p:sldLayoutId xmlns:r="http://schemas.openxmlformats.org/officeDocument/2006/relationships" id="2147483649" r:id="R7c0a2ad83e7c4b11"/>
   </p:sldLayoutIdLst>
   <p:txStyles>
     <p:titleStyle>
@@ -2055,7 +2055,7 @@
           <p:cNvPr id="9" name="">
             <a:extLst xmlns:a="http://schemas.openxmlformats.org/drawingml/2006/main">
               <a:ext uri="{FF2B5EF4-FFF2-40B4-BE49-F238E27FC236}">
-                <a16:creationId xmlns:a16="http://schemas.microsoft.com/office/drawing/2014/main" id="{6F224678-8C24-4F87-9716-A5EE6242E567}"/>
+                <a16:creationId xmlns:a16="http://schemas.microsoft.com/office/drawing/2014/main" id="{53A7EAEC-7B1B-4096-B71B-BD0F02E96265}"/>
               </a:ext>
             </a:extLst>
           </p:cNvPr>
@@ -2112,7 +2112,7 @@
           <p:cNvPr id="2" name="">
             <a:extLst xmlns:a="http://schemas.openxmlformats.org/drawingml/2006/main">
               <a:ext uri="{FF2B5EF4-FFF2-40B4-BE49-F238E27FC236}">
-                <a16:creationId xmlns:a16="http://schemas.microsoft.com/office/drawing/2014/main" id="{122D88E6-AA0E-4C5F-8A23-E23046F0663F}"/>
+                <a16:creationId xmlns:a16="http://schemas.microsoft.com/office/drawing/2014/main" id="{B87E3126-9B47-4C4B-AFDA-B48BB01A9AE1}"/>
               </a:ext>
             </a:extLst>
           </p:cNvPr>
@@ -2169,7 +2169,7 @@
           <p:cNvPr id="3" name="">
             <a:extLst xmlns:a="http://schemas.openxmlformats.org/drawingml/2006/main">
               <a:ext uri="{FF2B5EF4-FFF2-40B4-BE49-F238E27FC236}">
-                <a16:creationId xmlns:a16="http://schemas.microsoft.com/office/drawing/2014/main" id="{65A36042-BEBA-46ED-A3BF-FACFF76487EB}"/>
+                <a16:creationId xmlns:a16="http://schemas.microsoft.com/office/drawing/2014/main" id="{8E0F140B-18C4-44AD-899F-B8A1C3686520}"/>
               </a:ext>
             </a:extLst>
           </p:cNvPr>
@@ -2226,7 +2226,7 @@
           <p:cNvPr id="4" name="">
             <a:extLst xmlns:a="http://schemas.openxmlformats.org/drawingml/2006/main">
               <a:ext uri="{FF2B5EF4-FFF2-40B4-BE49-F238E27FC236}">
-                <a16:creationId xmlns:a16="http://schemas.microsoft.com/office/drawing/2014/main" id="{81F97B9C-E2A5-43CB-95DA-5D23850B34A5}"/>
+                <a16:creationId xmlns:a16="http://schemas.microsoft.com/office/drawing/2014/main" id="{1FB8E7D5-DC71-4C90-9AD3-0CB179E2CCA4}"/>
               </a:ext>
             </a:extLst>
           </p:cNvPr>
@@ -2283,7 +2283,7 @@
           <p:cNvPr id="5" name="">
             <a:extLst xmlns:a="http://schemas.openxmlformats.org/drawingml/2006/main">
               <a:ext uri="{FF2B5EF4-FFF2-40B4-BE49-F238E27FC236}">
-                <a16:creationId xmlns:a16="http://schemas.microsoft.com/office/drawing/2014/main" id="{57C1A7F6-574B-469D-8FDB-5F674B6C73AC}"/>
+                <a16:creationId xmlns:a16="http://schemas.microsoft.com/office/drawing/2014/main" id="{8F0763E3-B9E4-4F4E-B0F2-EC450444D235}"/>
               </a:ext>
             </a:extLst>
           </p:cNvPr>
@@ -2340,7 +2340,7 @@
           <p:cNvPr id="6" name="">
             <a:extLst xmlns:a="http://schemas.openxmlformats.org/drawingml/2006/main">
               <a:ext uri="{FF2B5EF4-FFF2-40B4-BE49-F238E27FC236}">
-                <a16:creationId xmlns:a16="http://schemas.microsoft.com/office/drawing/2014/main" id="{C8BC944C-3F0C-48B4-9950-1211FC761091}"/>
+                <a16:creationId xmlns:a16="http://schemas.microsoft.com/office/drawing/2014/main" id="{DE49390D-323E-40BD-A6CB-9642065C287A}"/>
               </a:ext>
             </a:extLst>
           </p:cNvPr>
@@ -2397,7 +2397,7 @@
           <p:cNvPr id="7" name="">
             <a:extLst xmlns:a="http://schemas.openxmlformats.org/drawingml/2006/main">
               <a:ext uri="{FF2B5EF4-FFF2-40B4-BE49-F238E27FC236}">
-                <a16:creationId xmlns:a16="http://schemas.microsoft.com/office/drawing/2014/main" id="{0279CE60-8AED-4E8A-8155-174922105606}"/>
+                <a16:creationId xmlns:a16="http://schemas.microsoft.com/office/drawing/2014/main" id="{7DF1ABCF-A6B5-45A1-9C6D-23B7EDC0E996}"/>
               </a:ext>
             </a:extLst>
           </p:cNvPr>
@@ -2477,7 +2477,7 @@
           <p:cNvPr id="8" name="">
             <a:extLst xmlns:a="http://schemas.openxmlformats.org/drawingml/2006/main">
               <a:ext uri="{FF2B5EF4-FFF2-40B4-BE49-F238E27FC236}">
-                <a16:creationId xmlns:a16="http://schemas.microsoft.com/office/drawing/2014/main" id="{7EB7DFBE-A3FA-42E0-A525-5991A038F32F}"/>
+                <a16:creationId xmlns:a16="http://schemas.microsoft.com/office/drawing/2014/main" id="{405317F6-06F7-4717-A154-D8D62DA66D81}"/>
               </a:ext>
             </a:extLst>
           </p:cNvPr>
@@ -2532,7 +2532,7 @@
     </p:spTree>
     <p:extLst>
       <p:ext uri="{BB962C8B-B14F-4D97-AF65-F5344CB8AC3E}">
-        <p14:creationId xmlns:p14="http://schemas.microsoft.com/office/powerpoint/2010/main" val="770387514"/>
+        <p14:creationId xmlns:p14="http://schemas.microsoft.com/office/powerpoint/2010/main" val="798683384"/>
       </p:ext>
     </p:extLst>
   </p:cSld>
@@ -2563,7 +2563,7 @@
           <p:cNvPr id="7" name="">
             <a:extLst xmlns:a="http://schemas.openxmlformats.org/drawingml/2006/main">
               <a:ext uri="{FF2B5EF4-FFF2-40B4-BE49-F238E27FC236}">
-                <a16:creationId xmlns:a16="http://schemas.microsoft.com/office/drawing/2014/main" id="{825A1070-2C9E-44C1-B90B-BEB0EA9639C1}"/>
+                <a16:creationId xmlns:a16="http://schemas.microsoft.com/office/drawing/2014/main" id="{A21B91D1-56FD-41D1-938E-06A38076D960}"/>
               </a:ext>
             </a:extLst>
           </p:cNvPr>
@@ -2620,7 +2620,7 @@
           <p:cNvPr id="2" name="">
             <a:extLst xmlns:a="http://schemas.openxmlformats.org/drawingml/2006/main">
               <a:ext uri="{FF2B5EF4-FFF2-40B4-BE49-F238E27FC236}">
-                <a16:creationId xmlns:a16="http://schemas.microsoft.com/office/drawing/2014/main" id="{8035CBBB-1CDC-421E-841C-5FC30B4FE5C8}"/>
+                <a16:creationId xmlns:a16="http://schemas.microsoft.com/office/drawing/2014/main" id="{7374DA61-A289-44E5-A320-A3AE030CEA6F}"/>
               </a:ext>
             </a:extLst>
           </p:cNvPr>
@@ -2677,7 +2677,7 @@
           <p:cNvPr id="3" name="">
             <a:extLst xmlns:a="http://schemas.openxmlformats.org/drawingml/2006/main">
               <a:ext uri="{FF2B5EF4-FFF2-40B4-BE49-F238E27FC236}">
-                <a16:creationId xmlns:a16="http://schemas.microsoft.com/office/drawing/2014/main" id="{36F1A355-FAA6-443D-9F5C-028F2B274F5E}"/>
+                <a16:creationId xmlns:a16="http://schemas.microsoft.com/office/drawing/2014/main" id="{E5E53E14-BEDB-4A06-9063-54C1436511DE}"/>
               </a:ext>
             </a:extLst>
           </p:cNvPr>
@@ -2734,7 +2734,7 @@
           <p:cNvPr id="4" name="">
             <a:extLst xmlns:a="http://schemas.openxmlformats.org/drawingml/2006/main">
               <a:ext uri="{FF2B5EF4-FFF2-40B4-BE49-F238E27FC236}">
-                <a16:creationId xmlns:a16="http://schemas.microsoft.com/office/drawing/2014/main" id="{D78F14E2-07AD-4036-AF80-246D46842A42}"/>
+                <a16:creationId xmlns:a16="http://schemas.microsoft.com/office/drawing/2014/main" id="{BBCA9C0C-5DFC-42BD-B9D0-18164D27DB87}"/>
               </a:ext>
             </a:extLst>
           </p:cNvPr>
@@ -2795,13 +2795,13 @@
           <p:nvPr/>
         </p:nvPicPr>
         <p:blipFill>
-          <a:blip xmlns:r="http://schemas.openxmlformats.org/officeDocument/2006/relationships" xmlns:a="http://schemas.openxmlformats.org/drawingml/2006/main" r:embed="R4b279703e6344050"/>
+          <a:blip xmlns:r="http://schemas.openxmlformats.org/officeDocument/2006/relationships" xmlns:a="http://schemas.openxmlformats.org/drawingml/2006/main" r:embed="Rea8d9dab8b9d401f"/>
           <a:stretch xmlns:a="http://schemas.openxmlformats.org/drawingml/2006/main"/>
         </p:blipFill>
         <p:spPr>
           <a:xfrm xmlns:a="http://schemas.openxmlformats.org/drawingml/2006/main">
-            <a:off x="1262884" y="1028700"/>
-            <a:ext cx="9666233" cy="5143500"/>
+            <a:off x="996841" y="1028700"/>
+            <a:ext cx="10198319" cy="5143500"/>
           </a:xfrm>
           <a:prstGeom xmlns:a="http://schemas.openxmlformats.org/drawingml/2006/main" prst="rect">
             <a:avLst/>
@@ -2813,7 +2813,7 @@
           <p:cNvPr id="6" name="">
             <a:extLst xmlns:a="http://schemas.openxmlformats.org/drawingml/2006/main">
               <a:ext uri="{FF2B5EF4-FFF2-40B4-BE49-F238E27FC236}">
-                <a16:creationId xmlns:a16="http://schemas.microsoft.com/office/drawing/2014/main" id="{937FEB36-2968-49ED-AA2B-596A44687713}"/>
+                <a16:creationId xmlns:a16="http://schemas.microsoft.com/office/drawing/2014/main" id="{97A5A097-1932-4509-A92B-5875242E54BA}"/>
               </a:ext>
             </a:extLst>
           </p:cNvPr>
@@ -2868,7 +2868,7 @@
     </p:spTree>
     <p:extLst>
       <p:ext uri="{BB962C8B-B14F-4D97-AF65-F5344CB8AC3E}">
-        <p14:creationId xmlns:p14="http://schemas.microsoft.com/office/powerpoint/2010/main" val="251180789"/>
+        <p14:creationId xmlns:p14="http://schemas.microsoft.com/office/powerpoint/2010/main" val="1291847265"/>
       </p:ext>
     </p:extLst>
   </p:cSld>
@@ -2899,7 +2899,7 @@
           <p:cNvPr id="7" name="">
             <a:extLst xmlns:a="http://schemas.openxmlformats.org/drawingml/2006/main">
               <a:ext uri="{FF2B5EF4-FFF2-40B4-BE49-F238E27FC236}">
-                <a16:creationId xmlns:a16="http://schemas.microsoft.com/office/drawing/2014/main" id="{5AD6739D-8028-45FD-946F-9EFFE3BE8B90}"/>
+                <a16:creationId xmlns:a16="http://schemas.microsoft.com/office/drawing/2014/main" id="{2C3E14B6-9415-48B2-BC53-B3C5518AC8AE}"/>
               </a:ext>
             </a:extLst>
           </p:cNvPr>
@@ -2956,7 +2956,7 @@
           <p:cNvPr id="2" name="">
             <a:extLst xmlns:a="http://schemas.openxmlformats.org/drawingml/2006/main">
               <a:ext uri="{FF2B5EF4-FFF2-40B4-BE49-F238E27FC236}">
-                <a16:creationId xmlns:a16="http://schemas.microsoft.com/office/drawing/2014/main" id="{9677DF46-6302-4306-9B68-3F01DFD855ED}"/>
+                <a16:creationId xmlns:a16="http://schemas.microsoft.com/office/drawing/2014/main" id="{C9CFA663-C23E-4FB4-BCA2-AC78B464C950}"/>
               </a:ext>
             </a:extLst>
           </p:cNvPr>
@@ -3013,7 +3013,7 @@
           <p:cNvPr id="3" name="">
             <a:extLst xmlns:a="http://schemas.openxmlformats.org/drawingml/2006/main">
               <a:ext uri="{FF2B5EF4-FFF2-40B4-BE49-F238E27FC236}">
-                <a16:creationId xmlns:a16="http://schemas.microsoft.com/office/drawing/2014/main" id="{2FD45CC3-0939-43EC-8E84-A04DCEE196E4}"/>
+                <a16:creationId xmlns:a16="http://schemas.microsoft.com/office/drawing/2014/main" id="{B957C28A-D86F-400C-AA4E-485B65257FFB}"/>
               </a:ext>
             </a:extLst>
           </p:cNvPr>
@@ -3070,7 +3070,7 @@
           <p:cNvPr id="4" name="">
             <a:extLst xmlns:a="http://schemas.openxmlformats.org/drawingml/2006/main">
               <a:ext uri="{FF2B5EF4-FFF2-40B4-BE49-F238E27FC236}">
-                <a16:creationId xmlns:a16="http://schemas.microsoft.com/office/drawing/2014/main" id="{01C0D05B-6291-4220-9D7A-C7532218FD16}"/>
+                <a16:creationId xmlns:a16="http://schemas.microsoft.com/office/drawing/2014/main" id="{C3D4E045-C150-4FA0-9E42-F0C78AD591FE}"/>
               </a:ext>
             </a:extLst>
           </p:cNvPr>
@@ -3131,7 +3131,7 @@
           <p:nvPr/>
         </p:nvPicPr>
         <p:blipFill>
-          <a:blip xmlns:r="http://schemas.openxmlformats.org/officeDocument/2006/relationships" xmlns:a="http://schemas.openxmlformats.org/drawingml/2006/main" r:embed="R3f44a7801bfa485f"/>
+          <a:blip xmlns:r="http://schemas.openxmlformats.org/officeDocument/2006/relationships" xmlns:a="http://schemas.openxmlformats.org/drawingml/2006/main" r:embed="R1f90ac593c794146"/>
           <a:stretch xmlns:a="http://schemas.openxmlformats.org/drawingml/2006/main"/>
         </p:blipFill>
         <p:spPr>
@@ -3149,7 +3149,7 @@
           <p:cNvPr id="6" name="">
             <a:extLst xmlns:a="http://schemas.openxmlformats.org/drawingml/2006/main">
               <a:ext uri="{FF2B5EF4-FFF2-40B4-BE49-F238E27FC236}">
-                <a16:creationId xmlns:a16="http://schemas.microsoft.com/office/drawing/2014/main" id="{91488D28-98AE-498C-B876-ECD76EC87DC9}"/>
+                <a16:creationId xmlns:a16="http://schemas.microsoft.com/office/drawing/2014/main" id="{0D820D84-E89A-4BC9-87AB-55CA89877152}"/>
               </a:ext>
             </a:extLst>
           </p:cNvPr>
@@ -3204,7 +3204,7 @@
     </p:spTree>
     <p:extLst>
       <p:ext uri="{BB962C8B-B14F-4D97-AF65-F5344CB8AC3E}">
-        <p14:creationId xmlns:p14="http://schemas.microsoft.com/office/powerpoint/2010/main" val="1317863225"/>
+        <p14:creationId xmlns:p14="http://schemas.microsoft.com/office/powerpoint/2010/main" val="1261073684"/>
       </p:ext>
     </p:extLst>
   </p:cSld>
@@ -3235,7 +3235,7 @@
           <p:cNvPr id="8" name="">
             <a:extLst xmlns:a="http://schemas.openxmlformats.org/drawingml/2006/main">
               <a:ext uri="{FF2B5EF4-FFF2-40B4-BE49-F238E27FC236}">
-                <a16:creationId xmlns:a16="http://schemas.microsoft.com/office/drawing/2014/main" id="{EAFDFD02-A2B2-4D6F-BD1C-909C6FF26F01}"/>
+                <a16:creationId xmlns:a16="http://schemas.microsoft.com/office/drawing/2014/main" id="{286F1412-0CA5-4CF5-838A-10C3347E2E6B}"/>
               </a:ext>
             </a:extLst>
           </p:cNvPr>
@@ -3292,7 +3292,7 @@
           <p:cNvPr id="2" name="">
             <a:extLst xmlns:a="http://schemas.openxmlformats.org/drawingml/2006/main">
               <a:ext uri="{FF2B5EF4-FFF2-40B4-BE49-F238E27FC236}">
-                <a16:creationId xmlns:a16="http://schemas.microsoft.com/office/drawing/2014/main" id="{5E1AC2A5-43A5-4526-82C3-664B0D45091E}"/>
+                <a16:creationId xmlns:a16="http://schemas.microsoft.com/office/drawing/2014/main" id="{7FE41ADF-0961-4FB2-8427-32E37B510EAA}"/>
               </a:ext>
             </a:extLst>
           </p:cNvPr>
@@ -3349,7 +3349,7 @@
           <p:cNvPr id="3" name="">
             <a:extLst xmlns:a="http://schemas.openxmlformats.org/drawingml/2006/main">
               <a:ext uri="{FF2B5EF4-FFF2-40B4-BE49-F238E27FC236}">
-                <a16:creationId xmlns:a16="http://schemas.microsoft.com/office/drawing/2014/main" id="{41FF9BE0-0B89-4E6C-BFA0-4F2150322561}"/>
+                <a16:creationId xmlns:a16="http://schemas.microsoft.com/office/drawing/2014/main" id="{5B84301A-AAAD-4600-9D6F-6CF3F60BDE21}"/>
               </a:ext>
             </a:extLst>
           </p:cNvPr>
@@ -3406,7 +3406,7 @@
           <p:cNvPr id="4" name="">
             <a:extLst xmlns:a="http://schemas.openxmlformats.org/drawingml/2006/main">
               <a:ext uri="{FF2B5EF4-FFF2-40B4-BE49-F238E27FC236}">
-                <a16:creationId xmlns:a16="http://schemas.microsoft.com/office/drawing/2014/main" id="{25BEAA8F-1092-4694-A7B9-4623CA62B3DC}"/>
+                <a16:creationId xmlns:a16="http://schemas.microsoft.com/office/drawing/2014/main" id="{DE810D18-3743-41DA-91FC-60224307EA37}"/>
               </a:ext>
             </a:extLst>
           </p:cNvPr>
@@ -3467,7 +3467,7 @@
           <p:nvPr/>
         </p:nvPicPr>
         <p:blipFill>
-          <a:blip xmlns:r="http://schemas.openxmlformats.org/officeDocument/2006/relationships" xmlns:a="http://schemas.openxmlformats.org/drawingml/2006/main" r:embed="Rc7155f9de3334533"/>
+          <a:blip xmlns:r="http://schemas.openxmlformats.org/officeDocument/2006/relationships" xmlns:a="http://schemas.openxmlformats.org/drawingml/2006/main" r:embed="R46f5625f4bfe428d"/>
           <a:stretch xmlns:a="http://schemas.openxmlformats.org/drawingml/2006/main"/>
         </p:blipFill>
         <p:spPr>
@@ -3485,7 +3485,7 @@
           <p:cNvPr id="6" name="">
             <a:extLst xmlns:a="http://schemas.openxmlformats.org/drawingml/2006/main">
               <a:ext uri="{FF2B5EF4-FFF2-40B4-BE49-F238E27FC236}">
-                <a16:creationId xmlns:a16="http://schemas.microsoft.com/office/drawing/2014/main" id="{FB1673DC-F9F3-4C15-B598-21BA31B6C16C}"/>
+                <a16:creationId xmlns:a16="http://schemas.microsoft.com/office/drawing/2014/main" id="{9C8B68B5-A728-4A0F-9ECB-5C5FB6F6B04B}"/>
               </a:ext>
             </a:extLst>
           </p:cNvPr>
@@ -3542,7 +3542,7 @@
           <p:cNvPr id="7" name="">
             <a:extLst xmlns:a="http://schemas.openxmlformats.org/drawingml/2006/main">
               <a:ext uri="{FF2B5EF4-FFF2-40B4-BE49-F238E27FC236}">
-                <a16:creationId xmlns:a16="http://schemas.microsoft.com/office/drawing/2014/main" id="{1552A820-E265-4E1E-AF48-07FCB494E0C3}"/>
+                <a16:creationId xmlns:a16="http://schemas.microsoft.com/office/drawing/2014/main" id="{B4092E9B-F2C1-4BFE-8BFE-B695F1727B5F}"/>
               </a:ext>
             </a:extLst>
           </p:cNvPr>
@@ -3625,7 +3625,7 @@
     </p:spTree>
     <p:extLst>
       <p:ext uri="{BB962C8B-B14F-4D97-AF65-F5344CB8AC3E}">
-        <p14:creationId xmlns:p14="http://schemas.microsoft.com/office/powerpoint/2010/main" val="429133491"/>
+        <p14:creationId xmlns:p14="http://schemas.microsoft.com/office/powerpoint/2010/main" val="634872135"/>
       </p:ext>
     </p:extLst>
   </p:cSld>
@@ -3656,7 +3656,7 @@
           <p:cNvPr id="9" name="">
             <a:extLst xmlns:a="http://schemas.openxmlformats.org/drawingml/2006/main">
               <a:ext uri="{FF2B5EF4-FFF2-40B4-BE49-F238E27FC236}">
-                <a16:creationId xmlns:a16="http://schemas.microsoft.com/office/drawing/2014/main" id="{321236D8-FB1E-4557-80CC-AB72AFBB6E21}"/>
+                <a16:creationId xmlns:a16="http://schemas.microsoft.com/office/drawing/2014/main" id="{98821ADB-8A5F-4C24-A575-8AFDE7A67208}"/>
               </a:ext>
             </a:extLst>
           </p:cNvPr>
@@ -3713,7 +3713,7 @@
           <p:cNvPr id="2" name="">
             <a:extLst xmlns:a="http://schemas.openxmlformats.org/drawingml/2006/main">
               <a:ext uri="{FF2B5EF4-FFF2-40B4-BE49-F238E27FC236}">
-                <a16:creationId xmlns:a16="http://schemas.microsoft.com/office/drawing/2014/main" id="{46A21852-B7D9-4EB2-90F7-0DCFA28D4ED5}"/>
+                <a16:creationId xmlns:a16="http://schemas.microsoft.com/office/drawing/2014/main" id="{5E3B77D5-F247-440A-828A-9E062858B9DE}"/>
               </a:ext>
             </a:extLst>
           </p:cNvPr>
@@ -3770,7 +3770,7 @@
           <p:cNvPr id="3" name="">
             <a:extLst xmlns:a="http://schemas.openxmlformats.org/drawingml/2006/main">
               <a:ext uri="{FF2B5EF4-FFF2-40B4-BE49-F238E27FC236}">
-                <a16:creationId xmlns:a16="http://schemas.microsoft.com/office/drawing/2014/main" id="{0C3FB69E-FC5D-4853-A2BA-302591086F7A}"/>
+                <a16:creationId xmlns:a16="http://schemas.microsoft.com/office/drawing/2014/main" id="{DD6D0149-4EE4-49EF-AC94-F2F52C33D789}"/>
               </a:ext>
             </a:extLst>
           </p:cNvPr>
@@ -3827,7 +3827,7 @@
           <p:cNvPr id="4" name="">
             <a:extLst xmlns:a="http://schemas.openxmlformats.org/drawingml/2006/main">
               <a:ext uri="{FF2B5EF4-FFF2-40B4-BE49-F238E27FC236}">
-                <a16:creationId xmlns:a16="http://schemas.microsoft.com/office/drawing/2014/main" id="{359327B8-83C0-4826-9705-87F39F2BFC30}"/>
+                <a16:creationId xmlns:a16="http://schemas.microsoft.com/office/drawing/2014/main" id="{0B49661F-3509-4136-B007-9211DA873CAF}"/>
               </a:ext>
             </a:extLst>
           </p:cNvPr>
@@ -3884,7 +3884,7 @@
           <p:cNvPr id="5" name="">
             <a:extLst xmlns:a="http://schemas.openxmlformats.org/drawingml/2006/main">
               <a:ext uri="{FF2B5EF4-FFF2-40B4-BE49-F238E27FC236}">
-                <a16:creationId xmlns:a16="http://schemas.microsoft.com/office/drawing/2014/main" id="{F960B70B-F035-4B04-A321-DE2F57BB4E13}"/>
+                <a16:creationId xmlns:a16="http://schemas.microsoft.com/office/drawing/2014/main" id="{43876220-88E9-411E-BCE9-83FD7812A9CB}"/>
               </a:ext>
             </a:extLst>
           </p:cNvPr>
@@ -4188,7 +4188,7 @@
           <p:cNvPr id="7" name="">
             <a:extLst xmlns:a="http://schemas.openxmlformats.org/drawingml/2006/main">
               <a:ext uri="{FF2B5EF4-FFF2-40B4-BE49-F238E27FC236}">
-                <a16:creationId xmlns:a16="http://schemas.microsoft.com/office/drawing/2014/main" id="{48618F6B-73F6-4DF0-9582-24A61344881A}"/>
+                <a16:creationId xmlns:a16="http://schemas.microsoft.com/office/drawing/2014/main" id="{1145EFE8-50F5-4878-84D8-3571DE5A0464}"/>
               </a:ext>
             </a:extLst>
           </p:cNvPr>
@@ -4245,7 +4245,7 @@
           <p:cNvPr id="8" name="">
             <a:extLst xmlns:a="http://schemas.openxmlformats.org/drawingml/2006/main">
               <a:ext uri="{FF2B5EF4-FFF2-40B4-BE49-F238E27FC236}">
-                <a16:creationId xmlns:a16="http://schemas.microsoft.com/office/drawing/2014/main" id="{D091CFC0-FBA9-4B3E-AD70-A1C8E3B44D33}"/>
+                <a16:creationId xmlns:a16="http://schemas.microsoft.com/office/drawing/2014/main" id="{44969CD6-3E99-4FA0-A638-BAA34AEDAA0A}"/>
               </a:ext>
             </a:extLst>
           </p:cNvPr>
@@ -4300,7 +4300,7 @@
     </p:spTree>
     <p:extLst>
       <p:ext uri="{BB962C8B-B14F-4D97-AF65-F5344CB8AC3E}">
-        <p14:creationId xmlns:p14="http://schemas.microsoft.com/office/powerpoint/2010/main" val="1116444970"/>
+        <p14:creationId xmlns:p14="http://schemas.microsoft.com/office/powerpoint/2010/main" val="1772708109"/>
       </p:ext>
     </p:extLst>
   </p:cSld>
@@ -4331,7 +4331,7 @@
           <p:cNvPr id="8" name="">
             <a:extLst xmlns:a="http://schemas.openxmlformats.org/drawingml/2006/main">
               <a:ext uri="{FF2B5EF4-FFF2-40B4-BE49-F238E27FC236}">
-                <a16:creationId xmlns:a16="http://schemas.microsoft.com/office/drawing/2014/main" id="{1F97F416-7675-4BBF-9CBB-B2C9C1DAB26D}"/>
+                <a16:creationId xmlns:a16="http://schemas.microsoft.com/office/drawing/2014/main" id="{F1AB7F69-B7EF-4E64-9866-40A18028ABB0}"/>
               </a:ext>
             </a:extLst>
           </p:cNvPr>
@@ -4388,7 +4388,7 @@
           <p:cNvPr id="2" name="">
             <a:extLst xmlns:a="http://schemas.openxmlformats.org/drawingml/2006/main">
               <a:ext uri="{FF2B5EF4-FFF2-40B4-BE49-F238E27FC236}">
-                <a16:creationId xmlns:a16="http://schemas.microsoft.com/office/drawing/2014/main" id="{26DADC63-782C-4170-AC67-09EFD30EE3D8}"/>
+                <a16:creationId xmlns:a16="http://schemas.microsoft.com/office/drawing/2014/main" id="{80C7FDDA-4B02-4578-9697-FBFD58187C1C}"/>
               </a:ext>
             </a:extLst>
           </p:cNvPr>
@@ -4445,7 +4445,7 @@
           <p:cNvPr id="3" name="">
             <a:extLst xmlns:a="http://schemas.openxmlformats.org/drawingml/2006/main">
               <a:ext uri="{FF2B5EF4-FFF2-40B4-BE49-F238E27FC236}">
-                <a16:creationId xmlns:a16="http://schemas.microsoft.com/office/drawing/2014/main" id="{25D14D91-BF95-40EF-AA52-BDB2ED23ECE6}"/>
+                <a16:creationId xmlns:a16="http://schemas.microsoft.com/office/drawing/2014/main" id="{A81B7B4D-F284-412A-8DB7-30612B35E349}"/>
               </a:ext>
             </a:extLst>
           </p:cNvPr>
@@ -4502,7 +4502,7 @@
           <p:cNvPr id="4" name="">
             <a:extLst xmlns:a="http://schemas.openxmlformats.org/drawingml/2006/main">
               <a:ext uri="{FF2B5EF4-FFF2-40B4-BE49-F238E27FC236}">
-                <a16:creationId xmlns:a16="http://schemas.microsoft.com/office/drawing/2014/main" id="{526BDCE2-2A62-483A-81C4-0F6F332561DD}"/>
+                <a16:creationId xmlns:a16="http://schemas.microsoft.com/office/drawing/2014/main" id="{AC69B0A6-2BC0-4C05-B915-E0266A73653F}"/>
               </a:ext>
             </a:extLst>
           </p:cNvPr>
@@ -4559,7 +4559,7 @@
           <p:cNvPr id="5" name="">
             <a:extLst xmlns:a="http://schemas.openxmlformats.org/drawingml/2006/main">
               <a:ext uri="{FF2B5EF4-FFF2-40B4-BE49-F238E27FC236}">
-                <a16:creationId xmlns:a16="http://schemas.microsoft.com/office/drawing/2014/main" id="{811B6381-9765-4E66-B3AF-6C2AAC391449}"/>
+                <a16:creationId xmlns:a16="http://schemas.microsoft.com/office/drawing/2014/main" id="{031AE53B-7C16-404B-8E31-44D2B7AF0198}"/>
               </a:ext>
             </a:extLst>
           </p:cNvPr>
@@ -4616,7 +4616,7 @@
           <p:cNvPr id="6" name="">
             <a:extLst xmlns:a="http://schemas.openxmlformats.org/drawingml/2006/main">
               <a:ext uri="{FF2B5EF4-FFF2-40B4-BE49-F238E27FC236}">
-                <a16:creationId xmlns:a16="http://schemas.microsoft.com/office/drawing/2014/main" id="{D3B13E93-F698-4527-9C07-2BE3F971BFE1}"/>
+                <a16:creationId xmlns:a16="http://schemas.microsoft.com/office/drawing/2014/main" id="{73B74BC3-38E9-4C5B-B922-815D72892969}"/>
               </a:ext>
             </a:extLst>
           </p:cNvPr>
@@ -4673,7 +4673,7 @@
           <p:cNvPr id="7" name="">
             <a:extLst xmlns:a="http://schemas.openxmlformats.org/drawingml/2006/main">
               <a:ext uri="{FF2B5EF4-FFF2-40B4-BE49-F238E27FC236}">
-                <a16:creationId xmlns:a16="http://schemas.microsoft.com/office/drawing/2014/main" id="{8A0401EC-5B75-4BCC-AC53-985909101359}"/>
+                <a16:creationId xmlns:a16="http://schemas.microsoft.com/office/drawing/2014/main" id="{4950219B-B492-428D-AD83-A521FC83CDC5}"/>
               </a:ext>
             </a:extLst>
           </p:cNvPr>
@@ -4728,7 +4728,7 @@
     </p:spTree>
     <p:extLst>
       <p:ext uri="{BB962C8B-B14F-4D97-AF65-F5344CB8AC3E}">
-        <p14:creationId xmlns:p14="http://schemas.microsoft.com/office/powerpoint/2010/main" val="101256378"/>
+        <p14:creationId xmlns:p14="http://schemas.microsoft.com/office/powerpoint/2010/main" val="1636770395"/>
       </p:ext>
     </p:extLst>
   </p:cSld>
@@ -4759,7 +4759,7 @@
           <p:cNvPr id="8" name="">
             <a:extLst xmlns:a="http://schemas.openxmlformats.org/drawingml/2006/main">
               <a:ext uri="{FF2B5EF4-FFF2-40B4-BE49-F238E27FC236}">
-                <a16:creationId xmlns:a16="http://schemas.microsoft.com/office/drawing/2014/main" id="{AC42142E-187C-421B-88AA-33A1F86C41CD}"/>
+                <a16:creationId xmlns:a16="http://schemas.microsoft.com/office/drawing/2014/main" id="{E9A168C8-7337-4F2F-9BED-023C88E47FF6}"/>
               </a:ext>
             </a:extLst>
           </p:cNvPr>
@@ -4816,7 +4816,7 @@
           <p:cNvPr id="2" name="">
             <a:extLst xmlns:a="http://schemas.openxmlformats.org/drawingml/2006/main">
               <a:ext uri="{FF2B5EF4-FFF2-40B4-BE49-F238E27FC236}">
-                <a16:creationId xmlns:a16="http://schemas.microsoft.com/office/drawing/2014/main" id="{E09E0294-989D-4F9F-9EC6-86177B325AD3}"/>
+                <a16:creationId xmlns:a16="http://schemas.microsoft.com/office/drawing/2014/main" id="{E7A5807B-FEED-4ECF-9A51-4272D065795F}"/>
               </a:ext>
             </a:extLst>
           </p:cNvPr>
@@ -4873,7 +4873,7 @@
           <p:cNvPr id="3" name="">
             <a:extLst xmlns:a="http://schemas.openxmlformats.org/drawingml/2006/main">
               <a:ext uri="{FF2B5EF4-FFF2-40B4-BE49-F238E27FC236}">
-                <a16:creationId xmlns:a16="http://schemas.microsoft.com/office/drawing/2014/main" id="{021DC6B3-B741-4867-B135-E6605236CCCC}"/>
+                <a16:creationId xmlns:a16="http://schemas.microsoft.com/office/drawing/2014/main" id="{E2D916AE-0A39-48FE-B379-36958612183F}"/>
               </a:ext>
             </a:extLst>
           </p:cNvPr>
@@ -4930,7 +4930,7 @@
           <p:cNvPr id="4" name="">
             <a:extLst xmlns:a="http://schemas.openxmlformats.org/drawingml/2006/main">
               <a:ext uri="{FF2B5EF4-FFF2-40B4-BE49-F238E27FC236}">
-                <a16:creationId xmlns:a16="http://schemas.microsoft.com/office/drawing/2014/main" id="{35F8E8A5-8344-485E-B399-2C70259929D4}"/>
+                <a16:creationId xmlns:a16="http://schemas.microsoft.com/office/drawing/2014/main" id="{C5B07D9A-BFA7-4833-9927-04BE98AE37B8}"/>
               </a:ext>
             </a:extLst>
           </p:cNvPr>
@@ -5269,7 +5269,7 @@
           <p:cNvPr id="6" name="">
             <a:extLst xmlns:a="http://schemas.openxmlformats.org/drawingml/2006/main">
               <a:ext uri="{FF2B5EF4-FFF2-40B4-BE49-F238E27FC236}">
-                <a16:creationId xmlns:a16="http://schemas.microsoft.com/office/drawing/2014/main" id="{BD293830-BB62-458F-B326-9FC31949318B}"/>
+                <a16:creationId xmlns:a16="http://schemas.microsoft.com/office/drawing/2014/main" id="{AC1AACD3-73E8-4E73-8A7D-80B0D0B35BFC}"/>
               </a:ext>
             </a:extLst>
           </p:cNvPr>
@@ -5326,7 +5326,7 @@
           <p:cNvPr id="7" name="">
             <a:extLst xmlns:a="http://schemas.openxmlformats.org/drawingml/2006/main">
               <a:ext uri="{FF2B5EF4-FFF2-40B4-BE49-F238E27FC236}">
-                <a16:creationId xmlns:a16="http://schemas.microsoft.com/office/drawing/2014/main" id="{8E9854AF-B743-4057-968E-30A708F95F88}"/>
+                <a16:creationId xmlns:a16="http://schemas.microsoft.com/office/drawing/2014/main" id="{47A72EFF-37E6-46B4-A687-EDE19EFA1680}"/>
               </a:ext>
             </a:extLst>
           </p:cNvPr>
@@ -5381,7 +5381,7 @@
     </p:spTree>
     <p:extLst>
       <p:ext uri="{BB962C8B-B14F-4D97-AF65-F5344CB8AC3E}">
-        <p14:creationId xmlns:p14="http://schemas.microsoft.com/office/powerpoint/2010/main" val="381876132"/>
+        <p14:creationId xmlns:p14="http://schemas.microsoft.com/office/powerpoint/2010/main" val="1292841609"/>
       </p:ext>
     </p:extLst>
   </p:cSld>
@@ -5412,7 +5412,7 @@
           <p:cNvPr id="7" name="">
             <a:extLst xmlns:a="http://schemas.openxmlformats.org/drawingml/2006/main">
               <a:ext uri="{FF2B5EF4-FFF2-40B4-BE49-F238E27FC236}">
-                <a16:creationId xmlns:a16="http://schemas.microsoft.com/office/drawing/2014/main" id="{6708BA26-4E4A-4D07-A11D-DCFFADADB797}"/>
+                <a16:creationId xmlns:a16="http://schemas.microsoft.com/office/drawing/2014/main" id="{361BABC0-37BB-42A7-91D8-BECD1FA26554}"/>
               </a:ext>
             </a:extLst>
           </p:cNvPr>
@@ -5469,7 +5469,7 @@
           <p:cNvPr id="2" name="">
             <a:extLst xmlns:a="http://schemas.openxmlformats.org/drawingml/2006/main">
               <a:ext uri="{FF2B5EF4-FFF2-40B4-BE49-F238E27FC236}">
-                <a16:creationId xmlns:a16="http://schemas.microsoft.com/office/drawing/2014/main" id="{D75E65B5-6012-4C13-BDF7-B64AF3061BD9}"/>
+                <a16:creationId xmlns:a16="http://schemas.microsoft.com/office/drawing/2014/main" id="{37C00A5A-A647-4536-94C2-9F3F8DB9F13B}"/>
               </a:ext>
             </a:extLst>
           </p:cNvPr>
@@ -5526,7 +5526,7 @@
           <p:cNvPr id="3" name="">
             <a:extLst xmlns:a="http://schemas.openxmlformats.org/drawingml/2006/main">
               <a:ext uri="{FF2B5EF4-FFF2-40B4-BE49-F238E27FC236}">
-                <a16:creationId xmlns:a16="http://schemas.microsoft.com/office/drawing/2014/main" id="{7AF9ADB7-6EEC-4B25-BA8A-F09ADF5798E1}"/>
+                <a16:creationId xmlns:a16="http://schemas.microsoft.com/office/drawing/2014/main" id="{167114A4-A069-4D8D-B0EE-50C3E18F3CE6}"/>
               </a:ext>
             </a:extLst>
           </p:cNvPr>
@@ -5583,7 +5583,7 @@
           <p:cNvPr id="4" name="">
             <a:extLst xmlns:a="http://schemas.openxmlformats.org/drawingml/2006/main">
               <a:ext uri="{FF2B5EF4-FFF2-40B4-BE49-F238E27FC236}">
-                <a16:creationId xmlns:a16="http://schemas.microsoft.com/office/drawing/2014/main" id="{06C93596-C79E-45B2-96B2-A96ACFA7F194}"/>
+                <a16:creationId xmlns:a16="http://schemas.microsoft.com/office/drawing/2014/main" id="{D2E639B1-A5FB-4EC5-9CE6-FC0E581B607C}"/>
               </a:ext>
             </a:extLst>
           </p:cNvPr>
@@ -6017,7 +6017,7 @@
           <p:cNvPr id="6" name="">
             <a:extLst xmlns:a="http://schemas.openxmlformats.org/drawingml/2006/main">
               <a:ext uri="{FF2B5EF4-FFF2-40B4-BE49-F238E27FC236}">
-                <a16:creationId xmlns:a16="http://schemas.microsoft.com/office/drawing/2014/main" id="{827BC9FF-7C70-4EBF-8C18-F84D3079C89E}"/>
+                <a16:creationId xmlns:a16="http://schemas.microsoft.com/office/drawing/2014/main" id="{691AC983-8BDA-4C0A-A260-F2CB137F2459}"/>
               </a:ext>
             </a:extLst>
           </p:cNvPr>
@@ -6072,7 +6072,7 @@
     </p:spTree>
     <p:extLst>
       <p:ext uri="{BB962C8B-B14F-4D97-AF65-F5344CB8AC3E}">
-        <p14:creationId xmlns:p14="http://schemas.microsoft.com/office/powerpoint/2010/main" val="649372558"/>
+        <p14:creationId xmlns:p14="http://schemas.microsoft.com/office/powerpoint/2010/main" val="544368125"/>
       </p:ext>
     </p:extLst>
   </p:cSld>
@@ -6103,7 +6103,7 @@
           <p:cNvPr id="9" name="">
             <a:extLst xmlns:a="http://schemas.openxmlformats.org/drawingml/2006/main">
               <a:ext uri="{FF2B5EF4-FFF2-40B4-BE49-F238E27FC236}">
-                <a16:creationId xmlns:a16="http://schemas.microsoft.com/office/drawing/2014/main" id="{00FCF519-23D7-4F86-9904-0E689E7FC02A}"/>
+                <a16:creationId xmlns:a16="http://schemas.microsoft.com/office/drawing/2014/main" id="{B2832ADB-45C5-4BD3-859F-A60B620A89EA}"/>
               </a:ext>
             </a:extLst>
           </p:cNvPr>
@@ -6160,7 +6160,7 @@
           <p:cNvPr id="2" name="">
             <a:extLst xmlns:a="http://schemas.openxmlformats.org/drawingml/2006/main">
               <a:ext uri="{FF2B5EF4-FFF2-40B4-BE49-F238E27FC236}">
-                <a16:creationId xmlns:a16="http://schemas.microsoft.com/office/drawing/2014/main" id="{EA9EF959-A0BF-47AF-909F-89EADEFEBC8C}"/>
+                <a16:creationId xmlns:a16="http://schemas.microsoft.com/office/drawing/2014/main" id="{F015D9E8-BF6C-4D70-90A6-62125654ED87}"/>
               </a:ext>
             </a:extLst>
           </p:cNvPr>
@@ -6217,7 +6217,7 @@
           <p:cNvPr id="3" name="">
             <a:extLst xmlns:a="http://schemas.openxmlformats.org/drawingml/2006/main">
               <a:ext uri="{FF2B5EF4-FFF2-40B4-BE49-F238E27FC236}">
-                <a16:creationId xmlns:a16="http://schemas.microsoft.com/office/drawing/2014/main" id="{662BB04C-B9B4-4CBC-9231-38961C630C42}"/>
+                <a16:creationId xmlns:a16="http://schemas.microsoft.com/office/drawing/2014/main" id="{55D71DC4-875A-4589-8ED9-77BA215A0F9A}"/>
               </a:ext>
             </a:extLst>
           </p:cNvPr>
@@ -6274,7 +6274,7 @@
           <p:cNvPr id="4" name="">
             <a:extLst xmlns:a="http://schemas.openxmlformats.org/drawingml/2006/main">
               <a:ext uri="{FF2B5EF4-FFF2-40B4-BE49-F238E27FC236}">
-                <a16:creationId xmlns:a16="http://schemas.microsoft.com/office/drawing/2014/main" id="{FF963E17-42BC-4D4A-AFF5-6E1ABBF1D6E8}"/>
+                <a16:creationId xmlns:a16="http://schemas.microsoft.com/office/drawing/2014/main" id="{5B4E39C9-D891-4E8C-A812-5D6CDA948BA2}"/>
               </a:ext>
             </a:extLst>
           </p:cNvPr>
@@ -6335,7 +6335,7 @@
           <p:nvPr/>
         </p:nvPicPr>
         <p:blipFill>
-          <a:blip xmlns:r="http://schemas.openxmlformats.org/officeDocument/2006/relationships" xmlns:a="http://schemas.openxmlformats.org/drawingml/2006/main" r:embed="Rb9e7fb062fd049e3"/>
+          <a:blip xmlns:r="http://schemas.openxmlformats.org/officeDocument/2006/relationships" xmlns:a="http://schemas.openxmlformats.org/drawingml/2006/main" r:embed="R39b4668ca227435c"/>
           <a:stretch xmlns:a="http://schemas.openxmlformats.org/drawingml/2006/main"/>
         </p:blipFill>
         <p:spPr>
@@ -6353,7 +6353,7 @@
           <p:cNvPr id="6" name="">
             <a:extLst xmlns:a="http://schemas.openxmlformats.org/drawingml/2006/main">
               <a:ext uri="{FF2B5EF4-FFF2-40B4-BE49-F238E27FC236}">
-                <a16:creationId xmlns:a16="http://schemas.microsoft.com/office/drawing/2014/main" id="{6DB926BD-C574-495B-B0F8-003C3B1C5A23}"/>
+                <a16:creationId xmlns:a16="http://schemas.microsoft.com/office/drawing/2014/main" id="{3A507953-3A72-4D64-A03C-7A16E4C6AAE0}"/>
               </a:ext>
             </a:extLst>
           </p:cNvPr>
@@ -6410,7 +6410,7 @@
           <p:cNvPr id="7" name="">
             <a:extLst xmlns:a="http://schemas.openxmlformats.org/drawingml/2006/main">
               <a:ext uri="{FF2B5EF4-FFF2-40B4-BE49-F238E27FC236}">
-                <a16:creationId xmlns:a16="http://schemas.microsoft.com/office/drawing/2014/main" id="{F29B4003-DF04-439F-98C9-E4083C625ABA}"/>
+                <a16:creationId xmlns:a16="http://schemas.microsoft.com/office/drawing/2014/main" id="{6D64FC58-D21F-4948-A22D-028CE385ABD2}"/>
               </a:ext>
             </a:extLst>
           </p:cNvPr>
@@ -6536,7 +6536,7 @@
           <p:cNvPr id="8" name="">
             <a:extLst xmlns:a="http://schemas.openxmlformats.org/drawingml/2006/main">
               <a:ext uri="{FF2B5EF4-FFF2-40B4-BE49-F238E27FC236}">
-                <a16:creationId xmlns:a16="http://schemas.microsoft.com/office/drawing/2014/main" id="{53A868D5-A782-4DEF-B9FD-3D9D88BC0FC0}"/>
+                <a16:creationId xmlns:a16="http://schemas.microsoft.com/office/drawing/2014/main" id="{5FA24884-393B-42A8-9C67-5E2AA3CBDCF7}"/>
               </a:ext>
             </a:extLst>
           </p:cNvPr>
@@ -6591,7 +6591,7 @@
     </p:spTree>
     <p:extLst>
       <p:ext uri="{BB962C8B-B14F-4D97-AF65-F5344CB8AC3E}">
-        <p14:creationId xmlns:p14="http://schemas.microsoft.com/office/powerpoint/2010/main" val="1257553538"/>
+        <p14:creationId xmlns:p14="http://schemas.microsoft.com/office/powerpoint/2010/main" val="1760624333"/>
       </p:ext>
     </p:extLst>
   </p:cSld>
@@ -6622,7 +6622,7 @@
           <p:cNvPr id="7" name="">
             <a:extLst xmlns:a="http://schemas.openxmlformats.org/drawingml/2006/main">
               <a:ext uri="{FF2B5EF4-FFF2-40B4-BE49-F238E27FC236}">
-                <a16:creationId xmlns:a16="http://schemas.microsoft.com/office/drawing/2014/main" id="{4029D8D0-061B-4F9D-BC1C-CED6AB800437}"/>
+                <a16:creationId xmlns:a16="http://schemas.microsoft.com/office/drawing/2014/main" id="{0D0E726A-EDDE-4E9F-8B40-1EDA87561DF7}"/>
               </a:ext>
             </a:extLst>
           </p:cNvPr>
@@ -6679,7 +6679,7 @@
           <p:cNvPr id="2" name="">
             <a:extLst xmlns:a="http://schemas.openxmlformats.org/drawingml/2006/main">
               <a:ext uri="{FF2B5EF4-FFF2-40B4-BE49-F238E27FC236}">
-                <a16:creationId xmlns:a16="http://schemas.microsoft.com/office/drawing/2014/main" id="{ED15D954-8941-4A4B-BF07-05C5F6FD86E9}"/>
+                <a16:creationId xmlns:a16="http://schemas.microsoft.com/office/drawing/2014/main" id="{F8E730DD-5DA7-43F9-8A4D-9CBA2DF1A335}"/>
               </a:ext>
             </a:extLst>
           </p:cNvPr>
@@ -6736,7 +6736,7 @@
           <p:cNvPr id="3" name="">
             <a:extLst xmlns:a="http://schemas.openxmlformats.org/drawingml/2006/main">
               <a:ext uri="{FF2B5EF4-FFF2-40B4-BE49-F238E27FC236}">
-                <a16:creationId xmlns:a16="http://schemas.microsoft.com/office/drawing/2014/main" id="{C45784C8-BCE6-41E0-9006-626C162EBD99}"/>
+                <a16:creationId xmlns:a16="http://schemas.microsoft.com/office/drawing/2014/main" id="{160C7708-8416-4106-AD12-4256336FEB0D}"/>
               </a:ext>
             </a:extLst>
           </p:cNvPr>
@@ -6793,7 +6793,7 @@
           <p:cNvPr id="4" name="">
             <a:extLst xmlns:a="http://schemas.openxmlformats.org/drawingml/2006/main">
               <a:ext uri="{FF2B5EF4-FFF2-40B4-BE49-F238E27FC236}">
-                <a16:creationId xmlns:a16="http://schemas.microsoft.com/office/drawing/2014/main" id="{1FD95CB4-3453-473D-9B2E-9885BAC58C64}"/>
+                <a16:creationId xmlns:a16="http://schemas.microsoft.com/office/drawing/2014/main" id="{A53A59A5-BF34-461E-BE61-2D7BFD220FAA}"/>
               </a:ext>
             </a:extLst>
           </p:cNvPr>
@@ -6854,7 +6854,7 @@
           <p:nvPr/>
         </p:nvPicPr>
         <p:blipFill>
-          <a:blip xmlns:r="http://schemas.openxmlformats.org/officeDocument/2006/relationships" xmlns:a="http://schemas.openxmlformats.org/drawingml/2006/main" r:embed="Rc89eef3a58e54d06"/>
+          <a:blip xmlns:r="http://schemas.openxmlformats.org/officeDocument/2006/relationships" xmlns:a="http://schemas.openxmlformats.org/drawingml/2006/main" r:embed="R7550870ac80c4276"/>
           <a:stretch xmlns:a="http://schemas.openxmlformats.org/drawingml/2006/main"/>
         </p:blipFill>
         <p:spPr>
@@ -6872,7 +6872,7 @@
           <p:cNvPr id="6" name="">
             <a:extLst xmlns:a="http://schemas.openxmlformats.org/drawingml/2006/main">
               <a:ext uri="{FF2B5EF4-FFF2-40B4-BE49-F238E27FC236}">
-                <a16:creationId xmlns:a16="http://schemas.microsoft.com/office/drawing/2014/main" id="{C6A5FE2C-EF46-4754-9E6B-2162E599CFDB}"/>
+                <a16:creationId xmlns:a16="http://schemas.microsoft.com/office/drawing/2014/main" id="{2A1198A1-91E7-43E1-B7D2-7E283FF9C78F}"/>
               </a:ext>
             </a:extLst>
           </p:cNvPr>
@@ -6927,7 +6927,7 @@
     </p:spTree>
     <p:extLst>
       <p:ext uri="{BB962C8B-B14F-4D97-AF65-F5344CB8AC3E}">
-        <p14:creationId xmlns:p14="http://schemas.microsoft.com/office/powerpoint/2010/main" val="1805453070"/>
+        <p14:creationId xmlns:p14="http://schemas.microsoft.com/office/powerpoint/2010/main" val="1848207180"/>
       </p:ext>
     </p:extLst>
   </p:cSld>
@@ -6958,7 +6958,7 @@
           <p:cNvPr id="10" name="">
             <a:extLst xmlns:a="http://schemas.openxmlformats.org/drawingml/2006/main">
               <a:ext uri="{FF2B5EF4-FFF2-40B4-BE49-F238E27FC236}">
-                <a16:creationId xmlns:a16="http://schemas.microsoft.com/office/drawing/2014/main" id="{D9A6593A-6E6D-427D-A795-5DEB521EB4D4}"/>
+                <a16:creationId xmlns:a16="http://schemas.microsoft.com/office/drawing/2014/main" id="{32AC49F4-BC57-4C5B-B27E-7D82A94E38AC}"/>
               </a:ext>
             </a:extLst>
           </p:cNvPr>
@@ -7015,7 +7015,7 @@
           <p:cNvPr id="2" name="">
             <a:extLst xmlns:a="http://schemas.openxmlformats.org/drawingml/2006/main">
               <a:ext uri="{FF2B5EF4-FFF2-40B4-BE49-F238E27FC236}">
-                <a16:creationId xmlns:a16="http://schemas.microsoft.com/office/drawing/2014/main" id="{B4EAE52C-BD34-4979-AF2A-2B78EC8D32DB}"/>
+                <a16:creationId xmlns:a16="http://schemas.microsoft.com/office/drawing/2014/main" id="{43C8F17F-DD80-4641-81D1-8A0490F11F86}"/>
               </a:ext>
             </a:extLst>
           </p:cNvPr>
@@ -7072,7 +7072,7 @@
           <p:cNvPr id="3" name="">
             <a:extLst xmlns:a="http://schemas.openxmlformats.org/drawingml/2006/main">
               <a:ext uri="{FF2B5EF4-FFF2-40B4-BE49-F238E27FC236}">
-                <a16:creationId xmlns:a16="http://schemas.microsoft.com/office/drawing/2014/main" id="{59010D7A-DDDD-4B09-992E-FFAF1A87D3B7}"/>
+                <a16:creationId xmlns:a16="http://schemas.microsoft.com/office/drawing/2014/main" id="{451DEFC2-9949-4FB1-84C9-E553899B6056}"/>
               </a:ext>
             </a:extLst>
           </p:cNvPr>
@@ -7129,7 +7129,7 @@
           <p:cNvPr id="4" name="">
             <a:extLst xmlns:a="http://schemas.openxmlformats.org/drawingml/2006/main">
               <a:ext uri="{FF2B5EF4-FFF2-40B4-BE49-F238E27FC236}">
-                <a16:creationId xmlns:a16="http://schemas.microsoft.com/office/drawing/2014/main" id="{D1A5F254-09E0-45F1-98C7-52A19B1A622B}"/>
+                <a16:creationId xmlns:a16="http://schemas.microsoft.com/office/drawing/2014/main" id="{5A3DAC44-C5C7-471D-B874-83483D146A59}"/>
               </a:ext>
             </a:extLst>
           </p:cNvPr>
@@ -7190,7 +7190,7 @@
           <p:nvPr/>
         </p:nvPicPr>
         <p:blipFill>
-          <a:blip xmlns:r="http://schemas.openxmlformats.org/officeDocument/2006/relationships" xmlns:a="http://schemas.openxmlformats.org/drawingml/2006/main" r:embed="Rd17e1403a0db42d0"/>
+          <a:blip xmlns:r="http://schemas.openxmlformats.org/officeDocument/2006/relationships" xmlns:a="http://schemas.openxmlformats.org/drawingml/2006/main" r:embed="Ra80fcb6945184530"/>
           <a:stretch xmlns:a="http://schemas.openxmlformats.org/drawingml/2006/main"/>
         </p:blipFill>
         <p:spPr>
@@ -7208,7 +7208,7 @@
           <p:cNvPr id="6" name="">
             <a:extLst xmlns:a="http://schemas.openxmlformats.org/drawingml/2006/main">
               <a:ext uri="{FF2B5EF4-FFF2-40B4-BE49-F238E27FC236}">
-                <a16:creationId xmlns:a16="http://schemas.microsoft.com/office/drawing/2014/main" id="{7FF866AD-CA24-4E64-8437-892657ABF77C}"/>
+                <a16:creationId xmlns:a16="http://schemas.microsoft.com/office/drawing/2014/main" id="{CEBBF787-B51D-4B87-9CD3-F60608837D9C}"/>
               </a:ext>
             </a:extLst>
           </p:cNvPr>
@@ -7288,7 +7288,7 @@
           <p:cNvPr id="7" name="">
             <a:extLst xmlns:a="http://schemas.openxmlformats.org/drawingml/2006/main">
               <a:ext uri="{FF2B5EF4-FFF2-40B4-BE49-F238E27FC236}">
-                <a16:creationId xmlns:a16="http://schemas.microsoft.com/office/drawing/2014/main" id="{0C589080-0389-4866-BE7D-1DBB09738529}"/>
+                <a16:creationId xmlns:a16="http://schemas.microsoft.com/office/drawing/2014/main" id="{1A4BFEC0-BB63-42F9-A8D7-5CAF2A409BBB}"/>
               </a:ext>
             </a:extLst>
           </p:cNvPr>
@@ -7368,7 +7368,7 @@
           <p:cNvPr id="8" name="">
             <a:extLst xmlns:a="http://schemas.openxmlformats.org/drawingml/2006/main">
               <a:ext uri="{FF2B5EF4-FFF2-40B4-BE49-F238E27FC236}">
-                <a16:creationId xmlns:a16="http://schemas.microsoft.com/office/drawing/2014/main" id="{7130A11B-59F9-4A76-8A49-64D6059EE510}"/>
+                <a16:creationId xmlns:a16="http://schemas.microsoft.com/office/drawing/2014/main" id="{781A4672-C110-4C02-BF58-C7797675858D}"/>
               </a:ext>
             </a:extLst>
           </p:cNvPr>
@@ -7471,7 +7471,7 @@
           <p:cNvPr id="9" name="">
             <a:extLst xmlns:a="http://schemas.openxmlformats.org/drawingml/2006/main">
               <a:ext uri="{FF2B5EF4-FFF2-40B4-BE49-F238E27FC236}">
-                <a16:creationId xmlns:a16="http://schemas.microsoft.com/office/drawing/2014/main" id="{F6A24658-22A2-4FFB-9D83-FF190C863CCF}"/>
+                <a16:creationId xmlns:a16="http://schemas.microsoft.com/office/drawing/2014/main" id="{ECF00A6E-A3C2-4D9C-9CF6-6A4EC6DE2904}"/>
               </a:ext>
             </a:extLst>
           </p:cNvPr>
@@ -7526,7 +7526,7 @@
     </p:spTree>
     <p:extLst>
       <p:ext uri="{BB962C8B-B14F-4D97-AF65-F5344CB8AC3E}">
-        <p14:creationId xmlns:p14="http://schemas.microsoft.com/office/powerpoint/2010/main" val="1267506133"/>
+        <p14:creationId xmlns:p14="http://schemas.microsoft.com/office/powerpoint/2010/main" val="85655303"/>
       </p:ext>
     </p:extLst>
   </p:cSld>
@@ -7557,7 +7557,7 @@
           <p:cNvPr id="8" name="">
             <a:extLst xmlns:a="http://schemas.openxmlformats.org/drawingml/2006/main">
               <a:ext uri="{FF2B5EF4-FFF2-40B4-BE49-F238E27FC236}">
-                <a16:creationId xmlns:a16="http://schemas.microsoft.com/office/drawing/2014/main" id="{AA7ED736-487E-4F56-B396-BADBC5106310}"/>
+                <a16:creationId xmlns:a16="http://schemas.microsoft.com/office/drawing/2014/main" id="{CFB5D491-7145-498C-8CEC-6DF4EA47F5FB}"/>
               </a:ext>
             </a:extLst>
           </p:cNvPr>
@@ -7614,7 +7614,7 @@
           <p:cNvPr id="2" name="">
             <a:extLst xmlns:a="http://schemas.openxmlformats.org/drawingml/2006/main">
               <a:ext uri="{FF2B5EF4-FFF2-40B4-BE49-F238E27FC236}">
-                <a16:creationId xmlns:a16="http://schemas.microsoft.com/office/drawing/2014/main" id="{40EBD3C0-AF05-4C41-8C6F-8AD824AA8B5F}"/>
+                <a16:creationId xmlns:a16="http://schemas.microsoft.com/office/drawing/2014/main" id="{232D97BA-9409-4A0B-B01A-4688491AC021}"/>
               </a:ext>
             </a:extLst>
           </p:cNvPr>
@@ -7671,7 +7671,7 @@
           <p:cNvPr id="3" name="">
             <a:extLst xmlns:a="http://schemas.openxmlformats.org/drawingml/2006/main">
               <a:ext uri="{FF2B5EF4-FFF2-40B4-BE49-F238E27FC236}">
-                <a16:creationId xmlns:a16="http://schemas.microsoft.com/office/drawing/2014/main" id="{41581309-B70E-443E-81D2-5328F54CBDD4}"/>
+                <a16:creationId xmlns:a16="http://schemas.microsoft.com/office/drawing/2014/main" id="{3BDCF144-095A-4FE3-B16D-DF45EB9ED785}"/>
               </a:ext>
             </a:extLst>
           </p:cNvPr>
@@ -7728,7 +7728,7 @@
           <p:cNvPr id="4" name="">
             <a:extLst xmlns:a="http://schemas.openxmlformats.org/drawingml/2006/main">
               <a:ext uri="{FF2B5EF4-FFF2-40B4-BE49-F238E27FC236}">
-                <a16:creationId xmlns:a16="http://schemas.microsoft.com/office/drawing/2014/main" id="{0F44AAE9-3DE4-438D-BF75-2FFE5964E8A8}"/>
+                <a16:creationId xmlns:a16="http://schemas.microsoft.com/office/drawing/2014/main" id="{5DFFF6D6-58D5-495E-BDC0-122388A1E378}"/>
               </a:ext>
             </a:extLst>
           </p:cNvPr>
@@ -7789,7 +7789,7 @@
           <p:nvPr/>
         </p:nvPicPr>
         <p:blipFill>
-          <a:blip xmlns:r="http://schemas.openxmlformats.org/officeDocument/2006/relationships" xmlns:a="http://schemas.openxmlformats.org/drawingml/2006/main" r:embed="Rc9868f3052a24924"/>
+          <a:blip xmlns:r="http://schemas.openxmlformats.org/officeDocument/2006/relationships" xmlns:a="http://schemas.openxmlformats.org/drawingml/2006/main" r:embed="R6b669168669b4c0b"/>
           <a:stretch xmlns:a="http://schemas.openxmlformats.org/drawingml/2006/main"/>
         </p:blipFill>
         <p:spPr>
@@ -7807,7 +7807,7 @@
           <p:cNvPr id="6" name="">
             <a:extLst xmlns:a="http://schemas.openxmlformats.org/drawingml/2006/main">
               <a:ext uri="{FF2B5EF4-FFF2-40B4-BE49-F238E27FC236}">
-                <a16:creationId xmlns:a16="http://schemas.microsoft.com/office/drawing/2014/main" id="{61F1B9AA-FF64-49D1-A8BD-9C09CB15BBB3}"/>
+                <a16:creationId xmlns:a16="http://schemas.microsoft.com/office/drawing/2014/main" id="{B5D8DB00-3D43-4335-9FA0-3A3737F8C2EA}"/>
               </a:ext>
             </a:extLst>
           </p:cNvPr>
@@ -7915,7 +7915,7 @@
           <p:cNvPr id="7" name="">
             <a:extLst xmlns:a="http://schemas.openxmlformats.org/drawingml/2006/main">
               <a:ext uri="{FF2B5EF4-FFF2-40B4-BE49-F238E27FC236}">
-                <a16:creationId xmlns:a16="http://schemas.microsoft.com/office/drawing/2014/main" id="{AF4A0256-F209-4D4E-A3EE-668600E043F9}"/>
+                <a16:creationId xmlns:a16="http://schemas.microsoft.com/office/drawing/2014/main" id="{1FAA9764-8593-47B7-98FA-7497757CF405}"/>
               </a:ext>
             </a:extLst>
           </p:cNvPr>
@@ -7970,7 +7970,7 @@
     </p:spTree>
     <p:extLst>
       <p:ext uri="{BB962C8B-B14F-4D97-AF65-F5344CB8AC3E}">
-        <p14:creationId xmlns:p14="http://schemas.microsoft.com/office/powerpoint/2010/main" val="352145769"/>
+        <p14:creationId xmlns:p14="http://schemas.microsoft.com/office/powerpoint/2010/main" val="1367063411"/>
       </p:ext>
     </p:extLst>
   </p:cSld>
@@ -8001,7 +8001,7 @@
           <p:cNvPr id="8" name="">
             <a:extLst xmlns:a="http://schemas.openxmlformats.org/drawingml/2006/main">
               <a:ext uri="{FF2B5EF4-FFF2-40B4-BE49-F238E27FC236}">
-                <a16:creationId xmlns:a16="http://schemas.microsoft.com/office/drawing/2014/main" id="{4E46B0BC-6CAB-420F-86C1-3772455A74C3}"/>
+                <a16:creationId xmlns:a16="http://schemas.microsoft.com/office/drawing/2014/main" id="{EF1604F7-4817-4AE7-8E4A-79616223AD38}"/>
               </a:ext>
             </a:extLst>
           </p:cNvPr>
@@ -8058,7 +8058,7 @@
           <p:cNvPr id="2" name="">
             <a:extLst xmlns:a="http://schemas.openxmlformats.org/drawingml/2006/main">
               <a:ext uri="{FF2B5EF4-FFF2-40B4-BE49-F238E27FC236}">
-                <a16:creationId xmlns:a16="http://schemas.microsoft.com/office/drawing/2014/main" id="{F945BF82-515A-4A64-85AC-D413016FBDDF}"/>
+                <a16:creationId xmlns:a16="http://schemas.microsoft.com/office/drawing/2014/main" id="{160D3618-CB3C-43CA-9649-891AA044A264}"/>
               </a:ext>
             </a:extLst>
           </p:cNvPr>
@@ -8115,7 +8115,7 @@
           <p:cNvPr id="3" name="">
             <a:extLst xmlns:a="http://schemas.openxmlformats.org/drawingml/2006/main">
               <a:ext uri="{FF2B5EF4-FFF2-40B4-BE49-F238E27FC236}">
-                <a16:creationId xmlns:a16="http://schemas.microsoft.com/office/drawing/2014/main" id="{03F06B1A-3BF9-42F9-92F4-BB0AEEC944C7}"/>
+                <a16:creationId xmlns:a16="http://schemas.microsoft.com/office/drawing/2014/main" id="{8B6C0CE2-2014-4844-8D28-8B8F4F5400E7}"/>
               </a:ext>
             </a:extLst>
           </p:cNvPr>
@@ -8172,7 +8172,7 @@
           <p:cNvPr id="4" name="">
             <a:extLst xmlns:a="http://schemas.openxmlformats.org/drawingml/2006/main">
               <a:ext uri="{FF2B5EF4-FFF2-40B4-BE49-F238E27FC236}">
-                <a16:creationId xmlns:a16="http://schemas.microsoft.com/office/drawing/2014/main" id="{09B646FE-95C0-492B-854A-B07CA305DB27}"/>
+                <a16:creationId xmlns:a16="http://schemas.microsoft.com/office/drawing/2014/main" id="{AA6C8586-CA46-4167-A402-B663AB847AC6}"/>
               </a:ext>
             </a:extLst>
           </p:cNvPr>
@@ -8233,7 +8233,7 @@
           <p:nvPr/>
         </p:nvPicPr>
         <p:blipFill>
-          <a:blip xmlns:r="http://schemas.openxmlformats.org/officeDocument/2006/relationships" xmlns:a="http://schemas.openxmlformats.org/drawingml/2006/main" r:embed="Rec43b646ba544b0d"/>
+          <a:blip xmlns:r="http://schemas.openxmlformats.org/officeDocument/2006/relationships" xmlns:a="http://schemas.openxmlformats.org/drawingml/2006/main" r:embed="R5c25c52ce8d842fe"/>
           <a:stretch xmlns:a="http://schemas.openxmlformats.org/drawingml/2006/main"/>
         </p:blipFill>
         <p:spPr>
@@ -8251,7 +8251,7 @@
           <p:cNvPr id="6" name="">
             <a:extLst xmlns:a="http://schemas.openxmlformats.org/drawingml/2006/main">
               <a:ext uri="{FF2B5EF4-FFF2-40B4-BE49-F238E27FC236}">
-                <a16:creationId xmlns:a16="http://schemas.microsoft.com/office/drawing/2014/main" id="{E2740392-4F40-42CB-820D-CE2342FE40A5}"/>
+                <a16:creationId xmlns:a16="http://schemas.microsoft.com/office/drawing/2014/main" id="{EF0CFB57-1A19-4D90-B85A-063059E1D2AD}"/>
               </a:ext>
             </a:extLst>
           </p:cNvPr>
@@ -8359,7 +8359,7 @@
           <p:cNvPr id="7" name="">
             <a:extLst xmlns:a="http://schemas.openxmlformats.org/drawingml/2006/main">
               <a:ext uri="{FF2B5EF4-FFF2-40B4-BE49-F238E27FC236}">
-                <a16:creationId xmlns:a16="http://schemas.microsoft.com/office/drawing/2014/main" id="{87E42520-5857-4ADB-BD43-ECE2B4778773}"/>
+                <a16:creationId xmlns:a16="http://schemas.microsoft.com/office/drawing/2014/main" id="{FA7BB84A-AF7C-4EB2-BDFD-C6D2D569DFE9}"/>
               </a:ext>
             </a:extLst>
           </p:cNvPr>
@@ -8414,7 +8414,7 @@
     </p:spTree>
     <p:extLst>
       <p:ext uri="{BB962C8B-B14F-4D97-AF65-F5344CB8AC3E}">
-        <p14:creationId xmlns:p14="http://schemas.microsoft.com/office/powerpoint/2010/main" val="1569619973"/>
+        <p14:creationId xmlns:p14="http://schemas.microsoft.com/office/powerpoint/2010/main" val="495476627"/>
       </p:ext>
     </p:extLst>
   </p:cSld>
@@ -8445,7 +8445,7 @@
           <p:cNvPr id="8" name="">
             <a:extLst xmlns:a="http://schemas.openxmlformats.org/drawingml/2006/main">
               <a:ext uri="{FF2B5EF4-FFF2-40B4-BE49-F238E27FC236}">
-                <a16:creationId xmlns:a16="http://schemas.microsoft.com/office/drawing/2014/main" id="{0DFF39F0-C6BD-49C7-A445-9C07F8BFD006}"/>
+                <a16:creationId xmlns:a16="http://schemas.microsoft.com/office/drawing/2014/main" id="{5353D773-9CCC-43AD-A1A2-09994086B077}"/>
               </a:ext>
             </a:extLst>
           </p:cNvPr>
@@ -8502,7 +8502,7 @@
           <p:cNvPr id="2" name="">
             <a:extLst xmlns:a="http://schemas.openxmlformats.org/drawingml/2006/main">
               <a:ext uri="{FF2B5EF4-FFF2-40B4-BE49-F238E27FC236}">
-                <a16:creationId xmlns:a16="http://schemas.microsoft.com/office/drawing/2014/main" id="{C7E92974-362F-48F0-BC32-B49EB44C3741}"/>
+                <a16:creationId xmlns:a16="http://schemas.microsoft.com/office/drawing/2014/main" id="{74B00C4E-5939-4CF4-BD06-17DE1688D868}"/>
               </a:ext>
             </a:extLst>
           </p:cNvPr>
@@ -8559,7 +8559,7 @@
           <p:cNvPr id="3" name="">
             <a:extLst xmlns:a="http://schemas.openxmlformats.org/drawingml/2006/main">
               <a:ext uri="{FF2B5EF4-FFF2-40B4-BE49-F238E27FC236}">
-                <a16:creationId xmlns:a16="http://schemas.microsoft.com/office/drawing/2014/main" id="{99348BF3-E1F5-468B-83E5-72023E6AD786}"/>
+                <a16:creationId xmlns:a16="http://schemas.microsoft.com/office/drawing/2014/main" id="{2C734433-CADA-4E28-B371-9D94A6C0A797}"/>
               </a:ext>
             </a:extLst>
           </p:cNvPr>
@@ -8616,7 +8616,7 @@
           <p:cNvPr id="4" name="">
             <a:extLst xmlns:a="http://schemas.openxmlformats.org/drawingml/2006/main">
               <a:ext uri="{FF2B5EF4-FFF2-40B4-BE49-F238E27FC236}">
-                <a16:creationId xmlns:a16="http://schemas.microsoft.com/office/drawing/2014/main" id="{23F43FCB-1241-47B1-AF1F-C9708B2E2638}"/>
+                <a16:creationId xmlns:a16="http://schemas.microsoft.com/office/drawing/2014/main" id="{8409E08A-827A-4F99-8CDB-8C3E8A35B803}"/>
               </a:ext>
             </a:extLst>
           </p:cNvPr>
@@ -8677,7 +8677,7 @@
           <p:nvPr/>
         </p:nvPicPr>
         <p:blipFill>
-          <a:blip xmlns:r="http://schemas.openxmlformats.org/officeDocument/2006/relationships" xmlns:a="http://schemas.openxmlformats.org/drawingml/2006/main" r:embed="R2e6fb96c30cc493b"/>
+          <a:blip xmlns:r="http://schemas.openxmlformats.org/officeDocument/2006/relationships" xmlns:a="http://schemas.openxmlformats.org/drawingml/2006/main" r:embed="Rd6bfbfacdbef4782"/>
           <a:stretch xmlns:a="http://schemas.openxmlformats.org/drawingml/2006/main"/>
         </p:blipFill>
         <p:spPr>
@@ -8695,7 +8695,7 @@
           <p:cNvPr id="6" name="">
             <a:extLst xmlns:a="http://schemas.openxmlformats.org/drawingml/2006/main">
               <a:ext uri="{FF2B5EF4-FFF2-40B4-BE49-F238E27FC236}">
-                <a16:creationId xmlns:a16="http://schemas.microsoft.com/office/drawing/2014/main" id="{9F450DD2-DE39-4EBF-8760-EB2862B9C786}"/>
+                <a16:creationId xmlns:a16="http://schemas.microsoft.com/office/drawing/2014/main" id="{C89BA735-8A5D-4BAC-B0F9-9E9460859CF5}"/>
               </a:ext>
             </a:extLst>
           </p:cNvPr>
@@ -8803,7 +8803,7 @@
           <p:cNvPr id="7" name="">
             <a:extLst xmlns:a="http://schemas.openxmlformats.org/drawingml/2006/main">
               <a:ext uri="{FF2B5EF4-FFF2-40B4-BE49-F238E27FC236}">
-                <a16:creationId xmlns:a16="http://schemas.microsoft.com/office/drawing/2014/main" id="{A96E5768-02D6-4696-850F-EC1DAAD69C46}"/>
+                <a16:creationId xmlns:a16="http://schemas.microsoft.com/office/drawing/2014/main" id="{9094A807-B276-4EDF-AD65-E3562B2A5841}"/>
               </a:ext>
             </a:extLst>
           </p:cNvPr>
@@ -8909,7 +8909,7 @@
     </p:spTree>
     <p:extLst>
       <p:ext uri="{BB962C8B-B14F-4D97-AF65-F5344CB8AC3E}">
-        <p14:creationId xmlns:p14="http://schemas.microsoft.com/office/powerpoint/2010/main" val="694357439"/>
+        <p14:creationId xmlns:p14="http://schemas.microsoft.com/office/powerpoint/2010/main" val="1886578808"/>
       </p:ext>
     </p:extLst>
   </p:cSld>
@@ -8940,7 +8940,7 @@
           <p:cNvPr id="7" name="">
             <a:extLst xmlns:a="http://schemas.openxmlformats.org/drawingml/2006/main">
               <a:ext uri="{FF2B5EF4-FFF2-40B4-BE49-F238E27FC236}">
-                <a16:creationId xmlns:a16="http://schemas.microsoft.com/office/drawing/2014/main" id="{4F239687-0003-4D5C-825E-87A6DF49366B}"/>
+                <a16:creationId xmlns:a16="http://schemas.microsoft.com/office/drawing/2014/main" id="{01D39199-C7F1-4B31-812F-86A6F027E399}"/>
               </a:ext>
             </a:extLst>
           </p:cNvPr>
@@ -8997,7 +8997,7 @@
           <p:cNvPr id="2" name="">
             <a:extLst xmlns:a="http://schemas.openxmlformats.org/drawingml/2006/main">
               <a:ext uri="{FF2B5EF4-FFF2-40B4-BE49-F238E27FC236}">
-                <a16:creationId xmlns:a16="http://schemas.microsoft.com/office/drawing/2014/main" id="{34B9DE9D-C764-4BC3-9819-AC0BE9651DCE}"/>
+                <a16:creationId xmlns:a16="http://schemas.microsoft.com/office/drawing/2014/main" id="{7AEC776E-DFF6-4C0E-8172-79A3B20DFDEC}"/>
               </a:ext>
             </a:extLst>
           </p:cNvPr>
@@ -9054,7 +9054,7 @@
           <p:cNvPr id="3" name="">
             <a:extLst xmlns:a="http://schemas.openxmlformats.org/drawingml/2006/main">
               <a:ext uri="{FF2B5EF4-FFF2-40B4-BE49-F238E27FC236}">
-                <a16:creationId xmlns:a16="http://schemas.microsoft.com/office/drawing/2014/main" id="{7E3DD063-A897-4BB7-8385-FF21731243BF}"/>
+                <a16:creationId xmlns:a16="http://schemas.microsoft.com/office/drawing/2014/main" id="{A51E7564-8F8B-4E55-A0CC-5B30363A7B0C}"/>
               </a:ext>
             </a:extLst>
           </p:cNvPr>
@@ -9111,7 +9111,7 @@
           <p:cNvPr id="4" name="">
             <a:extLst xmlns:a="http://schemas.openxmlformats.org/drawingml/2006/main">
               <a:ext uri="{FF2B5EF4-FFF2-40B4-BE49-F238E27FC236}">
-                <a16:creationId xmlns:a16="http://schemas.microsoft.com/office/drawing/2014/main" id="{78556452-6553-482A-A06D-46BAD8A73143}"/>
+                <a16:creationId xmlns:a16="http://schemas.microsoft.com/office/drawing/2014/main" id="{EB9C0752-FAED-4DD2-BD99-C8978170BC7B}"/>
               </a:ext>
             </a:extLst>
           </p:cNvPr>
@@ -9172,13 +9172,13 @@
           <p:nvPr/>
         </p:nvPicPr>
         <p:blipFill>
-          <a:blip xmlns:r="http://schemas.openxmlformats.org/officeDocument/2006/relationships" xmlns:a="http://schemas.openxmlformats.org/drawingml/2006/main" r:embed="R2de39dacb0c6440d"/>
+          <a:blip xmlns:r="http://schemas.openxmlformats.org/officeDocument/2006/relationships" xmlns:a="http://schemas.openxmlformats.org/drawingml/2006/main" r:embed="Ra31ed202a4784935"/>
           <a:stretch xmlns:a="http://schemas.openxmlformats.org/drawingml/2006/main"/>
         </p:blipFill>
         <p:spPr>
           <a:xfrm xmlns:a="http://schemas.openxmlformats.org/drawingml/2006/main">
-            <a:off x="1262884" y="1028700"/>
-            <a:ext cx="9666233" cy="5143500"/>
+            <a:off x="996841" y="1028700"/>
+            <a:ext cx="10198319" cy="5143500"/>
           </a:xfrm>
           <a:prstGeom xmlns:a="http://schemas.openxmlformats.org/drawingml/2006/main" prst="rect">
             <a:avLst/>
@@ -9190,7 +9190,7 @@
           <p:cNvPr id="6" name="">
             <a:extLst xmlns:a="http://schemas.openxmlformats.org/drawingml/2006/main">
               <a:ext uri="{FF2B5EF4-FFF2-40B4-BE49-F238E27FC236}">
-                <a16:creationId xmlns:a16="http://schemas.microsoft.com/office/drawing/2014/main" id="{3666FAD1-6C6B-43B6-B21B-F8D5D5257BD3}"/>
+                <a16:creationId xmlns:a16="http://schemas.microsoft.com/office/drawing/2014/main" id="{0F05698D-E13F-4DFB-9B80-CE535B6E006E}"/>
               </a:ext>
             </a:extLst>
           </p:cNvPr>
@@ -9245,7 +9245,7 @@
     </p:spTree>
     <p:extLst>
       <p:ext uri="{BB962C8B-B14F-4D97-AF65-F5344CB8AC3E}">
-        <p14:creationId xmlns:p14="http://schemas.microsoft.com/office/powerpoint/2010/main" val="1553630544"/>
+        <p14:creationId xmlns:p14="http://schemas.microsoft.com/office/powerpoint/2010/main" val="207259075"/>
       </p:ext>
     </p:extLst>
   </p:cSld>

</xml_diff>